<commit_message>
Update presentation: concerns callout, shorter metaphor, types overview
Changes:
- Slide 2: Shortened metaphor to one punchy sentence (Netflix/Shazam)
- Slide 3: Added "What we need from you" callout addressing unspoken
  concerns about time commitment and job security
- Slide 5: Converted from specific examples to "Types of Solutions"
  overview showing progression from dashboards → AI tools
  (sets up user's 5 detailed example slides to follow)

https://claude.ai/code/session_01DfvAyFmBegVKSBdqRLKP3K
</commit_message>
<xml_diff>
--- a/Enterprise_Analytics_AI_Team.pptx
+++ b/Enterprise_Analytics_AI_Team.pptx
@@ -3475,7 +3475,7 @@
         <p:spPr>
           <a:xfrm>
             <a:off x="548640" y="1554480"/>
-            <a:ext cx="11094415" cy="1645920"/>
+            <a:ext cx="11094415" cy="1280160"/>
           </a:xfrm>
           <a:prstGeom prst="roundRect">
             <a:avLst/>
@@ -3519,8 +3519,8 @@
         </p:nvSpPr>
         <p:spPr>
           <a:xfrm>
-            <a:off x="822960" y="1691640"/>
-            <a:ext cx="10515600" cy="1463040"/>
+            <a:off x="822960" y="1737360"/>
+            <a:ext cx="10515600" cy="1005840"/>
           </a:xfrm>
           <a:prstGeom prst="rect">
             <a:avLst/>
@@ -3534,29 +3534,14 @@
           <a:lstStyle/>
           <a:p>
             <a:pPr>
-              <a:spcAft>
-                <a:spcPts val="1200"/>
-              </a:spcAft>
-              <a:defRPr sz="2200" b="1">
-                <a:solidFill>
-                  <a:srgbClr val="172A45"/>
-                </a:solidFill>
-              </a:defRPr>
-            </a:pPr>
-            <a:r>
-              <a:t>Think of us as technology specialists who speak your language.</a:t>
-            </a:r>
-          </a:p>
-          <a:p>
-            <a:pPr>
-              <a:defRPr sz="1700">
+              <a:defRPr sz="2000">
                 <a:solidFill>
                   <a:srgbClr val="475569"/>
                 </a:solidFill>
               </a:defRPr>
             </a:pPr>
             <a:r>
-              <a:t>You know how Netflix somehow knows which shows you'll like? Or how your phone can identify a song in seconds? We're the people who build those kinds of systems — but for business problems. We create tools that find patterns in your data, predict what's coming next, and automate the tedious stuff so you can focus on what matters.</a:t>
+              <a:t>You know how Netflix figures out which shows you'll like, or how your phone identifies a song in seconds? We build those kinds of systems — but for your business problems.</a:t>
             </a:r>
           </a:p>
         </p:txBody>
@@ -3569,7 +3554,7 @@
         </p:nvSpPr>
         <p:spPr>
           <a:xfrm>
-            <a:off x="548640" y="3474720"/>
+            <a:off x="548640" y="3108960"/>
             <a:ext cx="3566160" cy="1920240"/>
           </a:xfrm>
           <a:prstGeom prst="roundRect">
@@ -3614,7 +3599,7 @@
         </p:nvSpPr>
         <p:spPr>
           <a:xfrm>
-            <a:off x="548640" y="3474720"/>
+            <a:off x="548640" y="3108960"/>
             <a:ext cx="3566160" cy="109728"/>
           </a:xfrm>
           <a:prstGeom prst="rect">
@@ -3657,7 +3642,7 @@
         </p:nvSpPr>
         <p:spPr>
           <a:xfrm>
-            <a:off x="731520" y="3749040"/>
+            <a:off x="731520" y="3383280"/>
             <a:ext cx="3200400" cy="457200"/>
           </a:xfrm>
           <a:prstGeom prst="rect">
@@ -3692,7 +3677,7 @@
         </p:nvSpPr>
         <p:spPr>
           <a:xfrm>
-            <a:off x="731520" y="4251960"/>
+            <a:off x="731520" y="3886200"/>
             <a:ext cx="3200400" cy="1005840"/>
           </a:xfrm>
           <a:prstGeom prst="rect">
@@ -3727,7 +3712,7 @@
         </p:nvSpPr>
         <p:spPr>
           <a:xfrm>
-            <a:off x="4343400" y="3474720"/>
+            <a:off x="4343400" y="3108960"/>
             <a:ext cx="3566160" cy="1920240"/>
           </a:xfrm>
           <a:prstGeom prst="roundRect">
@@ -3772,7 +3757,7 @@
         </p:nvSpPr>
         <p:spPr>
           <a:xfrm>
-            <a:off x="4343400" y="3474720"/>
+            <a:off x="4343400" y="3108960"/>
             <a:ext cx="3566160" cy="109728"/>
           </a:xfrm>
           <a:prstGeom prst="rect">
@@ -3815,7 +3800,7 @@
         </p:nvSpPr>
         <p:spPr>
           <a:xfrm>
-            <a:off x="4526280" y="3749040"/>
+            <a:off x="4526280" y="3383280"/>
             <a:ext cx="3200400" cy="457200"/>
           </a:xfrm>
           <a:prstGeom prst="rect">
@@ -3850,7 +3835,7 @@
         </p:nvSpPr>
         <p:spPr>
           <a:xfrm>
-            <a:off x="4526280" y="4251960"/>
+            <a:off x="4526280" y="3886200"/>
             <a:ext cx="3200400" cy="1005840"/>
           </a:xfrm>
           <a:prstGeom prst="rect">
@@ -3885,7 +3870,7 @@
         </p:nvSpPr>
         <p:spPr>
           <a:xfrm>
-            <a:off x="8138160" y="3474720"/>
+            <a:off x="8138160" y="3108960"/>
             <a:ext cx="3566160" cy="1920240"/>
           </a:xfrm>
           <a:prstGeom prst="roundRect">
@@ -3930,7 +3915,7 @@
         </p:nvSpPr>
         <p:spPr>
           <a:xfrm>
-            <a:off x="8138160" y="3474720"/>
+            <a:off x="8138160" y="3108960"/>
             <a:ext cx="3566160" cy="109728"/>
           </a:xfrm>
           <a:prstGeom prst="rect">
@@ -3973,7 +3958,7 @@
         </p:nvSpPr>
         <p:spPr>
           <a:xfrm>
-            <a:off x="8321040" y="3749040"/>
+            <a:off x="8321040" y="3383280"/>
             <a:ext cx="3200400" cy="457200"/>
           </a:xfrm>
           <a:prstGeom prst="rect">
@@ -4008,7 +3993,7 @@
         </p:nvSpPr>
         <p:spPr>
           <a:xfrm>
-            <a:off x="8321040" y="4251960"/>
+            <a:off x="8321040" y="3886200"/>
             <a:ext cx="3200400" cy="1005840"/>
           </a:xfrm>
           <a:prstGeom prst="rect">
@@ -4043,7 +4028,7 @@
         </p:nvSpPr>
         <p:spPr>
           <a:xfrm>
-            <a:off x="548640" y="5669280"/>
+            <a:off x="548640" y="5303520"/>
             <a:ext cx="10972800" cy="548640"/>
           </a:xfrm>
           <a:prstGeom prst="rect">
@@ -5345,7 +5330,122 @@
       </p:sp>
       <p:sp>
         <p:nvSpPr>
-          <p:cNvPr id="34" name="TextBox 33"/>
+          <p:cNvPr id="34" name="Rounded Rectangle 33"/>
+          <p:cNvSpPr/>
+          <p:nvPr/>
+        </p:nvSpPr>
+        <p:spPr>
+          <a:xfrm>
+            <a:off x="457200" y="5852160"/>
+            <a:ext cx="11277295" cy="822960"/>
+          </a:xfrm>
+          <a:prstGeom prst="roundRect">
+            <a:avLst/>
+          </a:prstGeom>
+          <a:solidFill>
+            <a:srgbClr val="FFFAF0"/>
+          </a:solidFill>
+          <a:ln w="19050">
+            <a:solidFill>
+              <a:srgbClr val="CD853F"/>
+            </a:solidFill>
+          </a:ln>
+        </p:spPr>
+        <p:style>
+          <a:lnRef idx="1">
+            <a:schemeClr val="accent1"/>
+          </a:lnRef>
+          <a:fillRef idx="3">
+            <a:schemeClr val="accent1"/>
+          </a:fillRef>
+          <a:effectRef idx="2">
+            <a:schemeClr val="accent1"/>
+          </a:effectRef>
+          <a:fontRef idx="minor">
+            <a:schemeClr val="lt1"/>
+          </a:fontRef>
+        </p:style>
+        <p:txBody>
+          <a:bodyPr rtlCol="0" anchor="ctr"/>
+          <a:lstStyle/>
+          <a:p>
+            <a:pPr algn="ctr"/>
+          </a:p>
+        </p:txBody>
+      </p:sp>
+      <p:sp>
+        <p:nvSpPr>
+          <p:cNvPr id="35" name="TextBox 34"/>
+          <p:cNvSpPr txBox="1"/>
+          <p:nvPr/>
+        </p:nvSpPr>
+        <p:spPr>
+          <a:xfrm>
+            <a:off x="731520" y="5943600"/>
+            <a:ext cx="2743200" cy="365760"/>
+          </a:xfrm>
+          <a:prstGeom prst="rect">
+            <a:avLst/>
+          </a:prstGeom>
+          <a:noFill/>
+        </p:spPr>
+        <p:txBody>
+          <a:bodyPr wrap="none">
+            <a:spAutoFit/>
+          </a:bodyPr>
+          <a:lstStyle/>
+          <a:p>
+            <a:pPr>
+              <a:defRPr sz="1400" b="1">
+                <a:solidFill>
+                  <a:srgbClr val="B46432"/>
+                </a:solidFill>
+              </a:defRPr>
+            </a:pPr>
+            <a:r>
+              <a:t>What we need from you:</a:t>
+            </a:r>
+          </a:p>
+        </p:txBody>
+      </p:sp>
+      <p:sp>
+        <p:nvSpPr>
+          <p:cNvPr id="36" name="TextBox 35"/>
+          <p:cNvSpPr txBox="1"/>
+          <p:nvPr/>
+        </p:nvSpPr>
+        <p:spPr>
+          <a:xfrm>
+            <a:off x="3474720" y="5943600"/>
+            <a:ext cx="8046720" cy="640080"/>
+          </a:xfrm>
+          <a:prstGeom prst="rect">
+            <a:avLst/>
+          </a:prstGeom>
+          <a:noFill/>
+        </p:spPr>
+        <p:txBody>
+          <a:bodyPr wrap="square">
+            <a:spAutoFit/>
+          </a:bodyPr>
+          <a:lstStyle/>
+          <a:p>
+            <a:pPr>
+              <a:defRPr sz="1400">
+                <a:solidFill>
+                  <a:srgbClr val="475569"/>
+                </a:solidFill>
+              </a:defRPr>
+            </a:pPr>
+            <a:r>
+              <a:t>A conversation or two to help us understand your work. That's it. We handle the technical building — you stay focused on your job.</a:t>
+            </a:r>
+          </a:p>
+        </p:txBody>
+      </p:sp>
+      <p:sp>
+        <p:nvSpPr>
+          <p:cNvPr id="37" name="TextBox 36"/>
           <p:cNvSpPr txBox="1"/>
           <p:nvPr/>
         </p:nvSpPr>
@@ -6650,29 +6750,64 @@
               </a:defRPr>
             </a:pPr>
             <a:r>
-              <a:t>Examples: What This Looks Like in Practice</a:t>
-            </a:r>
-          </a:p>
-        </p:txBody>
-      </p:sp>
-      <p:sp>
-        <p:nvSpPr>
-          <p:cNvPr id="5" name="Rounded Rectangle 4"/>
+              <a:t>Types of Solutions We Build</a:t>
+            </a:r>
+          </a:p>
+        </p:txBody>
+      </p:sp>
+      <p:sp>
+        <p:nvSpPr>
+          <p:cNvPr id="5" name="TextBox 4"/>
+          <p:cNvSpPr txBox="1"/>
+          <p:nvPr/>
+        </p:nvSpPr>
+        <p:spPr>
+          <a:xfrm>
+            <a:off x="731520" y="1371600"/>
+            <a:ext cx="10515600" cy="457200"/>
+          </a:xfrm>
+          <a:prstGeom prst="rect">
+            <a:avLst/>
+          </a:prstGeom>
+          <a:noFill/>
+        </p:spPr>
+        <p:txBody>
+          <a:bodyPr wrap="none">
+            <a:spAutoFit/>
+          </a:bodyPr>
+          <a:lstStyle/>
+          <a:p>
+            <a:pPr>
+              <a:defRPr sz="1600">
+                <a:solidFill>
+                  <a:srgbClr val="64748B"/>
+                </a:solidFill>
+              </a:defRPr>
+            </a:pPr>
+            <a:r>
+              <a:t>A spectrum of tools — from simple visibility to intelligent automation</a:t>
+            </a:r>
+          </a:p>
+        </p:txBody>
+      </p:sp>
+      <p:sp>
+        <p:nvSpPr>
+          <p:cNvPr id="6" name="Rounded Rectangle 5"/>
           <p:cNvSpPr/>
           <p:nvPr/>
         </p:nvSpPr>
         <p:spPr>
           <a:xfrm>
-            <a:off x="502920" y="1371600"/>
-            <a:ext cx="3657600" cy="1600200"/>
+            <a:off x="457200" y="1920240"/>
+            <a:ext cx="2148840" cy="3840480"/>
           </a:xfrm>
           <a:prstGeom prst="roundRect">
             <a:avLst/>
           </a:prstGeom>
           <a:solidFill>
-            <a:srgbClr val="F8FAFC"/>
+            <a:srgbClr val="FFFFFF"/>
           </a:solidFill>
-          <a:ln w="19050">
+          <a:ln w="25400">
             <a:solidFill>
               <a:srgbClr val="4682B4"/>
             </a:solidFill>
@@ -6702,16 +6837,16 @@
       </p:sp>
       <p:sp>
         <p:nvSpPr>
-          <p:cNvPr id="6" name="Oval 5"/>
+          <p:cNvPr id="7" name="Rectangle 6"/>
           <p:cNvSpPr/>
           <p:nvPr/>
         </p:nvSpPr>
         <p:spPr>
           <a:xfrm>
-            <a:off x="640080" y="1508760"/>
-            <a:ext cx="457200" cy="457200"/>
-          </a:xfrm>
-          <a:prstGeom prst="ellipse">
+            <a:off x="457200" y="1920240"/>
+            <a:ext cx="2148840" cy="137160"/>
+          </a:xfrm>
+          <a:prstGeom prst="rect">
             <a:avLst/>
           </a:prstGeom>
           <a:solidFill>
@@ -6745,126 +6880,23 @@
       </p:sp>
       <p:sp>
         <p:nvSpPr>
-          <p:cNvPr id="7" name="TextBox 6"/>
-          <p:cNvSpPr txBox="1"/>
-          <p:nvPr/>
-        </p:nvSpPr>
-        <p:spPr>
-          <a:xfrm>
-            <a:off x="640080" y="1554480"/>
-            <a:ext cx="457200" cy="365760"/>
-          </a:xfrm>
-          <a:prstGeom prst="rect">
-            <a:avLst/>
-          </a:prstGeom>
-          <a:noFill/>
-        </p:spPr>
-        <p:txBody>
-          <a:bodyPr wrap="none">
-            <a:spAutoFit/>
-          </a:bodyPr>
-          <a:lstStyle/>
-          <a:p>
-            <a:pPr algn="ctr">
-              <a:defRPr sz="2000"/>
-            </a:pPr>
-            <a:r>
-              <a:t>📋</a:t>
-            </a:r>
-          </a:p>
-        </p:txBody>
-      </p:sp>
-      <p:sp>
-        <p:nvSpPr>
-          <p:cNvPr id="8" name="TextBox 7"/>
-          <p:cNvSpPr txBox="1"/>
-          <p:nvPr/>
-        </p:nvSpPr>
-        <p:spPr>
-          <a:xfrm>
-            <a:off x="1188720" y="1554480"/>
-            <a:ext cx="2834640" cy="411480"/>
-          </a:xfrm>
-          <a:prstGeom prst="rect">
-            <a:avLst/>
-          </a:prstGeom>
-          <a:noFill/>
-        </p:spPr>
-        <p:txBody>
-          <a:bodyPr wrap="none">
-            <a:spAutoFit/>
-          </a:bodyPr>
-          <a:lstStyle/>
-          <a:p>
-            <a:pPr>
-              <a:defRPr sz="1400" b="1">
-                <a:solidFill>
-                  <a:srgbClr val="172A45"/>
-                </a:solidFill>
-              </a:defRPr>
-            </a:pPr>
-            <a:r>
-              <a:t>Project Pipeline Dashboard</a:t>
-            </a:r>
-          </a:p>
-        </p:txBody>
-      </p:sp>
-      <p:sp>
-        <p:nvSpPr>
-          <p:cNvPr id="9" name="TextBox 8"/>
-          <p:cNvSpPr txBox="1"/>
-          <p:nvPr/>
-        </p:nvSpPr>
-        <p:spPr>
-          <a:xfrm>
-            <a:off x="640080" y="2011680"/>
-            <a:ext cx="3383280" cy="914400"/>
-          </a:xfrm>
-          <a:prstGeom prst="rect">
-            <a:avLst/>
-          </a:prstGeom>
-          <a:noFill/>
-        </p:spPr>
-        <p:txBody>
-          <a:bodyPr wrap="square">
-            <a:spAutoFit/>
-          </a:bodyPr>
-          <a:lstStyle/>
-          <a:p>
-            <a:pPr>
-              <a:defRPr sz="1100">
-                <a:solidFill>
-                  <a:srgbClr val="475569"/>
-                </a:solidFill>
-              </a:defRPr>
-            </a:pPr>
-            <a:r>
-              <a:t>One screen showing every project's status from first landowner contact through permit approval — always up to date</a:t>
-            </a:r>
-          </a:p>
-        </p:txBody>
-      </p:sp>
-      <p:sp>
-        <p:nvSpPr>
-          <p:cNvPr id="10" name="Rounded Rectangle 9"/>
+          <p:cNvPr id="8" name="Oval 7"/>
           <p:cNvSpPr/>
           <p:nvPr/>
         </p:nvSpPr>
         <p:spPr>
           <a:xfrm>
-            <a:off x="4297680" y="1371600"/>
-            <a:ext cx="3657600" cy="1600200"/>
-          </a:xfrm>
-          <a:prstGeom prst="roundRect">
+            <a:off x="1165860" y="2240280"/>
+            <a:ext cx="731520" cy="731520"/>
+          </a:xfrm>
+          <a:prstGeom prst="ellipse">
             <a:avLst/>
           </a:prstGeom>
           <a:solidFill>
-            <a:srgbClr val="F8FAFC"/>
+            <a:srgbClr val="4682B4"/>
           </a:solidFill>
-          <a:ln w="19050">
-            <a:solidFill>
-              <a:srgbClr val="008080"/>
-            </a:solidFill>
+          <a:ln>
+            <a:noFill/>
           </a:ln>
         </p:spPr>
         <p:style>
@@ -6891,16 +6923,244 @@
       </p:sp>
       <p:sp>
         <p:nvSpPr>
-          <p:cNvPr id="11" name="Oval 10"/>
+          <p:cNvPr id="9" name="TextBox 8"/>
+          <p:cNvSpPr txBox="1"/>
+          <p:nvPr/>
+        </p:nvSpPr>
+        <p:spPr>
+          <a:xfrm>
+            <a:off x="1211580" y="2331720"/>
+            <a:ext cx="640080" cy="548640"/>
+          </a:xfrm>
+          <a:prstGeom prst="rect">
+            <a:avLst/>
+          </a:prstGeom>
+          <a:noFill/>
+        </p:spPr>
+        <p:txBody>
+          <a:bodyPr wrap="none">
+            <a:spAutoFit/>
+          </a:bodyPr>
+          <a:lstStyle/>
+          <a:p>
+            <a:pPr algn="ctr">
+              <a:defRPr sz="2800"/>
+            </a:pPr>
+            <a:r>
+              <a:t>📊</a:t>
+            </a:r>
+          </a:p>
+        </p:txBody>
+      </p:sp>
+      <p:sp>
+        <p:nvSpPr>
+          <p:cNvPr id="10" name="TextBox 9"/>
+          <p:cNvSpPr txBox="1"/>
+          <p:nvPr/>
+        </p:nvSpPr>
+        <p:spPr>
+          <a:xfrm>
+            <a:off x="548640" y="3063240"/>
+            <a:ext cx="1965960" cy="731520"/>
+          </a:xfrm>
+          <a:prstGeom prst="rect">
+            <a:avLst/>
+          </a:prstGeom>
+          <a:noFill/>
+        </p:spPr>
+        <p:txBody>
+          <a:bodyPr wrap="square">
+            <a:spAutoFit/>
+          </a:bodyPr>
+          <a:lstStyle/>
+          <a:p>
+            <a:pPr algn="ctr">
+              <a:defRPr sz="1400" b="1">
+                <a:solidFill>
+                  <a:srgbClr val="4682B4"/>
+                </a:solidFill>
+              </a:defRPr>
+            </a:pPr>
+            <a:r>
+              <a:t>Dashboards &amp;</a:t>
+            </a:r>
+            <a:br/>
+            <a:r>
+              <a:t>Visualizations</a:t>
+            </a:r>
+          </a:p>
+        </p:txBody>
+      </p:sp>
+      <p:sp>
+        <p:nvSpPr>
+          <p:cNvPr id="11" name="TextBox 10"/>
+          <p:cNvSpPr txBox="1"/>
+          <p:nvPr/>
+        </p:nvSpPr>
+        <p:spPr>
+          <a:xfrm>
+            <a:off x="548640" y="3794759"/>
+            <a:ext cx="1965960" cy="457200"/>
+          </a:xfrm>
+          <a:prstGeom prst="rect">
+            <a:avLst/>
+          </a:prstGeom>
+          <a:noFill/>
+        </p:spPr>
+        <p:txBody>
+          <a:bodyPr wrap="square">
+            <a:spAutoFit/>
+          </a:bodyPr>
+          <a:lstStyle/>
+          <a:p>
+            <a:pPr algn="ctr">
+              <a:defRPr sz="1300" b="1">
+                <a:solidFill>
+                  <a:srgbClr val="475569"/>
+                </a:solidFill>
+              </a:defRPr>
+            </a:pPr>
+            <a:r>
+              <a:t>See your data clearly</a:t>
+            </a:r>
+          </a:p>
+        </p:txBody>
+      </p:sp>
+      <p:sp>
+        <p:nvSpPr>
+          <p:cNvPr id="12" name="TextBox 11"/>
+          <p:cNvSpPr txBox="1"/>
+          <p:nvPr/>
+        </p:nvSpPr>
+        <p:spPr>
+          <a:xfrm>
+            <a:off x="548640" y="4251960"/>
+            <a:ext cx="1965960" cy="1280160"/>
+          </a:xfrm>
+          <a:prstGeom prst="rect">
+            <a:avLst/>
+          </a:prstGeom>
+          <a:noFill/>
+        </p:spPr>
+        <p:txBody>
+          <a:bodyPr wrap="square">
+            <a:spAutoFit/>
+          </a:bodyPr>
+          <a:lstStyle/>
+          <a:p>
+            <a:pPr algn="ctr">
+              <a:defRPr sz="1100">
+                <a:solidFill>
+                  <a:srgbClr val="64748B"/>
+                </a:solidFill>
+              </a:defRPr>
+            </a:pPr>
+            <a:r>
+              <a:t>Status trackers, maps, charts that update automatically</a:t>
+            </a:r>
+          </a:p>
+        </p:txBody>
+      </p:sp>
+      <p:sp>
+        <p:nvSpPr>
+          <p:cNvPr id="13" name="Right Arrow 12"/>
           <p:cNvSpPr/>
           <p:nvPr/>
         </p:nvSpPr>
         <p:spPr>
           <a:xfrm>
-            <a:off x="4434840" y="1508760"/>
-            <a:ext cx="457200" cy="457200"/>
-          </a:xfrm>
-          <a:prstGeom prst="ellipse">
+            <a:off x="2624328" y="2651760"/>
+            <a:ext cx="146304" cy="228600"/>
+          </a:xfrm>
+          <a:prstGeom prst="rightArrow">
+            <a:avLst/>
+          </a:prstGeom>
+          <a:solidFill>
+            <a:srgbClr val="C8D2DC"/>
+          </a:solidFill>
+          <a:ln>
+            <a:noFill/>
+          </a:ln>
+        </p:spPr>
+        <p:style>
+          <a:lnRef idx="1">
+            <a:schemeClr val="accent1"/>
+          </a:lnRef>
+          <a:fillRef idx="3">
+            <a:schemeClr val="accent1"/>
+          </a:fillRef>
+          <a:effectRef idx="2">
+            <a:schemeClr val="accent1"/>
+          </a:effectRef>
+          <a:fontRef idx="minor">
+            <a:schemeClr val="lt1"/>
+          </a:fontRef>
+        </p:style>
+        <p:txBody>
+          <a:bodyPr rtlCol="0" anchor="ctr"/>
+          <a:lstStyle/>
+          <a:p>
+            <a:pPr algn="ctr"/>
+          </a:p>
+        </p:txBody>
+      </p:sp>
+      <p:sp>
+        <p:nvSpPr>
+          <p:cNvPr id="14" name="Rounded Rectangle 13"/>
+          <p:cNvSpPr/>
+          <p:nvPr/>
+        </p:nvSpPr>
+        <p:spPr>
+          <a:xfrm>
+            <a:off x="2788920" y="1920240"/>
+            <a:ext cx="2148840" cy="3840480"/>
+          </a:xfrm>
+          <a:prstGeom prst="roundRect">
+            <a:avLst/>
+          </a:prstGeom>
+          <a:solidFill>
+            <a:srgbClr val="FFFFFF"/>
+          </a:solidFill>
+          <a:ln w="25400">
+            <a:solidFill>
+              <a:srgbClr val="008080"/>
+            </a:solidFill>
+          </a:ln>
+        </p:spPr>
+        <p:style>
+          <a:lnRef idx="1">
+            <a:schemeClr val="accent1"/>
+          </a:lnRef>
+          <a:fillRef idx="3">
+            <a:schemeClr val="accent1"/>
+          </a:fillRef>
+          <a:effectRef idx="2">
+            <a:schemeClr val="accent1"/>
+          </a:effectRef>
+          <a:fontRef idx="minor">
+            <a:schemeClr val="lt1"/>
+          </a:fontRef>
+        </p:style>
+        <p:txBody>
+          <a:bodyPr rtlCol="0" anchor="ctr"/>
+          <a:lstStyle/>
+          <a:p>
+            <a:pPr algn="ctr"/>
+          </a:p>
+        </p:txBody>
+      </p:sp>
+      <p:sp>
+        <p:nvSpPr>
+          <p:cNvPr id="15" name="Rectangle 14"/>
+          <p:cNvSpPr/>
+          <p:nvPr/>
+        </p:nvSpPr>
+        <p:spPr>
+          <a:xfrm>
+            <a:off x="2788920" y="1920240"/>
+            <a:ext cx="2148840" cy="137160"/>
+          </a:xfrm>
+          <a:prstGeom prst="rect">
             <a:avLst/>
           </a:prstGeom>
           <a:solidFill>
@@ -6934,126 +7194,23 @@
       </p:sp>
       <p:sp>
         <p:nvSpPr>
-          <p:cNvPr id="12" name="TextBox 11"/>
-          <p:cNvSpPr txBox="1"/>
-          <p:nvPr/>
-        </p:nvSpPr>
-        <p:spPr>
-          <a:xfrm>
-            <a:off x="4434840" y="1554480"/>
-            <a:ext cx="457200" cy="365760"/>
-          </a:xfrm>
-          <a:prstGeom prst="rect">
-            <a:avLst/>
-          </a:prstGeom>
-          <a:noFill/>
-        </p:spPr>
-        <p:txBody>
-          <a:bodyPr wrap="none">
-            <a:spAutoFit/>
-          </a:bodyPr>
-          <a:lstStyle/>
-          <a:p>
-            <a:pPr algn="ctr">
-              <a:defRPr sz="2000"/>
-            </a:pPr>
-            <a:r>
-              <a:t>🔮</a:t>
-            </a:r>
-          </a:p>
-        </p:txBody>
-      </p:sp>
-      <p:sp>
-        <p:nvSpPr>
-          <p:cNvPr id="13" name="TextBox 12"/>
-          <p:cNvSpPr txBox="1"/>
-          <p:nvPr/>
-        </p:nvSpPr>
-        <p:spPr>
-          <a:xfrm>
-            <a:off x="4983480" y="1554480"/>
-            <a:ext cx="2834640" cy="411480"/>
-          </a:xfrm>
-          <a:prstGeom prst="rect">
-            <a:avLst/>
-          </a:prstGeom>
-          <a:noFill/>
-        </p:spPr>
-        <p:txBody>
-          <a:bodyPr wrap="none">
-            <a:spAutoFit/>
-          </a:bodyPr>
-          <a:lstStyle/>
-          <a:p>
-            <a:pPr>
-              <a:defRPr sz="1400" b="1">
-                <a:solidFill>
-                  <a:srgbClr val="172A45"/>
-                </a:solidFill>
-              </a:defRPr>
-            </a:pPr>
-            <a:r>
-              <a:t>Permit Timeline Predictor</a:t>
-            </a:r>
-          </a:p>
-        </p:txBody>
-      </p:sp>
-      <p:sp>
-        <p:nvSpPr>
-          <p:cNvPr id="14" name="TextBox 13"/>
-          <p:cNvSpPr txBox="1"/>
-          <p:nvPr/>
-        </p:nvSpPr>
-        <p:spPr>
-          <a:xfrm>
-            <a:off x="4434840" y="2011680"/>
-            <a:ext cx="3383280" cy="914400"/>
-          </a:xfrm>
-          <a:prstGeom prst="rect">
-            <a:avLst/>
-          </a:prstGeom>
-          <a:noFill/>
-        </p:spPr>
-        <p:txBody>
-          <a:bodyPr wrap="square">
-            <a:spAutoFit/>
-          </a:bodyPr>
-          <a:lstStyle/>
-          <a:p>
-            <a:pPr>
-              <a:defRPr sz="1100">
-                <a:solidFill>
-                  <a:srgbClr val="475569"/>
-                </a:solidFill>
-              </a:defRPr>
-            </a:pPr>
-            <a:r>
-              <a:t>A tool that estimates realistic approval dates based on county, project size, and historical patterns</a:t>
-            </a:r>
-          </a:p>
-        </p:txBody>
-      </p:sp>
-      <p:sp>
-        <p:nvSpPr>
-          <p:cNvPr id="15" name="Rounded Rectangle 14"/>
+          <p:cNvPr id="16" name="Oval 15"/>
           <p:cNvSpPr/>
           <p:nvPr/>
         </p:nvSpPr>
         <p:spPr>
           <a:xfrm>
-            <a:off x="8092440" y="1371600"/>
-            <a:ext cx="3657600" cy="1600200"/>
-          </a:xfrm>
-          <a:prstGeom prst="roundRect">
+            <a:off x="3497580" y="2240280"/>
+            <a:ext cx="731520" cy="731520"/>
+          </a:xfrm>
+          <a:prstGeom prst="ellipse">
             <a:avLst/>
           </a:prstGeom>
           <a:solidFill>
-            <a:srgbClr val="F8FAFC"/>
+            <a:srgbClr val="008080"/>
           </a:solidFill>
-          <a:ln w="19050">
-            <a:solidFill>
-              <a:srgbClr val="558B6E"/>
-            </a:solidFill>
+          <a:ln>
+            <a:noFill/>
           </a:ln>
         </p:spPr>
         <p:style>
@@ -7080,16 +7237,244 @@
       </p:sp>
       <p:sp>
         <p:nvSpPr>
-          <p:cNvPr id="16" name="Oval 15"/>
+          <p:cNvPr id="17" name="TextBox 16"/>
+          <p:cNvSpPr txBox="1"/>
+          <p:nvPr/>
+        </p:nvSpPr>
+        <p:spPr>
+          <a:xfrm>
+            <a:off x="3543300" y="2331720"/>
+            <a:ext cx="640080" cy="548640"/>
+          </a:xfrm>
+          <a:prstGeom prst="rect">
+            <a:avLst/>
+          </a:prstGeom>
+          <a:noFill/>
+        </p:spPr>
+        <p:txBody>
+          <a:bodyPr wrap="none">
+            <a:spAutoFit/>
+          </a:bodyPr>
+          <a:lstStyle/>
+          <a:p>
+            <a:pPr algn="ctr">
+              <a:defRPr sz="2800"/>
+            </a:pPr>
+            <a:r>
+              <a:t>🔗</a:t>
+            </a:r>
+          </a:p>
+        </p:txBody>
+      </p:sp>
+      <p:sp>
+        <p:nvSpPr>
+          <p:cNvPr id="18" name="TextBox 17"/>
+          <p:cNvSpPr txBox="1"/>
+          <p:nvPr/>
+        </p:nvSpPr>
+        <p:spPr>
+          <a:xfrm>
+            <a:off x="2880360" y="3063240"/>
+            <a:ext cx="1965960" cy="731520"/>
+          </a:xfrm>
+          <a:prstGeom prst="rect">
+            <a:avLst/>
+          </a:prstGeom>
+          <a:noFill/>
+        </p:spPr>
+        <p:txBody>
+          <a:bodyPr wrap="square">
+            <a:spAutoFit/>
+          </a:bodyPr>
+          <a:lstStyle/>
+          <a:p>
+            <a:pPr algn="ctr">
+              <a:defRPr sz="1400" b="1">
+                <a:solidFill>
+                  <a:srgbClr val="008080"/>
+                </a:solidFill>
+              </a:defRPr>
+            </a:pPr>
+            <a:r>
+              <a:t>Connected</a:t>
+            </a:r>
+            <a:br/>
+            <a:r>
+              <a:t>Data Systems</a:t>
+            </a:r>
+          </a:p>
+        </p:txBody>
+      </p:sp>
+      <p:sp>
+        <p:nvSpPr>
+          <p:cNvPr id="19" name="TextBox 18"/>
+          <p:cNvSpPr txBox="1"/>
+          <p:nvPr/>
+        </p:nvSpPr>
+        <p:spPr>
+          <a:xfrm>
+            <a:off x="2880360" y="3794759"/>
+            <a:ext cx="1965960" cy="457200"/>
+          </a:xfrm>
+          <a:prstGeom prst="rect">
+            <a:avLst/>
+          </a:prstGeom>
+          <a:noFill/>
+        </p:spPr>
+        <p:txBody>
+          <a:bodyPr wrap="square">
+            <a:spAutoFit/>
+          </a:bodyPr>
+          <a:lstStyle/>
+          <a:p>
+            <a:pPr algn="ctr">
+              <a:defRPr sz="1300" b="1">
+                <a:solidFill>
+                  <a:srgbClr val="475569"/>
+                </a:solidFill>
+              </a:defRPr>
+            </a:pPr>
+            <a:r>
+              <a:t>Bring scattered info together</a:t>
+            </a:r>
+          </a:p>
+        </p:txBody>
+      </p:sp>
+      <p:sp>
+        <p:nvSpPr>
+          <p:cNvPr id="20" name="TextBox 19"/>
+          <p:cNvSpPr txBox="1"/>
+          <p:nvPr/>
+        </p:nvSpPr>
+        <p:spPr>
+          <a:xfrm>
+            <a:off x="2880360" y="4251960"/>
+            <a:ext cx="1965960" cy="1280160"/>
+          </a:xfrm>
+          <a:prstGeom prst="rect">
+            <a:avLst/>
+          </a:prstGeom>
+          <a:noFill/>
+        </p:spPr>
+        <p:txBody>
+          <a:bodyPr wrap="square">
+            <a:spAutoFit/>
+          </a:bodyPr>
+          <a:lstStyle/>
+          <a:p>
+            <a:pPr algn="ctr">
+              <a:defRPr sz="1100">
+                <a:solidFill>
+                  <a:srgbClr val="64748B"/>
+                </a:solidFill>
+              </a:defRPr>
+            </a:pPr>
+            <a:r>
+              <a:t>Link spreadsheets, databases, and documents in one place</a:t>
+            </a:r>
+          </a:p>
+        </p:txBody>
+      </p:sp>
+      <p:sp>
+        <p:nvSpPr>
+          <p:cNvPr id="21" name="Right Arrow 20"/>
           <p:cNvSpPr/>
           <p:nvPr/>
         </p:nvSpPr>
         <p:spPr>
           <a:xfrm>
-            <a:off x="8229600" y="1508760"/>
-            <a:ext cx="457200" cy="457200"/>
-          </a:xfrm>
-          <a:prstGeom prst="ellipse">
+            <a:off x="4956048" y="2651760"/>
+            <a:ext cx="146304" cy="228600"/>
+          </a:xfrm>
+          <a:prstGeom prst="rightArrow">
+            <a:avLst/>
+          </a:prstGeom>
+          <a:solidFill>
+            <a:srgbClr val="C8D2DC"/>
+          </a:solidFill>
+          <a:ln>
+            <a:noFill/>
+          </a:ln>
+        </p:spPr>
+        <p:style>
+          <a:lnRef idx="1">
+            <a:schemeClr val="accent1"/>
+          </a:lnRef>
+          <a:fillRef idx="3">
+            <a:schemeClr val="accent1"/>
+          </a:fillRef>
+          <a:effectRef idx="2">
+            <a:schemeClr val="accent1"/>
+          </a:effectRef>
+          <a:fontRef idx="minor">
+            <a:schemeClr val="lt1"/>
+          </a:fontRef>
+        </p:style>
+        <p:txBody>
+          <a:bodyPr rtlCol="0" anchor="ctr"/>
+          <a:lstStyle/>
+          <a:p>
+            <a:pPr algn="ctr"/>
+          </a:p>
+        </p:txBody>
+      </p:sp>
+      <p:sp>
+        <p:nvSpPr>
+          <p:cNvPr id="22" name="Rounded Rectangle 21"/>
+          <p:cNvSpPr/>
+          <p:nvPr/>
+        </p:nvSpPr>
+        <p:spPr>
+          <a:xfrm>
+            <a:off x="5120640" y="1920240"/>
+            <a:ext cx="2148840" cy="3840480"/>
+          </a:xfrm>
+          <a:prstGeom prst="roundRect">
+            <a:avLst/>
+          </a:prstGeom>
+          <a:solidFill>
+            <a:srgbClr val="FFFFFF"/>
+          </a:solidFill>
+          <a:ln w="25400">
+            <a:solidFill>
+              <a:srgbClr val="558B6E"/>
+            </a:solidFill>
+          </a:ln>
+        </p:spPr>
+        <p:style>
+          <a:lnRef idx="1">
+            <a:schemeClr val="accent1"/>
+          </a:lnRef>
+          <a:fillRef idx="3">
+            <a:schemeClr val="accent1"/>
+          </a:fillRef>
+          <a:effectRef idx="2">
+            <a:schemeClr val="accent1"/>
+          </a:effectRef>
+          <a:fontRef idx="minor">
+            <a:schemeClr val="lt1"/>
+          </a:fontRef>
+        </p:style>
+        <p:txBody>
+          <a:bodyPr rtlCol="0" anchor="ctr"/>
+          <a:lstStyle/>
+          <a:p>
+            <a:pPr algn="ctr"/>
+          </a:p>
+        </p:txBody>
+      </p:sp>
+      <p:sp>
+        <p:nvSpPr>
+          <p:cNvPr id="23" name="Rectangle 22"/>
+          <p:cNvSpPr/>
+          <p:nvPr/>
+        </p:nvSpPr>
+        <p:spPr>
+          <a:xfrm>
+            <a:off x="5120640" y="1920240"/>
+            <a:ext cx="2148840" cy="137160"/>
+          </a:xfrm>
+          <a:prstGeom prst="rect">
             <a:avLst/>
           </a:prstGeom>
           <a:solidFill>
@@ -7123,126 +7508,23 @@
       </p:sp>
       <p:sp>
         <p:nvSpPr>
-          <p:cNvPr id="17" name="TextBox 16"/>
-          <p:cNvSpPr txBox="1"/>
-          <p:nvPr/>
-        </p:nvSpPr>
-        <p:spPr>
-          <a:xfrm>
-            <a:off x="8229600" y="1554480"/>
-            <a:ext cx="457200" cy="365760"/>
-          </a:xfrm>
-          <a:prstGeom prst="rect">
-            <a:avLst/>
-          </a:prstGeom>
-          <a:noFill/>
-        </p:spPr>
-        <p:txBody>
-          <a:bodyPr wrap="none">
-            <a:spAutoFit/>
-          </a:bodyPr>
-          <a:lstStyle/>
-          <a:p>
-            <a:pPr algn="ctr">
-              <a:defRPr sz="2000"/>
-            </a:pPr>
-            <a:r>
-              <a:t>📄</a:t>
-            </a:r>
-          </a:p>
-        </p:txBody>
-      </p:sp>
-      <p:sp>
-        <p:nvSpPr>
-          <p:cNvPr id="18" name="TextBox 17"/>
-          <p:cNvSpPr txBox="1"/>
-          <p:nvPr/>
-        </p:nvSpPr>
-        <p:spPr>
-          <a:xfrm>
-            <a:off x="8778240" y="1554480"/>
-            <a:ext cx="2834640" cy="411480"/>
-          </a:xfrm>
-          <a:prstGeom prst="rect">
-            <a:avLst/>
-          </a:prstGeom>
-          <a:noFill/>
-        </p:spPr>
-        <p:txBody>
-          <a:bodyPr wrap="none">
-            <a:spAutoFit/>
-          </a:bodyPr>
-          <a:lstStyle/>
-          <a:p>
-            <a:pPr>
-              <a:defRPr sz="1400" b="1">
-                <a:solidFill>
-                  <a:srgbClr val="172A45"/>
-                </a:solidFill>
-              </a:defRPr>
-            </a:pPr>
-            <a:r>
-              <a:t>Automatic Report Generator</a:t>
-            </a:r>
-          </a:p>
-        </p:txBody>
-      </p:sp>
-      <p:sp>
-        <p:nvSpPr>
-          <p:cNvPr id="19" name="TextBox 18"/>
-          <p:cNvSpPr txBox="1"/>
-          <p:nvPr/>
-        </p:nvSpPr>
-        <p:spPr>
-          <a:xfrm>
-            <a:off x="8229600" y="2011680"/>
-            <a:ext cx="3383280" cy="914400"/>
-          </a:xfrm>
-          <a:prstGeom prst="rect">
-            <a:avLst/>
-          </a:prstGeom>
-          <a:noFill/>
-        </p:spPr>
-        <p:txBody>
-          <a:bodyPr wrap="square">
-            <a:spAutoFit/>
-          </a:bodyPr>
-          <a:lstStyle/>
-          <a:p>
-            <a:pPr>
-              <a:defRPr sz="1100">
-                <a:solidFill>
-                  <a:srgbClr val="475569"/>
-                </a:solidFill>
-              </a:defRPr>
-            </a:pPr>
-            <a:r>
-              <a:t>Feed in your project data, get a formatted status report or permit application draft — ready to review</a:t>
-            </a:r>
-          </a:p>
-        </p:txBody>
-      </p:sp>
-      <p:sp>
-        <p:nvSpPr>
-          <p:cNvPr id="20" name="Rounded Rectangle 19"/>
+          <p:cNvPr id="24" name="Oval 23"/>
           <p:cNvSpPr/>
           <p:nvPr/>
         </p:nvSpPr>
         <p:spPr>
           <a:xfrm>
-            <a:off x="502920" y="3108960"/>
-            <a:ext cx="3657600" cy="1600200"/>
-          </a:xfrm>
-          <a:prstGeom prst="roundRect">
+            <a:off x="5829300" y="2240280"/>
+            <a:ext cx="731520" cy="731520"/>
+          </a:xfrm>
+          <a:prstGeom prst="ellipse">
             <a:avLst/>
           </a:prstGeom>
           <a:solidFill>
-            <a:srgbClr val="F8FAFC"/>
+            <a:srgbClr val="558B6E"/>
           </a:solidFill>
-          <a:ln w="19050">
-            <a:solidFill>
-              <a:srgbClr val="9370A5"/>
-            </a:solidFill>
+          <a:ln>
+            <a:noFill/>
           </a:ln>
         </p:spPr>
         <p:style>
@@ -7269,16 +7551,244 @@
       </p:sp>
       <p:sp>
         <p:nvSpPr>
-          <p:cNvPr id="21" name="Oval 20"/>
+          <p:cNvPr id="25" name="TextBox 24"/>
+          <p:cNvSpPr txBox="1"/>
+          <p:nvPr/>
+        </p:nvSpPr>
+        <p:spPr>
+          <a:xfrm>
+            <a:off x="5875020" y="2331720"/>
+            <a:ext cx="640080" cy="548640"/>
+          </a:xfrm>
+          <a:prstGeom prst="rect">
+            <a:avLst/>
+          </a:prstGeom>
+          <a:noFill/>
+        </p:spPr>
+        <p:txBody>
+          <a:bodyPr wrap="none">
+            <a:spAutoFit/>
+          </a:bodyPr>
+          <a:lstStyle/>
+          <a:p>
+            <a:pPr algn="ctr">
+              <a:defRPr sz="2800"/>
+            </a:pPr>
+            <a:r>
+              <a:t>📈</a:t>
+            </a:r>
+          </a:p>
+        </p:txBody>
+      </p:sp>
+      <p:sp>
+        <p:nvSpPr>
+          <p:cNvPr id="26" name="TextBox 25"/>
+          <p:cNvSpPr txBox="1"/>
+          <p:nvPr/>
+        </p:nvSpPr>
+        <p:spPr>
+          <a:xfrm>
+            <a:off x="5212080" y="3063240"/>
+            <a:ext cx="1965960" cy="731520"/>
+          </a:xfrm>
+          <a:prstGeom prst="rect">
+            <a:avLst/>
+          </a:prstGeom>
+          <a:noFill/>
+        </p:spPr>
+        <p:txBody>
+          <a:bodyPr wrap="square">
+            <a:spAutoFit/>
+          </a:bodyPr>
+          <a:lstStyle/>
+          <a:p>
+            <a:pPr algn="ctr">
+              <a:defRPr sz="1400" b="1">
+                <a:solidFill>
+                  <a:srgbClr val="558B6E"/>
+                </a:solidFill>
+              </a:defRPr>
+            </a:pPr>
+            <a:r>
+              <a:t>Analysis &amp;</a:t>
+            </a:r>
+            <a:br/>
+            <a:r>
+              <a:t>Insights</a:t>
+            </a:r>
+          </a:p>
+        </p:txBody>
+      </p:sp>
+      <p:sp>
+        <p:nvSpPr>
+          <p:cNvPr id="27" name="TextBox 26"/>
+          <p:cNvSpPr txBox="1"/>
+          <p:nvPr/>
+        </p:nvSpPr>
+        <p:spPr>
+          <a:xfrm>
+            <a:off x="5212080" y="3794759"/>
+            <a:ext cx="1965960" cy="457200"/>
+          </a:xfrm>
+          <a:prstGeom prst="rect">
+            <a:avLst/>
+          </a:prstGeom>
+          <a:noFill/>
+        </p:spPr>
+        <p:txBody>
+          <a:bodyPr wrap="square">
+            <a:spAutoFit/>
+          </a:bodyPr>
+          <a:lstStyle/>
+          <a:p>
+            <a:pPr algn="ctr">
+              <a:defRPr sz="1300" b="1">
+                <a:solidFill>
+                  <a:srgbClr val="475569"/>
+                </a:solidFill>
+              </a:defRPr>
+            </a:pPr>
+            <a:r>
+              <a:t>Find patterns and trends</a:t>
+            </a:r>
+          </a:p>
+        </p:txBody>
+      </p:sp>
+      <p:sp>
+        <p:nvSpPr>
+          <p:cNvPr id="28" name="TextBox 27"/>
+          <p:cNvSpPr txBox="1"/>
+          <p:nvPr/>
+        </p:nvSpPr>
+        <p:spPr>
+          <a:xfrm>
+            <a:off x="5212080" y="4251960"/>
+            <a:ext cx="1965960" cy="1280160"/>
+          </a:xfrm>
+          <a:prstGeom prst="rect">
+            <a:avLst/>
+          </a:prstGeom>
+          <a:noFill/>
+        </p:spPr>
+        <p:txBody>
+          <a:bodyPr wrap="square">
+            <a:spAutoFit/>
+          </a:bodyPr>
+          <a:lstStyle/>
+          <a:p>
+            <a:pPr algn="ctr">
+              <a:defRPr sz="1100">
+                <a:solidFill>
+                  <a:srgbClr val="64748B"/>
+                </a:solidFill>
+              </a:defRPr>
+            </a:pPr>
+            <a:r>
+              <a:t>What's working? What's slowing down? Where to focus?</a:t>
+            </a:r>
+          </a:p>
+        </p:txBody>
+      </p:sp>
+      <p:sp>
+        <p:nvSpPr>
+          <p:cNvPr id="29" name="Right Arrow 28"/>
           <p:cNvSpPr/>
           <p:nvPr/>
         </p:nvSpPr>
         <p:spPr>
           <a:xfrm>
-            <a:off x="640080" y="3246120"/>
-            <a:ext cx="457200" cy="457200"/>
-          </a:xfrm>
-          <a:prstGeom prst="ellipse">
+            <a:off x="7287768" y="2651760"/>
+            <a:ext cx="146304" cy="228600"/>
+          </a:xfrm>
+          <a:prstGeom prst="rightArrow">
+            <a:avLst/>
+          </a:prstGeom>
+          <a:solidFill>
+            <a:srgbClr val="C8D2DC"/>
+          </a:solidFill>
+          <a:ln>
+            <a:noFill/>
+          </a:ln>
+        </p:spPr>
+        <p:style>
+          <a:lnRef idx="1">
+            <a:schemeClr val="accent1"/>
+          </a:lnRef>
+          <a:fillRef idx="3">
+            <a:schemeClr val="accent1"/>
+          </a:fillRef>
+          <a:effectRef idx="2">
+            <a:schemeClr val="accent1"/>
+          </a:effectRef>
+          <a:fontRef idx="minor">
+            <a:schemeClr val="lt1"/>
+          </a:fontRef>
+        </p:style>
+        <p:txBody>
+          <a:bodyPr rtlCol="0" anchor="ctr"/>
+          <a:lstStyle/>
+          <a:p>
+            <a:pPr algn="ctr"/>
+          </a:p>
+        </p:txBody>
+      </p:sp>
+      <p:sp>
+        <p:nvSpPr>
+          <p:cNvPr id="30" name="Rounded Rectangle 29"/>
+          <p:cNvSpPr/>
+          <p:nvPr/>
+        </p:nvSpPr>
+        <p:spPr>
+          <a:xfrm>
+            <a:off x="7452360" y="1920240"/>
+            <a:ext cx="2148840" cy="3840480"/>
+          </a:xfrm>
+          <a:prstGeom prst="roundRect">
+            <a:avLst/>
+          </a:prstGeom>
+          <a:solidFill>
+            <a:srgbClr val="FFFFFF"/>
+          </a:solidFill>
+          <a:ln w="25400">
+            <a:solidFill>
+              <a:srgbClr val="9370A5"/>
+            </a:solidFill>
+          </a:ln>
+        </p:spPr>
+        <p:style>
+          <a:lnRef idx="1">
+            <a:schemeClr val="accent1"/>
+          </a:lnRef>
+          <a:fillRef idx="3">
+            <a:schemeClr val="accent1"/>
+          </a:fillRef>
+          <a:effectRef idx="2">
+            <a:schemeClr val="accent1"/>
+          </a:effectRef>
+          <a:fontRef idx="minor">
+            <a:schemeClr val="lt1"/>
+          </a:fontRef>
+        </p:style>
+        <p:txBody>
+          <a:bodyPr rtlCol="0" anchor="ctr"/>
+          <a:lstStyle/>
+          <a:p>
+            <a:pPr algn="ctr"/>
+          </a:p>
+        </p:txBody>
+      </p:sp>
+      <p:sp>
+        <p:nvSpPr>
+          <p:cNvPr id="31" name="Rectangle 30"/>
+          <p:cNvSpPr/>
+          <p:nvPr/>
+        </p:nvSpPr>
+        <p:spPr>
+          <a:xfrm>
+            <a:off x="7452360" y="1920240"/>
+            <a:ext cx="2148840" cy="137160"/>
+          </a:xfrm>
+          <a:prstGeom prst="rect">
             <a:avLst/>
           </a:prstGeom>
           <a:solidFill>
@@ -7312,126 +7822,23 @@
       </p:sp>
       <p:sp>
         <p:nvSpPr>
-          <p:cNvPr id="22" name="TextBox 21"/>
-          <p:cNvSpPr txBox="1"/>
-          <p:nvPr/>
-        </p:nvSpPr>
-        <p:spPr>
-          <a:xfrm>
-            <a:off x="640080" y="3291840"/>
-            <a:ext cx="457200" cy="365760"/>
-          </a:xfrm>
-          <a:prstGeom prst="rect">
-            <a:avLst/>
-          </a:prstGeom>
-          <a:noFill/>
-        </p:spPr>
-        <p:txBody>
-          <a:bodyPr wrap="none">
-            <a:spAutoFit/>
-          </a:bodyPr>
-          <a:lstStyle/>
-          <a:p>
-            <a:pPr algn="ctr">
-              <a:defRPr sz="2000"/>
-            </a:pPr>
-            <a:r>
-              <a:t>🗺️</a:t>
-            </a:r>
-          </a:p>
-        </p:txBody>
-      </p:sp>
-      <p:sp>
-        <p:nvSpPr>
-          <p:cNvPr id="23" name="TextBox 22"/>
-          <p:cNvSpPr txBox="1"/>
-          <p:nvPr/>
-        </p:nvSpPr>
-        <p:spPr>
-          <a:xfrm>
-            <a:off x="1188720" y="3291840"/>
-            <a:ext cx="2834640" cy="411480"/>
-          </a:xfrm>
-          <a:prstGeom prst="rect">
-            <a:avLst/>
-          </a:prstGeom>
-          <a:noFill/>
-        </p:spPr>
-        <p:txBody>
-          <a:bodyPr wrap="none">
-            <a:spAutoFit/>
-          </a:bodyPr>
-          <a:lstStyle/>
-          <a:p>
-            <a:pPr>
-              <a:defRPr sz="1400" b="1">
-                <a:solidFill>
-                  <a:srgbClr val="172A45"/>
-                </a:solidFill>
-              </a:defRPr>
-            </a:pPr>
-            <a:r>
-              <a:t>Interactive Project Maps</a:t>
-            </a:r>
-          </a:p>
-        </p:txBody>
-      </p:sp>
-      <p:sp>
-        <p:nvSpPr>
-          <p:cNvPr id="24" name="TextBox 23"/>
-          <p:cNvSpPr txBox="1"/>
-          <p:nvPr/>
-        </p:nvSpPr>
-        <p:spPr>
-          <a:xfrm>
-            <a:off x="640080" y="3749040"/>
-            <a:ext cx="3383280" cy="914400"/>
-          </a:xfrm>
-          <a:prstGeom prst="rect">
-            <a:avLst/>
-          </a:prstGeom>
-          <a:noFill/>
-        </p:spPr>
-        <p:txBody>
-          <a:bodyPr wrap="square">
-            <a:spAutoFit/>
-          </a:bodyPr>
-          <a:lstStyle/>
-          <a:p>
-            <a:pPr>
-              <a:defRPr sz="1100">
-                <a:solidFill>
-                  <a:srgbClr val="475569"/>
-                </a:solidFill>
-              </a:defRPr>
-            </a:pPr>
-            <a:r>
-              <a:t>Visual maps showing land status, permitting progress, and key metrics you can explore and filter</a:t>
-            </a:r>
-          </a:p>
-        </p:txBody>
-      </p:sp>
-      <p:sp>
-        <p:nvSpPr>
-          <p:cNvPr id="25" name="Rounded Rectangle 24"/>
+          <p:cNvPr id="32" name="Oval 31"/>
           <p:cNvSpPr/>
           <p:nvPr/>
         </p:nvSpPr>
         <p:spPr>
           <a:xfrm>
-            <a:off x="4297680" y="3108960"/>
-            <a:ext cx="3657600" cy="1600200"/>
-          </a:xfrm>
-          <a:prstGeom prst="roundRect">
+            <a:off x="8161020" y="2240280"/>
+            <a:ext cx="731520" cy="731520"/>
+          </a:xfrm>
+          <a:prstGeom prst="ellipse">
             <a:avLst/>
           </a:prstGeom>
           <a:solidFill>
-            <a:srgbClr val="F8FAFC"/>
+            <a:srgbClr val="9370A5"/>
           </a:solidFill>
-          <a:ln w="19050">
-            <a:solidFill>
-              <a:srgbClr val="CD853F"/>
-            </a:solidFill>
+          <a:ln>
+            <a:noFill/>
           </a:ln>
         </p:spPr>
         <p:style>
@@ -7458,16 +7865,244 @@
       </p:sp>
       <p:sp>
         <p:nvSpPr>
-          <p:cNvPr id="26" name="Oval 25"/>
+          <p:cNvPr id="33" name="TextBox 32"/>
+          <p:cNvSpPr txBox="1"/>
+          <p:nvPr/>
+        </p:nvSpPr>
+        <p:spPr>
+          <a:xfrm>
+            <a:off x="8206740" y="2331720"/>
+            <a:ext cx="640080" cy="548640"/>
+          </a:xfrm>
+          <a:prstGeom prst="rect">
+            <a:avLst/>
+          </a:prstGeom>
+          <a:noFill/>
+        </p:spPr>
+        <p:txBody>
+          <a:bodyPr wrap="none">
+            <a:spAutoFit/>
+          </a:bodyPr>
+          <a:lstStyle/>
+          <a:p>
+            <a:pPr algn="ctr">
+              <a:defRPr sz="2800"/>
+            </a:pPr>
+            <a:r>
+              <a:t>🔮</a:t>
+            </a:r>
+          </a:p>
+        </p:txBody>
+      </p:sp>
+      <p:sp>
+        <p:nvSpPr>
+          <p:cNvPr id="34" name="TextBox 33"/>
+          <p:cNvSpPr txBox="1"/>
+          <p:nvPr/>
+        </p:nvSpPr>
+        <p:spPr>
+          <a:xfrm>
+            <a:off x="7543800" y="3063240"/>
+            <a:ext cx="1965960" cy="731520"/>
+          </a:xfrm>
+          <a:prstGeom prst="rect">
+            <a:avLst/>
+          </a:prstGeom>
+          <a:noFill/>
+        </p:spPr>
+        <p:txBody>
+          <a:bodyPr wrap="square">
+            <a:spAutoFit/>
+          </a:bodyPr>
+          <a:lstStyle/>
+          <a:p>
+            <a:pPr algn="ctr">
+              <a:defRPr sz="1400" b="1">
+                <a:solidFill>
+                  <a:srgbClr val="9370A5"/>
+                </a:solidFill>
+              </a:defRPr>
+            </a:pPr>
+            <a:r>
+              <a:t>Predictions &amp;</a:t>
+            </a:r>
+            <a:br/>
+            <a:r>
+              <a:t>Forecasts</a:t>
+            </a:r>
+          </a:p>
+        </p:txBody>
+      </p:sp>
+      <p:sp>
+        <p:nvSpPr>
+          <p:cNvPr id="35" name="TextBox 34"/>
+          <p:cNvSpPr txBox="1"/>
+          <p:nvPr/>
+        </p:nvSpPr>
+        <p:spPr>
+          <a:xfrm>
+            <a:off x="7543800" y="3794759"/>
+            <a:ext cx="1965960" cy="457200"/>
+          </a:xfrm>
+          <a:prstGeom prst="rect">
+            <a:avLst/>
+          </a:prstGeom>
+          <a:noFill/>
+        </p:spPr>
+        <p:txBody>
+          <a:bodyPr wrap="square">
+            <a:spAutoFit/>
+          </a:bodyPr>
+          <a:lstStyle/>
+          <a:p>
+            <a:pPr algn="ctr">
+              <a:defRPr sz="1300" b="1">
+                <a:solidFill>
+                  <a:srgbClr val="475569"/>
+                </a:solidFill>
+              </a:defRPr>
+            </a:pPr>
+            <a:r>
+              <a:t>See what's likely coming</a:t>
+            </a:r>
+          </a:p>
+        </p:txBody>
+      </p:sp>
+      <p:sp>
+        <p:nvSpPr>
+          <p:cNvPr id="36" name="TextBox 35"/>
+          <p:cNvSpPr txBox="1"/>
+          <p:nvPr/>
+        </p:nvSpPr>
+        <p:spPr>
+          <a:xfrm>
+            <a:off x="7543800" y="4251960"/>
+            <a:ext cx="1965960" cy="1280160"/>
+          </a:xfrm>
+          <a:prstGeom prst="rect">
+            <a:avLst/>
+          </a:prstGeom>
+          <a:noFill/>
+        </p:spPr>
+        <p:txBody>
+          <a:bodyPr wrap="square">
+            <a:spAutoFit/>
+          </a:bodyPr>
+          <a:lstStyle/>
+          <a:p>
+            <a:pPr algn="ctr">
+              <a:defRPr sz="1100">
+                <a:solidFill>
+                  <a:srgbClr val="64748B"/>
+                </a:solidFill>
+              </a:defRPr>
+            </a:pPr>
+            <a:r>
+              <a:t>Timeline estimates, risk flags, outcome probabilities</a:t>
+            </a:r>
+          </a:p>
+        </p:txBody>
+      </p:sp>
+      <p:sp>
+        <p:nvSpPr>
+          <p:cNvPr id="37" name="Right Arrow 36"/>
           <p:cNvSpPr/>
           <p:nvPr/>
         </p:nvSpPr>
         <p:spPr>
           <a:xfrm>
-            <a:off x="4434840" y="3246120"/>
-            <a:ext cx="457200" cy="457200"/>
-          </a:xfrm>
-          <a:prstGeom prst="ellipse">
+            <a:off x="9619488" y="2651760"/>
+            <a:ext cx="146304" cy="228600"/>
+          </a:xfrm>
+          <a:prstGeom prst="rightArrow">
+            <a:avLst/>
+          </a:prstGeom>
+          <a:solidFill>
+            <a:srgbClr val="C8D2DC"/>
+          </a:solidFill>
+          <a:ln>
+            <a:noFill/>
+          </a:ln>
+        </p:spPr>
+        <p:style>
+          <a:lnRef idx="1">
+            <a:schemeClr val="accent1"/>
+          </a:lnRef>
+          <a:fillRef idx="3">
+            <a:schemeClr val="accent1"/>
+          </a:fillRef>
+          <a:effectRef idx="2">
+            <a:schemeClr val="accent1"/>
+          </a:effectRef>
+          <a:fontRef idx="minor">
+            <a:schemeClr val="lt1"/>
+          </a:fontRef>
+        </p:style>
+        <p:txBody>
+          <a:bodyPr rtlCol="0" anchor="ctr"/>
+          <a:lstStyle/>
+          <a:p>
+            <a:pPr algn="ctr"/>
+          </a:p>
+        </p:txBody>
+      </p:sp>
+      <p:sp>
+        <p:nvSpPr>
+          <p:cNvPr id="38" name="Rounded Rectangle 37"/>
+          <p:cNvSpPr/>
+          <p:nvPr/>
+        </p:nvSpPr>
+        <p:spPr>
+          <a:xfrm>
+            <a:off x="9784080" y="1920240"/>
+            <a:ext cx="2148840" cy="3840480"/>
+          </a:xfrm>
+          <a:prstGeom prst="roundRect">
+            <a:avLst/>
+          </a:prstGeom>
+          <a:solidFill>
+            <a:srgbClr val="FFFFFF"/>
+          </a:solidFill>
+          <a:ln w="25400">
+            <a:solidFill>
+              <a:srgbClr val="CD853F"/>
+            </a:solidFill>
+          </a:ln>
+        </p:spPr>
+        <p:style>
+          <a:lnRef idx="1">
+            <a:schemeClr val="accent1"/>
+          </a:lnRef>
+          <a:fillRef idx="3">
+            <a:schemeClr val="accent1"/>
+          </a:fillRef>
+          <a:effectRef idx="2">
+            <a:schemeClr val="accent1"/>
+          </a:effectRef>
+          <a:fontRef idx="minor">
+            <a:schemeClr val="lt1"/>
+          </a:fontRef>
+        </p:style>
+        <p:txBody>
+          <a:bodyPr rtlCol="0" anchor="ctr"/>
+          <a:lstStyle/>
+          <a:p>
+            <a:pPr algn="ctr"/>
+          </a:p>
+        </p:txBody>
+      </p:sp>
+      <p:sp>
+        <p:nvSpPr>
+          <p:cNvPr id="39" name="Rectangle 38"/>
+          <p:cNvSpPr/>
+          <p:nvPr/>
+        </p:nvSpPr>
+        <p:spPr>
+          <a:xfrm>
+            <a:off x="9784080" y="1920240"/>
+            <a:ext cx="2148840" cy="137160"/>
+          </a:xfrm>
+          <a:prstGeom prst="rect">
             <a:avLst/>
           </a:prstGeom>
           <a:solidFill>
@@ -7501,126 +8136,23 @@
       </p:sp>
       <p:sp>
         <p:nvSpPr>
-          <p:cNvPr id="27" name="TextBox 26"/>
-          <p:cNvSpPr txBox="1"/>
-          <p:nvPr/>
-        </p:nvSpPr>
-        <p:spPr>
-          <a:xfrm>
-            <a:off x="4434840" y="3291840"/>
-            <a:ext cx="457200" cy="365760"/>
-          </a:xfrm>
-          <a:prstGeom prst="rect">
-            <a:avLst/>
-          </a:prstGeom>
-          <a:noFill/>
-        </p:spPr>
-        <p:txBody>
-          <a:bodyPr wrap="none">
-            <a:spAutoFit/>
-          </a:bodyPr>
-          <a:lstStyle/>
-          <a:p>
-            <a:pPr algn="ctr">
-              <a:defRPr sz="2000"/>
-            </a:pPr>
-            <a:r>
-              <a:t>💬</a:t>
-            </a:r>
-          </a:p>
-        </p:txBody>
-      </p:sp>
-      <p:sp>
-        <p:nvSpPr>
-          <p:cNvPr id="28" name="TextBox 27"/>
-          <p:cNvSpPr txBox="1"/>
-          <p:nvPr/>
-        </p:nvSpPr>
-        <p:spPr>
-          <a:xfrm>
-            <a:off x="4983480" y="3291840"/>
-            <a:ext cx="2834640" cy="411480"/>
-          </a:xfrm>
-          <a:prstGeom prst="rect">
-            <a:avLst/>
-          </a:prstGeom>
-          <a:noFill/>
-        </p:spPr>
-        <p:txBody>
-          <a:bodyPr wrap="none">
-            <a:spAutoFit/>
-          </a:bodyPr>
-          <a:lstStyle/>
-          <a:p>
-            <a:pPr>
-              <a:defRPr sz="1400" b="1">
-                <a:solidFill>
-                  <a:srgbClr val="172A45"/>
-                </a:solidFill>
-              </a:defRPr>
-            </a:pPr>
-            <a:r>
-              <a:t>Project Data Assistant</a:t>
-            </a:r>
-          </a:p>
-        </p:txBody>
-      </p:sp>
-      <p:sp>
-        <p:nvSpPr>
-          <p:cNvPr id="29" name="TextBox 28"/>
-          <p:cNvSpPr txBox="1"/>
-          <p:nvPr/>
-        </p:nvSpPr>
-        <p:spPr>
-          <a:xfrm>
-            <a:off x="4434840" y="3749040"/>
-            <a:ext cx="3383280" cy="914400"/>
-          </a:xfrm>
-          <a:prstGeom prst="rect">
-            <a:avLst/>
-          </a:prstGeom>
-          <a:noFill/>
-        </p:spPr>
-        <p:txBody>
-          <a:bodyPr wrap="square">
-            <a:spAutoFit/>
-          </a:bodyPr>
-          <a:lstStyle/>
-          <a:p>
-            <a:pPr>
-              <a:defRPr sz="1100">
-                <a:solidFill>
-                  <a:srgbClr val="475569"/>
-                </a:solidFill>
-              </a:defRPr>
-            </a:pPr>
-            <a:r>
-              <a:t>Ask questions in plain English like "Which projects in Texas are waiting on permits?" and get instant answers</a:t>
-            </a:r>
-          </a:p>
-        </p:txBody>
-      </p:sp>
-      <p:sp>
-        <p:nvSpPr>
-          <p:cNvPr id="30" name="Rounded Rectangle 29"/>
+          <p:cNvPr id="40" name="Oval 39"/>
           <p:cNvSpPr/>
           <p:nvPr/>
         </p:nvSpPr>
         <p:spPr>
           <a:xfrm>
-            <a:off x="8092440" y="3108960"/>
-            <a:ext cx="3657600" cy="1600200"/>
-          </a:xfrm>
-          <a:prstGeom prst="roundRect">
+            <a:off x="10492740" y="2240280"/>
+            <a:ext cx="731520" cy="731520"/>
+          </a:xfrm>
+          <a:prstGeom prst="ellipse">
             <a:avLst/>
           </a:prstGeom>
           <a:solidFill>
-            <a:srgbClr val="F8FAFC"/>
+            <a:srgbClr val="CD853F"/>
           </a:solidFill>
-          <a:ln w="19050">
-            <a:solidFill>
-              <a:srgbClr val="778899"/>
-            </a:solidFill>
+          <a:ln>
+            <a:noFill/>
           </a:ln>
         </p:spPr>
         <p:style>
@@ -7647,57 +8179,14 @@
       </p:sp>
       <p:sp>
         <p:nvSpPr>
-          <p:cNvPr id="31" name="Oval 30"/>
-          <p:cNvSpPr/>
-          <p:nvPr/>
-        </p:nvSpPr>
-        <p:spPr>
-          <a:xfrm>
-            <a:off x="8229600" y="3246120"/>
-            <a:ext cx="457200" cy="457200"/>
-          </a:xfrm>
-          <a:prstGeom prst="ellipse">
-            <a:avLst/>
-          </a:prstGeom>
-          <a:solidFill>
-            <a:srgbClr val="778899"/>
-          </a:solidFill>
-          <a:ln>
-            <a:noFill/>
-          </a:ln>
-        </p:spPr>
-        <p:style>
-          <a:lnRef idx="1">
-            <a:schemeClr val="accent1"/>
-          </a:lnRef>
-          <a:fillRef idx="3">
-            <a:schemeClr val="accent1"/>
-          </a:fillRef>
-          <a:effectRef idx="2">
-            <a:schemeClr val="accent1"/>
-          </a:effectRef>
-          <a:fontRef idx="minor">
-            <a:schemeClr val="lt1"/>
-          </a:fontRef>
-        </p:style>
-        <p:txBody>
-          <a:bodyPr rtlCol="0" anchor="ctr"/>
-          <a:lstStyle/>
-          <a:p>
-            <a:pPr algn="ctr"/>
-          </a:p>
-        </p:txBody>
-      </p:sp>
-      <p:sp>
-        <p:nvSpPr>
-          <p:cNvPr id="32" name="TextBox 31"/>
+          <p:cNvPr id="41" name="TextBox 40"/>
           <p:cNvSpPr txBox="1"/>
           <p:nvPr/>
         </p:nvSpPr>
         <p:spPr>
           <a:xfrm>
-            <a:off x="8229600" y="3291840"/>
-            <a:ext cx="457200" cy="365760"/>
+            <a:off x="10538460" y="2331720"/>
+            <a:ext cx="640080" cy="548640"/>
           </a:xfrm>
           <a:prstGeom prst="rect">
             <a:avLst/>
@@ -7711,24 +8200,133 @@
           <a:lstStyle/>
           <a:p>
             <a:pPr algn="ctr">
-              <a:defRPr sz="2000"/>
-            </a:pPr>
-            <a:r>
-              <a:t>🔗</a:t>
-            </a:r>
-          </a:p>
-        </p:txBody>
-      </p:sp>
-      <p:sp>
-        <p:nvSpPr>
-          <p:cNvPr id="33" name="TextBox 32"/>
+              <a:defRPr sz="2800"/>
+            </a:pPr>
+            <a:r>
+              <a:t>🤖</a:t>
+            </a:r>
+          </a:p>
+        </p:txBody>
+      </p:sp>
+      <p:sp>
+        <p:nvSpPr>
+          <p:cNvPr id="42" name="TextBox 41"/>
           <p:cNvSpPr txBox="1"/>
           <p:nvPr/>
         </p:nvSpPr>
         <p:spPr>
           <a:xfrm>
-            <a:off x="8778240" y="3291840"/>
-            <a:ext cx="2834640" cy="411480"/>
+            <a:off x="9875520" y="3063240"/>
+            <a:ext cx="1965960" cy="731520"/>
+          </a:xfrm>
+          <a:prstGeom prst="rect">
+            <a:avLst/>
+          </a:prstGeom>
+          <a:noFill/>
+        </p:spPr>
+        <p:txBody>
+          <a:bodyPr wrap="square">
+            <a:spAutoFit/>
+          </a:bodyPr>
+          <a:lstStyle/>
+          <a:p>
+            <a:pPr algn="ctr">
+              <a:defRPr sz="1400" b="1">
+                <a:solidFill>
+                  <a:srgbClr val="CD853F"/>
+                </a:solidFill>
+              </a:defRPr>
+            </a:pPr>
+            <a:r>
+              <a:t>AI-Powered</a:t>
+            </a:r>
+            <a:br/>
+            <a:r>
+              <a:t>Tools</a:t>
+            </a:r>
+          </a:p>
+        </p:txBody>
+      </p:sp>
+      <p:sp>
+        <p:nvSpPr>
+          <p:cNvPr id="43" name="TextBox 42"/>
+          <p:cNvSpPr txBox="1"/>
+          <p:nvPr/>
+        </p:nvSpPr>
+        <p:spPr>
+          <a:xfrm>
+            <a:off x="9875520" y="3794759"/>
+            <a:ext cx="1965960" cy="457200"/>
+          </a:xfrm>
+          <a:prstGeom prst="rect">
+            <a:avLst/>
+          </a:prstGeom>
+          <a:noFill/>
+        </p:spPr>
+        <p:txBody>
+          <a:bodyPr wrap="square">
+            <a:spAutoFit/>
+          </a:bodyPr>
+          <a:lstStyle/>
+          <a:p>
+            <a:pPr algn="ctr">
+              <a:defRPr sz="1300" b="1">
+                <a:solidFill>
+                  <a:srgbClr val="475569"/>
+                </a:solidFill>
+              </a:defRPr>
+            </a:pPr>
+            <a:r>
+              <a:t>Smart automation</a:t>
+            </a:r>
+          </a:p>
+        </p:txBody>
+      </p:sp>
+      <p:sp>
+        <p:nvSpPr>
+          <p:cNvPr id="44" name="TextBox 43"/>
+          <p:cNvSpPr txBox="1"/>
+          <p:nvPr/>
+        </p:nvSpPr>
+        <p:spPr>
+          <a:xfrm>
+            <a:off x="9875520" y="4251960"/>
+            <a:ext cx="1965960" cy="1280160"/>
+          </a:xfrm>
+          <a:prstGeom prst="rect">
+            <a:avLst/>
+          </a:prstGeom>
+          <a:noFill/>
+        </p:spPr>
+        <p:txBody>
+          <a:bodyPr wrap="square">
+            <a:spAutoFit/>
+          </a:bodyPr>
+          <a:lstStyle/>
+          <a:p>
+            <a:pPr algn="ctr">
+              <a:defRPr sz="1100">
+                <a:solidFill>
+                  <a:srgbClr val="64748B"/>
+                </a:solidFill>
+              </a:defRPr>
+            </a:pPr>
+            <a:r>
+              <a:t>Document generation, Q&amp;A assistants, intelligent workflows</a:t>
+            </a:r>
+          </a:p>
+        </p:txBody>
+      </p:sp>
+      <p:sp>
+        <p:nvSpPr>
+          <p:cNvPr id="45" name="TextBox 44"/>
+          <p:cNvSpPr txBox="1"/>
+          <p:nvPr/>
+        </p:nvSpPr>
+        <p:spPr>
+          <a:xfrm>
+            <a:off x="457200" y="5943600"/>
+            <a:ext cx="11247120" cy="457200"/>
           </a:xfrm>
           <a:prstGeom prst="rect">
             <a:avLst/>
@@ -7741,92 +8339,22 @@
           </a:bodyPr>
           <a:lstStyle/>
           <a:p>
-            <a:pPr>
-              <a:defRPr sz="1400" b="1">
-                <a:solidFill>
-                  <a:srgbClr val="172A45"/>
-                </a:solidFill>
-              </a:defRPr>
-            </a:pPr>
-            <a:r>
-              <a:t>Connected Data Systems</a:t>
-            </a:r>
-          </a:p>
-        </p:txBody>
-      </p:sp>
-      <p:sp>
-        <p:nvSpPr>
-          <p:cNvPr id="34" name="TextBox 33"/>
-          <p:cNvSpPr txBox="1"/>
-          <p:nvPr/>
-        </p:nvSpPr>
-        <p:spPr>
-          <a:xfrm>
-            <a:off x="8229600" y="3749040"/>
-            <a:ext cx="3383280" cy="914400"/>
-          </a:xfrm>
-          <a:prstGeom prst="rect">
-            <a:avLst/>
-          </a:prstGeom>
-          <a:noFill/>
-        </p:spPr>
-        <p:txBody>
-          <a:bodyPr wrap="square">
-            <a:spAutoFit/>
-          </a:bodyPr>
-          <a:lstStyle/>
-          <a:p>
-            <a:pPr>
-              <a:defRPr sz="1100">
-                <a:solidFill>
-                  <a:srgbClr val="475569"/>
-                </a:solidFill>
-              </a:defRPr>
-            </a:pPr>
-            <a:r>
-              <a:t>Link your spreadsheets, databases, and documents so information flows automatically — no more manual updates</a:t>
-            </a:r>
-          </a:p>
-        </p:txBody>
-      </p:sp>
-      <p:sp>
-        <p:nvSpPr>
-          <p:cNvPr id="35" name="TextBox 34"/>
-          <p:cNvSpPr txBox="1"/>
-          <p:nvPr/>
-        </p:nvSpPr>
-        <p:spPr>
-          <a:xfrm>
-            <a:off x="457200" y="4709160"/>
-            <a:ext cx="11247120" cy="457200"/>
-          </a:xfrm>
-          <a:prstGeom prst="rect">
-            <a:avLst/>
-          </a:prstGeom>
-          <a:noFill/>
-        </p:spPr>
-        <p:txBody>
-          <a:bodyPr wrap="none">
-            <a:spAutoFit/>
-          </a:bodyPr>
-          <a:lstStyle/>
-          <a:p>
             <a:pPr algn="ctr">
-              <a:defRPr sz="1400" i="1">
-                <a:solidFill>
-                  <a:srgbClr val="64748B"/>
-                </a:solidFill>
-              </a:defRPr>
-            </a:pPr>
-            <a:r>
-              <a:t>These are just examples — every solution is tailored to your specific needs</a:t>
-            </a:r>
-          </a:p>
-        </p:txBody>
-      </p:sp>
-      <p:sp>
-        <p:nvSpPr>
-          <p:cNvPr id="36" name="TextBox 35"/>
+              <a:defRPr sz="1600" b="1">
+                <a:solidFill>
+                  <a:srgbClr val="008080"/>
+                </a:solidFill>
+              </a:defRPr>
+            </a:pPr>
+            <a:r>
+              <a:t>Let's look at some real examples →</a:t>
+            </a:r>
+          </a:p>
+        </p:txBody>
+      </p:sp>
+      <p:sp>
+        <p:nvSpPr>
+          <p:cNvPr id="46" name="TextBox 45"/>
           <p:cNvSpPr txBox="1"/>
           <p:nvPr/>
         </p:nvSpPr>

</xml_diff>

<commit_message>
Revamp What We Offer slide with outcome-focused categories
Replaced capability-focused categories with outcome-focused framing:
1. See Your Data Clearly - dashboards, maps, unified views
2. Understand What's Happening - trends, root causes, analysis
3. Predict What's Coming - forecasts, risk flags, scenario modeling
4. Work Smarter with AI - document generation, Q&A from data,
   automation for routine tasks, smart alerts
5. Navigate AI Confidently - ChatGPT guidance, product evaluation,
   research partnerships

New 3-over-2 card layout to accommodate 5 categories.
Expanded AI section beyond just "automate the tedious" to show
full range of intelligent tools.

https://claude.ai/code/session_01DfvAyFmBegVKSBdqRLKP3K
</commit_message>
<xml_diff>
--- a/Enterprise_Analytics_AI_Team.pptx
+++ b/Enterprise_Analytics_AI_Team.pptx
@@ -5625,8 +5625,8 @@
         </p:nvSpPr>
         <p:spPr>
           <a:xfrm>
-            <a:off x="548640" y="1417320"/>
-            <a:ext cx="5546750" cy="2468880"/>
+            <a:off x="457200" y="1371600"/>
+            <a:ext cx="3657600" cy="2286000"/>
           </a:xfrm>
           <a:prstGeom prst="roundRect">
             <a:avLst/>
@@ -5670,8 +5670,8 @@
         </p:nvSpPr>
         <p:spPr>
           <a:xfrm>
-            <a:off x="548640" y="1417320"/>
-            <a:ext cx="137160" cy="2468880"/>
+            <a:off x="457200" y="1371600"/>
+            <a:ext cx="137160" cy="2286000"/>
           </a:xfrm>
           <a:prstGeom prst="rect">
             <a:avLst/>
@@ -5713,8 +5713,8 @@
         </p:nvSpPr>
         <p:spPr>
           <a:xfrm>
-            <a:off x="868680" y="1554480"/>
-            <a:ext cx="5089550" cy="457200"/>
+            <a:off x="777240" y="1508760"/>
+            <a:ext cx="3200400" cy="457200"/>
           </a:xfrm>
           <a:prstGeom prst="rect">
             <a:avLst/>
@@ -5735,7 +5735,7 @@
               </a:defRPr>
             </a:pPr>
             <a:r>
-              <a:t>📊  Data &amp; Dashboards</a:t>
+              <a:t>👁️  See Your Data Clearly</a:t>
             </a:r>
           </a:p>
         </p:txBody>
@@ -5748,8 +5748,8 @@
         </p:nvSpPr>
         <p:spPr>
           <a:xfrm>
-            <a:off x="868680" y="1965960"/>
-            <a:ext cx="5089550" cy="365760"/>
+            <a:off x="777240" y="1920240"/>
+            <a:ext cx="3200400" cy="365760"/>
           </a:xfrm>
           <a:prstGeom prst="rect">
             <a:avLst/>
@@ -5770,7 +5770,7 @@
               </a:defRPr>
             </a:pPr>
             <a:r>
-              <a:t>See what's happening across your projects</a:t>
+              <a:t>From scattered spreadsheets to a single source of truth</a:t>
             </a:r>
           </a:p>
         </p:txBody>
@@ -5783,8 +5783,8 @@
         </p:nvSpPr>
         <p:spPr>
           <a:xfrm>
-            <a:off x="868680" y="2377440"/>
-            <a:ext cx="5089550" cy="1371600"/>
+            <a:off x="777240" y="2331720"/>
+            <a:ext cx="3200400" cy="1371600"/>
           </a:xfrm>
           <a:prstGeom prst="rect">
             <a:avLst/>
@@ -5808,7 +5808,7 @@
               </a:defRPr>
             </a:pPr>
             <a:r>
-              <a:t>• Connect scattered data into one clear view</a:t>
+              <a:t>• Dashboards that show project status at a glance</a:t>
             </a:r>
           </a:p>
           <a:p>
@@ -5823,7 +5823,7 @@
               </a:defRPr>
             </a:pPr>
             <a:r>
-              <a:t>• Build visual dashboards that update automatically</a:t>
+              <a:t>• Maps and visuals that update automatically</a:t>
             </a:r>
           </a:p>
           <a:p>
@@ -5838,22 +5838,7 @@
               </a:defRPr>
             </a:pPr>
             <a:r>
-              <a:t>• Perform deep-dive analysis to spot trends</a:t>
-            </a:r>
-          </a:p>
-          <a:p>
-            <a:pPr>
-              <a:spcAft>
-                <a:spcPts val="300"/>
-              </a:spcAft>
-              <a:defRPr sz="1200">
-                <a:solidFill>
-                  <a:srgbClr val="475569"/>
-                </a:solidFill>
-              </a:defRPr>
-            </a:pPr>
-            <a:r>
-              <a:t>• Support teams that don't have dedicated data staff</a:t>
+              <a:t>• One place to see what's happening across teams</a:t>
             </a:r>
           </a:p>
         </p:txBody>
@@ -5866,8 +5851,8 @@
         </p:nvSpPr>
         <p:spPr>
           <a:xfrm>
-            <a:off x="6323990" y="1417320"/>
-            <a:ext cx="5546750" cy="2468880"/>
+            <a:off x="4297680" y="1371600"/>
+            <a:ext cx="3657600" cy="2286000"/>
           </a:xfrm>
           <a:prstGeom prst="roundRect">
             <a:avLst/>
@@ -5911,8 +5896,8 @@
         </p:nvSpPr>
         <p:spPr>
           <a:xfrm>
-            <a:off x="6323990" y="1417320"/>
-            <a:ext cx="137160" cy="2468880"/>
+            <a:off x="4297680" y="1371600"/>
+            <a:ext cx="137160" cy="2286000"/>
           </a:xfrm>
           <a:prstGeom prst="rect">
             <a:avLst/>
@@ -5954,8 +5939,8 @@
         </p:nvSpPr>
         <p:spPr>
           <a:xfrm>
-            <a:off x="6644030" y="1554480"/>
-            <a:ext cx="5089550" cy="457200"/>
+            <a:off x="4617720" y="1508760"/>
+            <a:ext cx="3200400" cy="457200"/>
           </a:xfrm>
           <a:prstGeom prst="rect">
             <a:avLst/>
@@ -5976,7 +5961,7 @@
               </a:defRPr>
             </a:pPr>
             <a:r>
-              <a:t>🤖  Custom AI Solutions</a:t>
+              <a:t>🔍  Understand What's Happening</a:t>
             </a:r>
           </a:p>
         </p:txBody>
@@ -5989,8 +5974,8 @@
         </p:nvSpPr>
         <p:spPr>
           <a:xfrm>
-            <a:off x="6644030" y="1965960"/>
-            <a:ext cx="5089550" cy="365760"/>
+            <a:off x="4617720" y="1920240"/>
+            <a:ext cx="3200400" cy="365760"/>
           </a:xfrm>
           <a:prstGeom prst="rect">
             <a:avLst/>
@@ -6011,7 +5996,7 @@
               </a:defRPr>
             </a:pPr>
             <a:r>
-              <a:t>Smart tools built for your specific challenges</a:t>
+              <a:t>Turn raw data into answers</a:t>
             </a:r>
           </a:p>
         </p:txBody>
@@ -6024,8 +6009,8 @@
         </p:nvSpPr>
         <p:spPr>
           <a:xfrm>
-            <a:off x="6644030" y="2377440"/>
-            <a:ext cx="5089550" cy="1371600"/>
+            <a:off x="4617720" y="2331720"/>
+            <a:ext cx="3200400" cy="1371600"/>
           </a:xfrm>
           <a:prstGeom prst="rect">
             <a:avLst/>
@@ -6049,7 +6034,7 @@
               </a:defRPr>
             </a:pPr>
             <a:r>
-              <a:t>• Predict outcomes (like permit timelines)</a:t>
+              <a:t>• Spot trends and patterns you'd otherwise miss</a:t>
             </a:r>
           </a:p>
           <a:p>
@@ -6064,7 +6049,7 @@
               </a:defRPr>
             </a:pPr>
             <a:r>
-              <a:t>• Automate repetitive data tasks</a:t>
+              <a:t>• Find root causes when things slow down</a:t>
             </a:r>
           </a:p>
           <a:p>
@@ -6079,22 +6064,7 @@
               </a:defRPr>
             </a:pPr>
             <a:r>
-              <a:t>• Build assistants that answer questions from your data</a:t>
-            </a:r>
-          </a:p>
-          <a:p>
-            <a:pPr>
-              <a:spcAft>
-                <a:spcPts val="300"/>
-              </a:spcAft>
-              <a:defRPr sz="1200">
-                <a:solidFill>
-                  <a:srgbClr val="475569"/>
-                </a:solidFill>
-              </a:defRPr>
-            </a:pPr>
-            <a:r>
-              <a:t>• Create systems that learn and improve over time</a:t>
+              <a:t>• Deep-dive analysis when you need to dig in</a:t>
             </a:r>
           </a:p>
         </p:txBody>
@@ -6107,8 +6077,8 @@
         </p:nvSpPr>
         <p:spPr>
           <a:xfrm>
-            <a:off x="548640" y="4114800"/>
-            <a:ext cx="5546750" cy="2468880"/>
+            <a:off x="8138160" y="1371600"/>
+            <a:ext cx="3657600" cy="2286000"/>
           </a:xfrm>
           <a:prstGeom prst="roundRect">
             <a:avLst/>
@@ -6152,8 +6122,8 @@
         </p:nvSpPr>
         <p:spPr>
           <a:xfrm>
-            <a:off x="548640" y="4114800"/>
-            <a:ext cx="137160" cy="2468880"/>
+            <a:off x="8138160" y="1371600"/>
+            <a:ext cx="137160" cy="2286000"/>
           </a:xfrm>
           <a:prstGeom prst="rect">
             <a:avLst/>
@@ -6195,8 +6165,8 @@
         </p:nvSpPr>
         <p:spPr>
           <a:xfrm>
-            <a:off x="868680" y="4251960"/>
-            <a:ext cx="5089550" cy="457200"/>
+            <a:off x="8458200" y="1508760"/>
+            <a:ext cx="3200400" cy="457200"/>
           </a:xfrm>
           <a:prstGeom prst="rect">
             <a:avLst/>
@@ -6217,7 +6187,7 @@
               </a:defRPr>
             </a:pPr>
             <a:r>
-              <a:t>🔍  AI Tools &amp; Guidance</a:t>
+              <a:t>🔮  Predict What's Coming</a:t>
             </a:r>
           </a:p>
         </p:txBody>
@@ -6230,8 +6200,8 @@
         </p:nvSpPr>
         <p:spPr>
           <a:xfrm>
-            <a:off x="868680" y="4663440"/>
-            <a:ext cx="5089550" cy="365760"/>
+            <a:off x="8458200" y="1920240"/>
+            <a:ext cx="3200400" cy="365760"/>
           </a:xfrm>
           <a:prstGeom prst="rect">
             <a:avLst/>
@@ -6252,7 +6222,7 @@
               </a:defRPr>
             </a:pPr>
             <a:r>
-              <a:t>Navigate the AI landscape safely</a:t>
+              <a:t>See around corners before problems arrive</a:t>
             </a:r>
           </a:p>
         </p:txBody>
@@ -6265,8 +6235,8 @@
         </p:nvSpPr>
         <p:spPr>
           <a:xfrm>
-            <a:off x="868680" y="5074920"/>
-            <a:ext cx="5089550" cy="1371600"/>
+            <a:off x="8458200" y="2331720"/>
+            <a:ext cx="3200400" cy="1371600"/>
           </a:xfrm>
           <a:prstGeom prst="rect">
             <a:avLst/>
@@ -6290,7 +6260,7 @@
               </a:defRPr>
             </a:pPr>
             <a:r>
-              <a:t>• Help you use ChatGPT and similar tools wisely</a:t>
+              <a:t>• Forecast timelines (like permit approvals)</a:t>
             </a:r>
           </a:p>
           <a:p>
@@ -6305,7 +6275,7 @@
               </a:defRPr>
             </a:pPr>
             <a:r>
-              <a:t>• Evaluate which AI products are worth buying</a:t>
+              <a:t>• Flag risks early so you can act</a:t>
             </a:r>
           </a:p>
           <a:p>
@@ -6320,22 +6290,7 @@
               </a:defRPr>
             </a:pPr>
             <a:r>
-              <a:t>• Connect with universities and research partners</a:t>
-            </a:r>
-          </a:p>
-          <a:p>
-            <a:pPr>
-              <a:spcAft>
-                <a:spcPts val="300"/>
-              </a:spcAft>
-              <a:defRPr sz="1200">
-                <a:solidFill>
-                  <a:srgbClr val="475569"/>
-                </a:solidFill>
-              </a:defRPr>
-            </a:pPr>
-            <a:r>
-              <a:t>• Ensure AI is used responsibly and securely</a:t>
+              <a:t>• Model scenarios to plan ahead</a:t>
             </a:r>
           </a:p>
         </p:txBody>
@@ -6348,8 +6303,8 @@
         </p:nvSpPr>
         <p:spPr>
           <a:xfrm>
-            <a:off x="6323990" y="4114800"/>
-            <a:ext cx="5546750" cy="2468880"/>
+            <a:off x="2331720" y="3840480"/>
+            <a:ext cx="3657600" cy="2286000"/>
           </a:xfrm>
           <a:prstGeom prst="roundRect">
             <a:avLst/>
@@ -6393,8 +6348,8 @@
         </p:nvSpPr>
         <p:spPr>
           <a:xfrm>
-            <a:off x="6323990" y="4114800"/>
-            <a:ext cx="137160" cy="2468880"/>
+            <a:off x="2331720" y="3840480"/>
+            <a:ext cx="137160" cy="2286000"/>
           </a:xfrm>
           <a:prstGeom prst="rect">
             <a:avLst/>
@@ -6436,8 +6391,8 @@
         </p:nvSpPr>
         <p:spPr>
           <a:xfrm>
-            <a:off x="6644030" y="4251960"/>
-            <a:ext cx="5089550" cy="457200"/>
+            <a:off x="2651760" y="3977640"/>
+            <a:ext cx="3200400" cy="457200"/>
           </a:xfrm>
           <a:prstGeom prst="rect">
             <a:avLst/>
@@ -6458,7 +6413,7 @@
               </a:defRPr>
             </a:pPr>
             <a:r>
-              <a:t>🤝  Company-Wide Collaboration</a:t>
+              <a:t>🤖  Work Smarter with AI</a:t>
             </a:r>
           </a:p>
         </p:txBody>
@@ -6471,8 +6426,8 @@
         </p:nvSpPr>
         <p:spPr>
           <a:xfrm>
-            <a:off x="6644030" y="4663440"/>
-            <a:ext cx="5089550" cy="365760"/>
+            <a:off x="2651760" y="4389120"/>
+            <a:ext cx="3200400" cy="365760"/>
           </a:xfrm>
           <a:prstGeom prst="rect">
             <a:avLst/>
@@ -6493,7 +6448,7 @@
               </a:defRPr>
             </a:pPr>
             <a:r>
-              <a:t>Connecting data expertise across teams</a:t>
+              <a:t>Intelligent tools that multiply your capacity</a:t>
             </a:r>
           </a:p>
         </p:txBody>
@@ -6506,8 +6461,8 @@
         </p:nvSpPr>
         <p:spPr>
           <a:xfrm>
-            <a:off x="6644030" y="5074920"/>
-            <a:ext cx="5089550" cy="1371600"/>
+            <a:off x="2651760" y="4800600"/>
+            <a:ext cx="3200400" cy="1371600"/>
           </a:xfrm>
           <a:prstGeom prst="rect">
             <a:avLst/>
@@ -6531,7 +6486,7 @@
               </a:defRPr>
             </a:pPr>
             <a:r>
-              <a:t>• Work alongside data professionals in every department</a:t>
+              <a:t>• Generate reports and documents automatically</a:t>
             </a:r>
           </a:p>
           <a:p>
@@ -6546,7 +6501,7 @@
               </a:defRPr>
             </a:pPr>
             <a:r>
-              <a:t>• Share best practices so everyone benefits</a:t>
+              <a:t>• Ask questions and get instant answers from your data</a:t>
             </a:r>
           </a:p>
           <a:p>
@@ -6561,7 +6516,7 @@
               </a:defRPr>
             </a:pPr>
             <a:r>
-              <a:t>• Organize working groups to solve common challenges</a:t>
+              <a:t>• Automate routine tasks so you can focus on judgment calls</a:t>
             </a:r>
           </a:p>
           <a:p>
@@ -6576,14 +6531,240 @@
               </a:defRPr>
             </a:pPr>
             <a:r>
-              <a:t>• Build tools that multiple teams can use</a:t>
-            </a:r>
-          </a:p>
-        </p:txBody>
-      </p:sp>
-      <p:sp>
-        <p:nvSpPr>
-          <p:cNvPr id="25" name="TextBox 24"/>
+              <a:t>• Get smart alerts when something needs your attention</a:t>
+            </a:r>
+          </a:p>
+        </p:txBody>
+      </p:sp>
+      <p:sp>
+        <p:nvSpPr>
+          <p:cNvPr id="25" name="Rounded Rectangle 24"/>
+          <p:cNvSpPr/>
+          <p:nvPr/>
+        </p:nvSpPr>
+        <p:spPr>
+          <a:xfrm>
+            <a:off x="6172200" y="3840480"/>
+            <a:ext cx="3657600" cy="2286000"/>
+          </a:xfrm>
+          <a:prstGeom prst="roundRect">
+            <a:avLst/>
+          </a:prstGeom>
+          <a:solidFill>
+            <a:srgbClr val="FFFFFF"/>
+          </a:solidFill>
+          <a:ln w="25400">
+            <a:solidFill>
+              <a:srgbClr val="CD853F"/>
+            </a:solidFill>
+          </a:ln>
+        </p:spPr>
+        <p:style>
+          <a:lnRef idx="1">
+            <a:schemeClr val="accent1"/>
+          </a:lnRef>
+          <a:fillRef idx="3">
+            <a:schemeClr val="accent1"/>
+          </a:fillRef>
+          <a:effectRef idx="2">
+            <a:schemeClr val="accent1"/>
+          </a:effectRef>
+          <a:fontRef idx="minor">
+            <a:schemeClr val="lt1"/>
+          </a:fontRef>
+        </p:style>
+        <p:txBody>
+          <a:bodyPr rtlCol="0" anchor="ctr"/>
+          <a:lstStyle/>
+          <a:p>
+            <a:pPr algn="ctr"/>
+          </a:p>
+        </p:txBody>
+      </p:sp>
+      <p:sp>
+        <p:nvSpPr>
+          <p:cNvPr id="26" name="Rectangle 25"/>
+          <p:cNvSpPr/>
+          <p:nvPr/>
+        </p:nvSpPr>
+        <p:spPr>
+          <a:xfrm>
+            <a:off x="6172200" y="3840480"/>
+            <a:ext cx="137160" cy="2286000"/>
+          </a:xfrm>
+          <a:prstGeom prst="rect">
+            <a:avLst/>
+          </a:prstGeom>
+          <a:solidFill>
+            <a:srgbClr val="CD853F"/>
+          </a:solidFill>
+          <a:ln>
+            <a:noFill/>
+          </a:ln>
+        </p:spPr>
+        <p:style>
+          <a:lnRef idx="1">
+            <a:schemeClr val="accent1"/>
+          </a:lnRef>
+          <a:fillRef idx="3">
+            <a:schemeClr val="accent1"/>
+          </a:fillRef>
+          <a:effectRef idx="2">
+            <a:schemeClr val="accent1"/>
+          </a:effectRef>
+          <a:fontRef idx="minor">
+            <a:schemeClr val="lt1"/>
+          </a:fontRef>
+        </p:style>
+        <p:txBody>
+          <a:bodyPr rtlCol="0" anchor="ctr"/>
+          <a:lstStyle/>
+          <a:p>
+            <a:pPr algn="ctr"/>
+          </a:p>
+        </p:txBody>
+      </p:sp>
+      <p:sp>
+        <p:nvSpPr>
+          <p:cNvPr id="27" name="TextBox 26"/>
+          <p:cNvSpPr txBox="1"/>
+          <p:nvPr/>
+        </p:nvSpPr>
+        <p:spPr>
+          <a:xfrm>
+            <a:off x="6492240" y="3977640"/>
+            <a:ext cx="3200400" cy="457200"/>
+          </a:xfrm>
+          <a:prstGeom prst="rect">
+            <a:avLst/>
+          </a:prstGeom>
+          <a:noFill/>
+        </p:spPr>
+        <p:txBody>
+          <a:bodyPr wrap="none">
+            <a:spAutoFit/>
+          </a:bodyPr>
+          <a:lstStyle/>
+          <a:p>
+            <a:pPr>
+              <a:defRPr sz="2000" b="1">
+                <a:solidFill>
+                  <a:srgbClr val="CD853F"/>
+                </a:solidFill>
+              </a:defRPr>
+            </a:pPr>
+            <a:r>
+              <a:t>🧭  Navigate AI Confidently</a:t>
+            </a:r>
+          </a:p>
+        </p:txBody>
+      </p:sp>
+      <p:sp>
+        <p:nvSpPr>
+          <p:cNvPr id="28" name="TextBox 27"/>
+          <p:cNvSpPr txBox="1"/>
+          <p:nvPr/>
+        </p:nvSpPr>
+        <p:spPr>
+          <a:xfrm>
+            <a:off x="6492240" y="4389120"/>
+            <a:ext cx="3200400" cy="365760"/>
+          </a:xfrm>
+          <a:prstGeom prst="rect">
+            <a:avLst/>
+          </a:prstGeom>
+          <a:noFill/>
+        </p:spPr>
+        <p:txBody>
+          <a:bodyPr wrap="none">
+            <a:spAutoFit/>
+          </a:bodyPr>
+          <a:lstStyle/>
+          <a:p>
+            <a:pPr>
+              <a:defRPr sz="1300" i="1">
+                <a:solidFill>
+                  <a:srgbClr val="64748B"/>
+                </a:solidFill>
+              </a:defRPr>
+            </a:pPr>
+            <a:r>
+              <a:t>Make smart choices in a fast-moving landscape</a:t>
+            </a:r>
+          </a:p>
+        </p:txBody>
+      </p:sp>
+      <p:sp>
+        <p:nvSpPr>
+          <p:cNvPr id="29" name="TextBox 28"/>
+          <p:cNvSpPr txBox="1"/>
+          <p:nvPr/>
+        </p:nvSpPr>
+        <p:spPr>
+          <a:xfrm>
+            <a:off x="6492240" y="4800600"/>
+            <a:ext cx="3200400" cy="1371600"/>
+          </a:xfrm>
+          <a:prstGeom prst="rect">
+            <a:avLst/>
+          </a:prstGeom>
+          <a:noFill/>
+        </p:spPr>
+        <p:txBody>
+          <a:bodyPr wrap="square">
+            <a:spAutoFit/>
+          </a:bodyPr>
+          <a:lstStyle/>
+          <a:p>
+            <a:pPr>
+              <a:spcAft>
+                <a:spcPts val="300"/>
+              </a:spcAft>
+              <a:defRPr sz="1200">
+                <a:solidFill>
+                  <a:srgbClr val="475569"/>
+                </a:solidFill>
+              </a:defRPr>
+            </a:pPr>
+            <a:r>
+              <a:t>• Guidance on using ChatGPT and similar tools safely</a:t>
+            </a:r>
+          </a:p>
+          <a:p>
+            <a:pPr>
+              <a:spcAft>
+                <a:spcPts val="300"/>
+              </a:spcAft>
+              <a:defRPr sz="1200">
+                <a:solidFill>
+                  <a:srgbClr val="475569"/>
+                </a:solidFill>
+              </a:defRPr>
+            </a:pPr>
+            <a:r>
+              <a:t>• Evaluate which AI products are actually worth it</a:t>
+            </a:r>
+          </a:p>
+          <a:p>
+            <a:pPr>
+              <a:spcAft>
+                <a:spcPts val="300"/>
+              </a:spcAft>
+              <a:defRPr sz="1200">
+                <a:solidFill>
+                  <a:srgbClr val="475569"/>
+                </a:solidFill>
+              </a:defRPr>
+            </a:pPr>
+            <a:r>
+              <a:t>• Stay ahead with university and industry connections</a:t>
+            </a:r>
+          </a:p>
+        </p:txBody>
+      </p:sp>
+      <p:sp>
+        <p:nvSpPr>
+          <p:cNvPr id="30" name="TextBox 29"/>
           <p:cNvSpPr txBox="1"/>
           <p:nvPr/>
         </p:nvSpPr>

</xml_diff>

<commit_message>
Restructure slides 4-5: separate deliverables from enablement
Slide 4 - "What We Build" (core consulting deliverables):
- Visibility: dashboards, maps, unified views
- Understanding: trends, root causes, analysis
- Foresight: forecasts, risk flags, scenarios
- Intelligent Tools: auto-generation, Q&A, smart alerts
Shows progression with arrows, clean 4-card horizontal layout

Slide 5 - "Beyond Project Work" (enablement services):
- AI Guidance: ChatGPT help, product evaluation
- Training & Skills: workshops, office hours
- External Partnerships: universities, labs, industry
- Cross-Company Collaboration: best practices, shared tools
- Communities of Practice: user groups, working sessions
Note: "These services are available to everyone — no project required"

Eliminates redundancy between previous slides 4 and 5.

https://claude.ai/code/session_01DfvAyFmBegVKSBdqRLKP3K
</commit_message>
<xml_diff>
--- a/Enterprise_Analytics_AI_Team.pptx
+++ b/Enterprise_Analytics_AI_Team.pptx
@@ -5612,21 +5612,56 @@
               </a:defRPr>
             </a:pPr>
             <a:r>
-              <a:t>What We Offer</a:t>
-            </a:r>
-          </a:p>
-        </p:txBody>
-      </p:sp>
-      <p:sp>
-        <p:nvSpPr>
-          <p:cNvPr id="5" name="Rounded Rectangle 4"/>
+              <a:t>What We Build</a:t>
+            </a:r>
+          </a:p>
+        </p:txBody>
+      </p:sp>
+      <p:sp>
+        <p:nvSpPr>
+          <p:cNvPr id="5" name="TextBox 4"/>
+          <p:cNvSpPr txBox="1"/>
+          <p:nvPr/>
+        </p:nvSpPr>
+        <p:spPr>
+          <a:xfrm>
+            <a:off x="731520" y="1325880"/>
+            <a:ext cx="10515600" cy="457200"/>
+          </a:xfrm>
+          <a:prstGeom prst="rect">
+            <a:avLst/>
+          </a:prstGeom>
+          <a:noFill/>
+        </p:spPr>
+        <p:txBody>
+          <a:bodyPr wrap="none">
+            <a:spAutoFit/>
+          </a:bodyPr>
+          <a:lstStyle/>
+          <a:p>
+            <a:pPr>
+              <a:defRPr sz="1600">
+                <a:solidFill>
+                  <a:srgbClr val="64748B"/>
+                </a:solidFill>
+              </a:defRPr>
+            </a:pPr>
+            <a:r>
+              <a:t>When you work with us, here's what you can expect to get</a:t>
+            </a:r>
+          </a:p>
+        </p:txBody>
+      </p:sp>
+      <p:sp>
+        <p:nvSpPr>
+          <p:cNvPr id="6" name="Rounded Rectangle 5"/>
           <p:cNvSpPr/>
           <p:nvPr/>
         </p:nvSpPr>
         <p:spPr>
           <a:xfrm>
-            <a:off x="457200" y="1371600"/>
-            <a:ext cx="3657600" cy="2286000"/>
+            <a:off x="411480" y="1828800"/>
+            <a:ext cx="2743200" cy="3657600"/>
           </a:xfrm>
           <a:prstGeom prst="roundRect">
             <a:avLst/>
@@ -5664,14 +5699,14 @@
       </p:sp>
       <p:sp>
         <p:nvSpPr>
-          <p:cNvPr id="6" name="Rectangle 5"/>
+          <p:cNvPr id="7" name="Rectangle 6"/>
           <p:cNvSpPr/>
           <p:nvPr/>
         </p:nvSpPr>
         <p:spPr>
           <a:xfrm>
-            <a:off x="457200" y="1371600"/>
-            <a:ext cx="137160" cy="2286000"/>
+            <a:off x="411480" y="1828800"/>
+            <a:ext cx="2743200" cy="109728"/>
           </a:xfrm>
           <a:prstGeom prst="rect">
             <a:avLst/>
@@ -5707,14 +5742,57 @@
       </p:sp>
       <p:sp>
         <p:nvSpPr>
-          <p:cNvPr id="7" name="TextBox 6"/>
+          <p:cNvPr id="8" name="Oval 7"/>
+          <p:cNvSpPr/>
+          <p:nvPr/>
+        </p:nvSpPr>
+        <p:spPr>
+          <a:xfrm>
+            <a:off x="1417320" y="2103120"/>
+            <a:ext cx="731520" cy="731520"/>
+          </a:xfrm>
+          <a:prstGeom prst="ellipse">
+            <a:avLst/>
+          </a:prstGeom>
+          <a:solidFill>
+            <a:srgbClr val="4682B4"/>
+          </a:solidFill>
+          <a:ln>
+            <a:noFill/>
+          </a:ln>
+        </p:spPr>
+        <p:style>
+          <a:lnRef idx="1">
+            <a:schemeClr val="accent1"/>
+          </a:lnRef>
+          <a:fillRef idx="3">
+            <a:schemeClr val="accent1"/>
+          </a:fillRef>
+          <a:effectRef idx="2">
+            <a:schemeClr val="accent1"/>
+          </a:effectRef>
+          <a:fontRef idx="minor">
+            <a:schemeClr val="lt1"/>
+          </a:fontRef>
+        </p:style>
+        <p:txBody>
+          <a:bodyPr rtlCol="0" anchor="ctr"/>
+          <a:lstStyle/>
+          <a:p>
+            <a:pPr algn="ctr"/>
+          </a:p>
+        </p:txBody>
+      </p:sp>
+      <p:sp>
+        <p:nvSpPr>
+          <p:cNvPr id="9" name="TextBox 8"/>
           <p:cNvSpPr txBox="1"/>
           <p:nvPr/>
         </p:nvSpPr>
         <p:spPr>
           <a:xfrm>
-            <a:off x="777240" y="1508760"/>
-            <a:ext cx="3200400" cy="457200"/>
+            <a:off x="1463040" y="2194560"/>
+            <a:ext cx="640080" cy="548640"/>
           </a:xfrm>
           <a:prstGeom prst="rect">
             <a:avLst/>
@@ -5727,29 +5805,25 @@
           </a:bodyPr>
           <a:lstStyle/>
           <a:p>
-            <a:pPr>
-              <a:defRPr sz="2000" b="1">
-                <a:solidFill>
-                  <a:srgbClr val="4682B4"/>
-                </a:solidFill>
-              </a:defRPr>
+            <a:pPr algn="ctr">
+              <a:defRPr sz="2800"/>
             </a:pPr>
             <a:r>
-              <a:t>👁️  See Your Data Clearly</a:t>
-            </a:r>
-          </a:p>
-        </p:txBody>
-      </p:sp>
-      <p:sp>
-        <p:nvSpPr>
-          <p:cNvPr id="8" name="TextBox 7"/>
+              <a:t>👁️</a:t>
+            </a:r>
+          </a:p>
+        </p:txBody>
+      </p:sp>
+      <p:sp>
+        <p:nvSpPr>
+          <p:cNvPr id="10" name="TextBox 9"/>
           <p:cNvSpPr txBox="1"/>
           <p:nvPr/>
         </p:nvSpPr>
         <p:spPr>
           <a:xfrm>
-            <a:off x="777240" y="1920240"/>
-            <a:ext cx="3200400" cy="365760"/>
+            <a:off x="502920" y="2926080"/>
+            <a:ext cx="2560320" cy="457200"/>
           </a:xfrm>
           <a:prstGeom prst="rect">
             <a:avLst/>
@@ -5762,29 +5836,64 @@
           </a:bodyPr>
           <a:lstStyle/>
           <a:p>
-            <a:pPr>
-              <a:defRPr sz="1300" i="1">
+            <a:pPr algn="ctr">
+              <a:defRPr sz="1800" b="1">
+                <a:solidFill>
+                  <a:srgbClr val="4682B4"/>
+                </a:solidFill>
+              </a:defRPr>
+            </a:pPr>
+            <a:r>
+              <a:t>Visibility</a:t>
+            </a:r>
+          </a:p>
+        </p:txBody>
+      </p:sp>
+      <p:sp>
+        <p:nvSpPr>
+          <p:cNvPr id="11" name="TextBox 10"/>
+          <p:cNvSpPr txBox="1"/>
+          <p:nvPr/>
+        </p:nvSpPr>
+        <p:spPr>
+          <a:xfrm>
+            <a:off x="502920" y="3337560"/>
+            <a:ext cx="2560320" cy="365760"/>
+          </a:xfrm>
+          <a:prstGeom prst="rect">
+            <a:avLst/>
+          </a:prstGeom>
+          <a:noFill/>
+        </p:spPr>
+        <p:txBody>
+          <a:bodyPr wrap="none">
+            <a:spAutoFit/>
+          </a:bodyPr>
+          <a:lstStyle/>
+          <a:p>
+            <a:pPr algn="ctr">
+              <a:defRPr sz="1200" i="1">
                 <a:solidFill>
                   <a:srgbClr val="64748B"/>
                 </a:solidFill>
               </a:defRPr>
             </a:pPr>
             <a:r>
-              <a:t>From scattered spreadsheets to a single source of truth</a:t>
-            </a:r>
-          </a:p>
-        </p:txBody>
-      </p:sp>
-      <p:sp>
-        <p:nvSpPr>
-          <p:cNvPr id="9" name="TextBox 8"/>
+              <a:t>See your data clearly</a:t>
+            </a:r>
+          </a:p>
+        </p:txBody>
+      </p:sp>
+      <p:sp>
+        <p:nvSpPr>
+          <p:cNvPr id="12" name="TextBox 11"/>
           <p:cNvSpPr txBox="1"/>
           <p:nvPr/>
         </p:nvSpPr>
         <p:spPr>
           <a:xfrm>
-            <a:off x="777240" y="2331720"/>
-            <a:ext cx="3200400" cy="1371600"/>
+            <a:off x="548640" y="3749040"/>
+            <a:ext cx="2468880" cy="1554480"/>
           </a:xfrm>
           <a:prstGeom prst="rect">
             <a:avLst/>
@@ -5799,24 +5908,24 @@
           <a:p>
             <a:pPr>
               <a:spcAft>
-                <a:spcPts val="300"/>
+                <a:spcPts val="400"/>
               </a:spcAft>
-              <a:defRPr sz="1200">
+              <a:defRPr sz="1100">
                 <a:solidFill>
                   <a:srgbClr val="475569"/>
                 </a:solidFill>
               </a:defRPr>
             </a:pPr>
             <a:r>
-              <a:t>• Dashboards that show project status at a glance</a:t>
+              <a:t>• Dashboards showing status at a glance</a:t>
             </a:r>
           </a:p>
           <a:p>
             <a:pPr>
               <a:spcAft>
-                <a:spcPts val="300"/>
+                <a:spcPts val="400"/>
               </a:spcAft>
-              <a:defRPr sz="1200">
+              <a:defRPr sz="1100">
                 <a:solidFill>
                   <a:srgbClr val="475569"/>
                 </a:solidFill>
@@ -5829,30 +5938,73 @@
           <a:p>
             <a:pPr>
               <a:spcAft>
-                <a:spcPts val="300"/>
+                <a:spcPts val="400"/>
               </a:spcAft>
-              <a:defRPr sz="1200">
+              <a:defRPr sz="1100">
                 <a:solidFill>
                   <a:srgbClr val="475569"/>
                 </a:solidFill>
               </a:defRPr>
             </a:pPr>
             <a:r>
-              <a:t>• One place to see what's happening across teams</a:t>
-            </a:r>
-          </a:p>
-        </p:txBody>
-      </p:sp>
-      <p:sp>
-        <p:nvSpPr>
-          <p:cNvPr id="10" name="Rounded Rectangle 9"/>
+              <a:t>• One place to see across teams</a:t>
+            </a:r>
+          </a:p>
+        </p:txBody>
+      </p:sp>
+      <p:sp>
+        <p:nvSpPr>
+          <p:cNvPr id="13" name="Right Arrow 12"/>
           <p:cNvSpPr/>
           <p:nvPr/>
         </p:nvSpPr>
         <p:spPr>
           <a:xfrm>
-            <a:off x="4297680" y="1371600"/>
-            <a:ext cx="3657600" cy="2286000"/>
+            <a:off x="3182112" y="2331720"/>
+            <a:ext cx="128016" cy="201168"/>
+          </a:xfrm>
+          <a:prstGeom prst="rightArrow">
+            <a:avLst/>
+          </a:prstGeom>
+          <a:solidFill>
+            <a:srgbClr val="C8D2DC"/>
+          </a:solidFill>
+          <a:ln>
+            <a:noFill/>
+          </a:ln>
+        </p:spPr>
+        <p:style>
+          <a:lnRef idx="1">
+            <a:schemeClr val="accent1"/>
+          </a:lnRef>
+          <a:fillRef idx="3">
+            <a:schemeClr val="accent1"/>
+          </a:fillRef>
+          <a:effectRef idx="2">
+            <a:schemeClr val="accent1"/>
+          </a:effectRef>
+          <a:fontRef idx="minor">
+            <a:schemeClr val="lt1"/>
+          </a:fontRef>
+        </p:style>
+        <p:txBody>
+          <a:bodyPr rtlCol="0" anchor="ctr"/>
+          <a:lstStyle/>
+          <a:p>
+            <a:pPr algn="ctr"/>
+          </a:p>
+        </p:txBody>
+      </p:sp>
+      <p:sp>
+        <p:nvSpPr>
+          <p:cNvPr id="14" name="Rounded Rectangle 13"/>
+          <p:cNvSpPr/>
+          <p:nvPr/>
+        </p:nvSpPr>
+        <p:spPr>
+          <a:xfrm>
+            <a:off x="3337560" y="1828800"/>
+            <a:ext cx="2743200" cy="3657600"/>
           </a:xfrm>
           <a:prstGeom prst="roundRect">
             <a:avLst/>
@@ -5890,14 +6042,14 @@
       </p:sp>
       <p:sp>
         <p:nvSpPr>
-          <p:cNvPr id="11" name="Rectangle 10"/>
+          <p:cNvPr id="15" name="Rectangle 14"/>
           <p:cNvSpPr/>
           <p:nvPr/>
         </p:nvSpPr>
         <p:spPr>
           <a:xfrm>
-            <a:off x="4297680" y="1371600"/>
-            <a:ext cx="137160" cy="2286000"/>
+            <a:off x="3337560" y="1828800"/>
+            <a:ext cx="2743200" cy="109728"/>
           </a:xfrm>
           <a:prstGeom prst="rect">
             <a:avLst/>
@@ -5933,14 +6085,57 @@
       </p:sp>
       <p:sp>
         <p:nvSpPr>
-          <p:cNvPr id="12" name="TextBox 11"/>
+          <p:cNvPr id="16" name="Oval 15"/>
+          <p:cNvSpPr/>
+          <p:nvPr/>
+        </p:nvSpPr>
+        <p:spPr>
+          <a:xfrm>
+            <a:off x="4343400" y="2103120"/>
+            <a:ext cx="731520" cy="731520"/>
+          </a:xfrm>
+          <a:prstGeom prst="ellipse">
+            <a:avLst/>
+          </a:prstGeom>
+          <a:solidFill>
+            <a:srgbClr val="008080"/>
+          </a:solidFill>
+          <a:ln>
+            <a:noFill/>
+          </a:ln>
+        </p:spPr>
+        <p:style>
+          <a:lnRef idx="1">
+            <a:schemeClr val="accent1"/>
+          </a:lnRef>
+          <a:fillRef idx="3">
+            <a:schemeClr val="accent1"/>
+          </a:fillRef>
+          <a:effectRef idx="2">
+            <a:schemeClr val="accent1"/>
+          </a:effectRef>
+          <a:fontRef idx="minor">
+            <a:schemeClr val="lt1"/>
+          </a:fontRef>
+        </p:style>
+        <p:txBody>
+          <a:bodyPr rtlCol="0" anchor="ctr"/>
+          <a:lstStyle/>
+          <a:p>
+            <a:pPr algn="ctr"/>
+          </a:p>
+        </p:txBody>
+      </p:sp>
+      <p:sp>
+        <p:nvSpPr>
+          <p:cNvPr id="17" name="TextBox 16"/>
           <p:cNvSpPr txBox="1"/>
           <p:nvPr/>
         </p:nvSpPr>
         <p:spPr>
           <a:xfrm>
-            <a:off x="4617720" y="1508760"/>
-            <a:ext cx="3200400" cy="457200"/>
+            <a:off x="4389120" y="2194560"/>
+            <a:ext cx="640080" cy="548640"/>
           </a:xfrm>
           <a:prstGeom prst="rect">
             <a:avLst/>
@@ -5953,29 +6148,25 @@
           </a:bodyPr>
           <a:lstStyle/>
           <a:p>
-            <a:pPr>
-              <a:defRPr sz="2000" b="1">
-                <a:solidFill>
-                  <a:srgbClr val="008080"/>
-                </a:solidFill>
-              </a:defRPr>
+            <a:pPr algn="ctr">
+              <a:defRPr sz="2800"/>
             </a:pPr>
             <a:r>
-              <a:t>🔍  Understand What's Happening</a:t>
-            </a:r>
-          </a:p>
-        </p:txBody>
-      </p:sp>
-      <p:sp>
-        <p:nvSpPr>
-          <p:cNvPr id="13" name="TextBox 12"/>
+              <a:t>🔍</a:t>
+            </a:r>
+          </a:p>
+        </p:txBody>
+      </p:sp>
+      <p:sp>
+        <p:nvSpPr>
+          <p:cNvPr id="18" name="TextBox 17"/>
           <p:cNvSpPr txBox="1"/>
           <p:nvPr/>
         </p:nvSpPr>
         <p:spPr>
           <a:xfrm>
-            <a:off x="4617720" y="1920240"/>
-            <a:ext cx="3200400" cy="365760"/>
+            <a:off x="3429000" y="2926080"/>
+            <a:ext cx="2560320" cy="457200"/>
           </a:xfrm>
           <a:prstGeom prst="rect">
             <a:avLst/>
@@ -5988,29 +6179,64 @@
           </a:bodyPr>
           <a:lstStyle/>
           <a:p>
-            <a:pPr>
-              <a:defRPr sz="1300" i="1">
+            <a:pPr algn="ctr">
+              <a:defRPr sz="1800" b="1">
+                <a:solidFill>
+                  <a:srgbClr val="008080"/>
+                </a:solidFill>
+              </a:defRPr>
+            </a:pPr>
+            <a:r>
+              <a:t>Understanding</a:t>
+            </a:r>
+          </a:p>
+        </p:txBody>
+      </p:sp>
+      <p:sp>
+        <p:nvSpPr>
+          <p:cNvPr id="19" name="TextBox 18"/>
+          <p:cNvSpPr txBox="1"/>
+          <p:nvPr/>
+        </p:nvSpPr>
+        <p:spPr>
+          <a:xfrm>
+            <a:off x="3429000" y="3337560"/>
+            <a:ext cx="2560320" cy="365760"/>
+          </a:xfrm>
+          <a:prstGeom prst="rect">
+            <a:avLst/>
+          </a:prstGeom>
+          <a:noFill/>
+        </p:spPr>
+        <p:txBody>
+          <a:bodyPr wrap="none">
+            <a:spAutoFit/>
+          </a:bodyPr>
+          <a:lstStyle/>
+          <a:p>
+            <a:pPr algn="ctr">
+              <a:defRPr sz="1200" i="1">
                 <a:solidFill>
                   <a:srgbClr val="64748B"/>
                 </a:solidFill>
               </a:defRPr>
             </a:pPr>
             <a:r>
-              <a:t>Turn raw data into answers</a:t>
-            </a:r>
-          </a:p>
-        </p:txBody>
-      </p:sp>
-      <p:sp>
-        <p:nvSpPr>
-          <p:cNvPr id="14" name="TextBox 13"/>
+              <a:t>Know what's really happening</a:t>
+            </a:r>
+          </a:p>
+        </p:txBody>
+      </p:sp>
+      <p:sp>
+        <p:nvSpPr>
+          <p:cNvPr id="20" name="TextBox 19"/>
           <p:cNvSpPr txBox="1"/>
           <p:nvPr/>
         </p:nvSpPr>
         <p:spPr>
           <a:xfrm>
-            <a:off x="4617720" y="2331720"/>
-            <a:ext cx="3200400" cy="1371600"/>
+            <a:off x="3474720" y="3749040"/>
+            <a:ext cx="2468880" cy="1554480"/>
           </a:xfrm>
           <a:prstGeom prst="rect">
             <a:avLst/>
@@ -6025,24 +6251,24 @@
           <a:p>
             <a:pPr>
               <a:spcAft>
-                <a:spcPts val="300"/>
+                <a:spcPts val="400"/>
               </a:spcAft>
-              <a:defRPr sz="1200">
+              <a:defRPr sz="1100">
                 <a:solidFill>
                   <a:srgbClr val="475569"/>
                 </a:solidFill>
               </a:defRPr>
             </a:pPr>
             <a:r>
-              <a:t>• Spot trends and patterns you'd otherwise miss</a:t>
+              <a:t>• Spot trends you'd otherwise miss</a:t>
             </a:r>
           </a:p>
           <a:p>
             <a:pPr>
               <a:spcAft>
-                <a:spcPts val="300"/>
+                <a:spcPts val="400"/>
               </a:spcAft>
-              <a:defRPr sz="1200">
+              <a:defRPr sz="1100">
                 <a:solidFill>
                   <a:srgbClr val="475569"/>
                 </a:solidFill>
@@ -6055,30 +6281,73 @@
           <a:p>
             <a:pPr>
               <a:spcAft>
-                <a:spcPts val="300"/>
+                <a:spcPts val="400"/>
               </a:spcAft>
-              <a:defRPr sz="1200">
+              <a:defRPr sz="1100">
                 <a:solidFill>
                   <a:srgbClr val="475569"/>
                 </a:solidFill>
               </a:defRPr>
             </a:pPr>
             <a:r>
-              <a:t>• Deep-dive analysis when you need to dig in</a:t>
-            </a:r>
-          </a:p>
-        </p:txBody>
-      </p:sp>
-      <p:sp>
-        <p:nvSpPr>
-          <p:cNvPr id="15" name="Rounded Rectangle 14"/>
+              <a:t>• Analysis that answers your questions</a:t>
+            </a:r>
+          </a:p>
+        </p:txBody>
+      </p:sp>
+      <p:sp>
+        <p:nvSpPr>
+          <p:cNvPr id="21" name="Right Arrow 20"/>
           <p:cNvSpPr/>
           <p:nvPr/>
         </p:nvSpPr>
         <p:spPr>
           <a:xfrm>
-            <a:off x="8138160" y="1371600"/>
-            <a:ext cx="3657600" cy="2286000"/>
+            <a:off x="6108192" y="2331720"/>
+            <a:ext cx="128016" cy="201168"/>
+          </a:xfrm>
+          <a:prstGeom prst="rightArrow">
+            <a:avLst/>
+          </a:prstGeom>
+          <a:solidFill>
+            <a:srgbClr val="C8D2DC"/>
+          </a:solidFill>
+          <a:ln>
+            <a:noFill/>
+          </a:ln>
+        </p:spPr>
+        <p:style>
+          <a:lnRef idx="1">
+            <a:schemeClr val="accent1"/>
+          </a:lnRef>
+          <a:fillRef idx="3">
+            <a:schemeClr val="accent1"/>
+          </a:fillRef>
+          <a:effectRef idx="2">
+            <a:schemeClr val="accent1"/>
+          </a:effectRef>
+          <a:fontRef idx="minor">
+            <a:schemeClr val="lt1"/>
+          </a:fontRef>
+        </p:style>
+        <p:txBody>
+          <a:bodyPr rtlCol="0" anchor="ctr"/>
+          <a:lstStyle/>
+          <a:p>
+            <a:pPr algn="ctr"/>
+          </a:p>
+        </p:txBody>
+      </p:sp>
+      <p:sp>
+        <p:nvSpPr>
+          <p:cNvPr id="22" name="Rounded Rectangle 21"/>
+          <p:cNvSpPr/>
+          <p:nvPr/>
+        </p:nvSpPr>
+        <p:spPr>
+          <a:xfrm>
+            <a:off x="6263640" y="1828800"/>
+            <a:ext cx="2743200" cy="3657600"/>
           </a:xfrm>
           <a:prstGeom prst="roundRect">
             <a:avLst/>
@@ -6116,14 +6385,14 @@
       </p:sp>
       <p:sp>
         <p:nvSpPr>
-          <p:cNvPr id="16" name="Rectangle 15"/>
+          <p:cNvPr id="23" name="Rectangle 22"/>
           <p:cNvSpPr/>
           <p:nvPr/>
         </p:nvSpPr>
         <p:spPr>
           <a:xfrm>
-            <a:off x="8138160" y="1371600"/>
-            <a:ext cx="137160" cy="2286000"/>
+            <a:off x="6263640" y="1828800"/>
+            <a:ext cx="2743200" cy="109728"/>
           </a:xfrm>
           <a:prstGeom prst="rect">
             <a:avLst/>
@@ -6159,14 +6428,57 @@
       </p:sp>
       <p:sp>
         <p:nvSpPr>
-          <p:cNvPr id="17" name="TextBox 16"/>
+          <p:cNvPr id="24" name="Oval 23"/>
+          <p:cNvSpPr/>
+          <p:nvPr/>
+        </p:nvSpPr>
+        <p:spPr>
+          <a:xfrm>
+            <a:off x="7269480" y="2103120"/>
+            <a:ext cx="731520" cy="731520"/>
+          </a:xfrm>
+          <a:prstGeom prst="ellipse">
+            <a:avLst/>
+          </a:prstGeom>
+          <a:solidFill>
+            <a:srgbClr val="558B6E"/>
+          </a:solidFill>
+          <a:ln>
+            <a:noFill/>
+          </a:ln>
+        </p:spPr>
+        <p:style>
+          <a:lnRef idx="1">
+            <a:schemeClr val="accent1"/>
+          </a:lnRef>
+          <a:fillRef idx="3">
+            <a:schemeClr val="accent1"/>
+          </a:fillRef>
+          <a:effectRef idx="2">
+            <a:schemeClr val="accent1"/>
+          </a:effectRef>
+          <a:fontRef idx="minor">
+            <a:schemeClr val="lt1"/>
+          </a:fontRef>
+        </p:style>
+        <p:txBody>
+          <a:bodyPr rtlCol="0" anchor="ctr"/>
+          <a:lstStyle/>
+          <a:p>
+            <a:pPr algn="ctr"/>
+          </a:p>
+        </p:txBody>
+      </p:sp>
+      <p:sp>
+        <p:nvSpPr>
+          <p:cNvPr id="25" name="TextBox 24"/>
           <p:cNvSpPr txBox="1"/>
           <p:nvPr/>
         </p:nvSpPr>
         <p:spPr>
           <a:xfrm>
-            <a:off x="8458200" y="1508760"/>
-            <a:ext cx="3200400" cy="457200"/>
+            <a:off x="7315200" y="2194560"/>
+            <a:ext cx="640080" cy="548640"/>
           </a:xfrm>
           <a:prstGeom prst="rect">
             <a:avLst/>
@@ -6179,29 +6491,25 @@
           </a:bodyPr>
           <a:lstStyle/>
           <a:p>
-            <a:pPr>
-              <a:defRPr sz="2000" b="1">
-                <a:solidFill>
-                  <a:srgbClr val="558B6E"/>
-                </a:solidFill>
-              </a:defRPr>
+            <a:pPr algn="ctr">
+              <a:defRPr sz="2800"/>
             </a:pPr>
             <a:r>
-              <a:t>🔮  Predict What's Coming</a:t>
-            </a:r>
-          </a:p>
-        </p:txBody>
-      </p:sp>
-      <p:sp>
-        <p:nvSpPr>
-          <p:cNvPr id="18" name="TextBox 17"/>
+              <a:t>🔮</a:t>
+            </a:r>
+          </a:p>
+        </p:txBody>
+      </p:sp>
+      <p:sp>
+        <p:nvSpPr>
+          <p:cNvPr id="26" name="TextBox 25"/>
           <p:cNvSpPr txBox="1"/>
           <p:nvPr/>
         </p:nvSpPr>
         <p:spPr>
           <a:xfrm>
-            <a:off x="8458200" y="1920240"/>
-            <a:ext cx="3200400" cy="365760"/>
+            <a:off x="6355080" y="2926080"/>
+            <a:ext cx="2560320" cy="457200"/>
           </a:xfrm>
           <a:prstGeom prst="rect">
             <a:avLst/>
@@ -6214,29 +6522,64 @@
           </a:bodyPr>
           <a:lstStyle/>
           <a:p>
-            <a:pPr>
-              <a:defRPr sz="1300" i="1">
+            <a:pPr algn="ctr">
+              <a:defRPr sz="1800" b="1">
+                <a:solidFill>
+                  <a:srgbClr val="558B6E"/>
+                </a:solidFill>
+              </a:defRPr>
+            </a:pPr>
+            <a:r>
+              <a:t>Foresight</a:t>
+            </a:r>
+          </a:p>
+        </p:txBody>
+      </p:sp>
+      <p:sp>
+        <p:nvSpPr>
+          <p:cNvPr id="27" name="TextBox 26"/>
+          <p:cNvSpPr txBox="1"/>
+          <p:nvPr/>
+        </p:nvSpPr>
+        <p:spPr>
+          <a:xfrm>
+            <a:off x="6355080" y="3337560"/>
+            <a:ext cx="2560320" cy="365760"/>
+          </a:xfrm>
+          <a:prstGeom prst="rect">
+            <a:avLst/>
+          </a:prstGeom>
+          <a:noFill/>
+        </p:spPr>
+        <p:txBody>
+          <a:bodyPr wrap="none">
+            <a:spAutoFit/>
+          </a:bodyPr>
+          <a:lstStyle/>
+          <a:p>
+            <a:pPr algn="ctr">
+              <a:defRPr sz="1200" i="1">
                 <a:solidFill>
                   <a:srgbClr val="64748B"/>
                 </a:solidFill>
               </a:defRPr>
             </a:pPr>
             <a:r>
-              <a:t>See around corners before problems arrive</a:t>
-            </a:r>
-          </a:p>
-        </p:txBody>
-      </p:sp>
-      <p:sp>
-        <p:nvSpPr>
-          <p:cNvPr id="19" name="TextBox 18"/>
+              <a:t>See what's coming</a:t>
+            </a:r>
+          </a:p>
+        </p:txBody>
+      </p:sp>
+      <p:sp>
+        <p:nvSpPr>
+          <p:cNvPr id="28" name="TextBox 27"/>
           <p:cNvSpPr txBox="1"/>
           <p:nvPr/>
         </p:nvSpPr>
         <p:spPr>
           <a:xfrm>
-            <a:off x="8458200" y="2331720"/>
-            <a:ext cx="3200400" cy="1371600"/>
+            <a:off x="6400800" y="3749040"/>
+            <a:ext cx="2468880" cy="1554480"/>
           </a:xfrm>
           <a:prstGeom prst="rect">
             <a:avLst/>
@@ -6251,39 +6594,39 @@
           <a:p>
             <a:pPr>
               <a:spcAft>
-                <a:spcPts val="300"/>
+                <a:spcPts val="400"/>
               </a:spcAft>
-              <a:defRPr sz="1200">
+              <a:defRPr sz="1100">
                 <a:solidFill>
                   <a:srgbClr val="475569"/>
                 </a:solidFill>
               </a:defRPr>
             </a:pPr>
             <a:r>
-              <a:t>• Forecast timelines (like permit approvals)</a:t>
+              <a:t>• Forecast timelines and outcomes</a:t>
             </a:r>
           </a:p>
           <a:p>
             <a:pPr>
               <a:spcAft>
-                <a:spcPts val="300"/>
+                <a:spcPts val="400"/>
               </a:spcAft>
-              <a:defRPr sz="1200">
+              <a:defRPr sz="1100">
                 <a:solidFill>
                   <a:srgbClr val="475569"/>
                 </a:solidFill>
               </a:defRPr>
             </a:pPr>
             <a:r>
-              <a:t>• Flag risks early so you can act</a:t>
+              <a:t>• Flag risks before they become problems</a:t>
             </a:r>
           </a:p>
           <a:p>
             <a:pPr>
               <a:spcAft>
-                <a:spcPts val="300"/>
+                <a:spcPts val="400"/>
               </a:spcAft>
-              <a:defRPr sz="1200">
+              <a:defRPr sz="1100">
                 <a:solidFill>
                   <a:srgbClr val="475569"/>
                 </a:solidFill>
@@ -6297,14 +6640,57 @@
       </p:sp>
       <p:sp>
         <p:nvSpPr>
-          <p:cNvPr id="20" name="Rounded Rectangle 19"/>
+          <p:cNvPr id="29" name="Right Arrow 28"/>
           <p:cNvSpPr/>
           <p:nvPr/>
         </p:nvSpPr>
         <p:spPr>
           <a:xfrm>
-            <a:off x="2331720" y="3840480"/>
-            <a:ext cx="3657600" cy="2286000"/>
+            <a:off x="9034272" y="2331720"/>
+            <a:ext cx="128016" cy="201168"/>
+          </a:xfrm>
+          <a:prstGeom prst="rightArrow">
+            <a:avLst/>
+          </a:prstGeom>
+          <a:solidFill>
+            <a:srgbClr val="C8D2DC"/>
+          </a:solidFill>
+          <a:ln>
+            <a:noFill/>
+          </a:ln>
+        </p:spPr>
+        <p:style>
+          <a:lnRef idx="1">
+            <a:schemeClr val="accent1"/>
+          </a:lnRef>
+          <a:fillRef idx="3">
+            <a:schemeClr val="accent1"/>
+          </a:fillRef>
+          <a:effectRef idx="2">
+            <a:schemeClr val="accent1"/>
+          </a:effectRef>
+          <a:fontRef idx="minor">
+            <a:schemeClr val="lt1"/>
+          </a:fontRef>
+        </p:style>
+        <p:txBody>
+          <a:bodyPr rtlCol="0" anchor="ctr"/>
+          <a:lstStyle/>
+          <a:p>
+            <a:pPr algn="ctr"/>
+          </a:p>
+        </p:txBody>
+      </p:sp>
+      <p:sp>
+        <p:nvSpPr>
+          <p:cNvPr id="30" name="Rounded Rectangle 29"/>
+          <p:cNvSpPr/>
+          <p:nvPr/>
+        </p:nvSpPr>
+        <p:spPr>
+          <a:xfrm>
+            <a:off x="9189720" y="1828800"/>
+            <a:ext cx="2743200" cy="3657600"/>
           </a:xfrm>
           <a:prstGeom prst="roundRect">
             <a:avLst/>
@@ -6342,14 +6728,14 @@
       </p:sp>
       <p:sp>
         <p:nvSpPr>
-          <p:cNvPr id="21" name="Rectangle 20"/>
+          <p:cNvPr id="31" name="Rectangle 30"/>
           <p:cNvSpPr/>
           <p:nvPr/>
         </p:nvSpPr>
         <p:spPr>
           <a:xfrm>
-            <a:off x="2331720" y="3840480"/>
-            <a:ext cx="137160" cy="2286000"/>
+            <a:off x="9189720" y="1828800"/>
+            <a:ext cx="2743200" cy="109728"/>
           </a:xfrm>
           <a:prstGeom prst="rect">
             <a:avLst/>
@@ -6385,178 +6771,23 @@
       </p:sp>
       <p:sp>
         <p:nvSpPr>
-          <p:cNvPr id="22" name="TextBox 21"/>
-          <p:cNvSpPr txBox="1"/>
-          <p:nvPr/>
-        </p:nvSpPr>
-        <p:spPr>
-          <a:xfrm>
-            <a:off x="2651760" y="3977640"/>
-            <a:ext cx="3200400" cy="457200"/>
-          </a:xfrm>
-          <a:prstGeom prst="rect">
-            <a:avLst/>
-          </a:prstGeom>
-          <a:noFill/>
-        </p:spPr>
-        <p:txBody>
-          <a:bodyPr wrap="none">
-            <a:spAutoFit/>
-          </a:bodyPr>
-          <a:lstStyle/>
-          <a:p>
-            <a:pPr>
-              <a:defRPr sz="2000" b="1">
-                <a:solidFill>
-                  <a:srgbClr val="9370A5"/>
-                </a:solidFill>
-              </a:defRPr>
-            </a:pPr>
-            <a:r>
-              <a:t>🤖  Work Smarter with AI</a:t>
-            </a:r>
-          </a:p>
-        </p:txBody>
-      </p:sp>
-      <p:sp>
-        <p:nvSpPr>
-          <p:cNvPr id="23" name="TextBox 22"/>
-          <p:cNvSpPr txBox="1"/>
-          <p:nvPr/>
-        </p:nvSpPr>
-        <p:spPr>
-          <a:xfrm>
-            <a:off x="2651760" y="4389120"/>
-            <a:ext cx="3200400" cy="365760"/>
-          </a:xfrm>
-          <a:prstGeom prst="rect">
-            <a:avLst/>
-          </a:prstGeom>
-          <a:noFill/>
-        </p:spPr>
-        <p:txBody>
-          <a:bodyPr wrap="none">
-            <a:spAutoFit/>
-          </a:bodyPr>
-          <a:lstStyle/>
-          <a:p>
-            <a:pPr>
-              <a:defRPr sz="1300" i="1">
-                <a:solidFill>
-                  <a:srgbClr val="64748B"/>
-                </a:solidFill>
-              </a:defRPr>
-            </a:pPr>
-            <a:r>
-              <a:t>Intelligent tools that multiply your capacity</a:t>
-            </a:r>
-          </a:p>
-        </p:txBody>
-      </p:sp>
-      <p:sp>
-        <p:nvSpPr>
-          <p:cNvPr id="24" name="TextBox 23"/>
-          <p:cNvSpPr txBox="1"/>
-          <p:nvPr/>
-        </p:nvSpPr>
-        <p:spPr>
-          <a:xfrm>
-            <a:off x="2651760" y="4800600"/>
-            <a:ext cx="3200400" cy="1371600"/>
-          </a:xfrm>
-          <a:prstGeom prst="rect">
-            <a:avLst/>
-          </a:prstGeom>
-          <a:noFill/>
-        </p:spPr>
-        <p:txBody>
-          <a:bodyPr wrap="square">
-            <a:spAutoFit/>
-          </a:bodyPr>
-          <a:lstStyle/>
-          <a:p>
-            <a:pPr>
-              <a:spcAft>
-                <a:spcPts val="300"/>
-              </a:spcAft>
-              <a:defRPr sz="1200">
-                <a:solidFill>
-                  <a:srgbClr val="475569"/>
-                </a:solidFill>
-              </a:defRPr>
-            </a:pPr>
-            <a:r>
-              <a:t>• Generate reports and documents automatically</a:t>
-            </a:r>
-          </a:p>
-          <a:p>
-            <a:pPr>
-              <a:spcAft>
-                <a:spcPts val="300"/>
-              </a:spcAft>
-              <a:defRPr sz="1200">
-                <a:solidFill>
-                  <a:srgbClr val="475569"/>
-                </a:solidFill>
-              </a:defRPr>
-            </a:pPr>
-            <a:r>
-              <a:t>• Ask questions and get instant answers from your data</a:t>
-            </a:r>
-          </a:p>
-          <a:p>
-            <a:pPr>
-              <a:spcAft>
-                <a:spcPts val="300"/>
-              </a:spcAft>
-              <a:defRPr sz="1200">
-                <a:solidFill>
-                  <a:srgbClr val="475569"/>
-                </a:solidFill>
-              </a:defRPr>
-            </a:pPr>
-            <a:r>
-              <a:t>• Automate routine tasks so you can focus on judgment calls</a:t>
-            </a:r>
-          </a:p>
-          <a:p>
-            <a:pPr>
-              <a:spcAft>
-                <a:spcPts val="300"/>
-              </a:spcAft>
-              <a:defRPr sz="1200">
-                <a:solidFill>
-                  <a:srgbClr val="475569"/>
-                </a:solidFill>
-              </a:defRPr>
-            </a:pPr>
-            <a:r>
-              <a:t>• Get smart alerts when something needs your attention</a:t>
-            </a:r>
-          </a:p>
-        </p:txBody>
-      </p:sp>
-      <p:sp>
-        <p:nvSpPr>
-          <p:cNvPr id="25" name="Rounded Rectangle 24"/>
+          <p:cNvPr id="32" name="Oval 31"/>
           <p:cNvSpPr/>
           <p:nvPr/>
         </p:nvSpPr>
         <p:spPr>
           <a:xfrm>
-            <a:off x="6172200" y="3840480"/>
-            <a:ext cx="3657600" cy="2286000"/>
-          </a:xfrm>
-          <a:prstGeom prst="roundRect">
+            <a:off x="10195560" y="2103120"/>
+            <a:ext cx="731520" cy="731520"/>
+          </a:xfrm>
+          <a:prstGeom prst="ellipse">
             <a:avLst/>
           </a:prstGeom>
           <a:solidFill>
-            <a:srgbClr val="FFFFFF"/>
+            <a:srgbClr val="9370A5"/>
           </a:solidFill>
-          <a:ln w="25400">
-            <a:solidFill>
-              <a:srgbClr val="CD853F"/>
-            </a:solidFill>
+          <a:ln>
+            <a:noFill/>
           </a:ln>
         </p:spPr>
         <p:style>
@@ -6583,57 +6814,14 @@
       </p:sp>
       <p:sp>
         <p:nvSpPr>
-          <p:cNvPr id="26" name="Rectangle 25"/>
-          <p:cNvSpPr/>
-          <p:nvPr/>
-        </p:nvSpPr>
-        <p:spPr>
-          <a:xfrm>
-            <a:off x="6172200" y="3840480"/>
-            <a:ext cx="137160" cy="2286000"/>
-          </a:xfrm>
-          <a:prstGeom prst="rect">
-            <a:avLst/>
-          </a:prstGeom>
-          <a:solidFill>
-            <a:srgbClr val="CD853F"/>
-          </a:solidFill>
-          <a:ln>
-            <a:noFill/>
-          </a:ln>
-        </p:spPr>
-        <p:style>
-          <a:lnRef idx="1">
-            <a:schemeClr val="accent1"/>
-          </a:lnRef>
-          <a:fillRef idx="3">
-            <a:schemeClr val="accent1"/>
-          </a:fillRef>
-          <a:effectRef idx="2">
-            <a:schemeClr val="accent1"/>
-          </a:effectRef>
-          <a:fontRef idx="minor">
-            <a:schemeClr val="lt1"/>
-          </a:fontRef>
-        </p:style>
-        <p:txBody>
-          <a:bodyPr rtlCol="0" anchor="ctr"/>
-          <a:lstStyle/>
-          <a:p>
-            <a:pPr algn="ctr"/>
-          </a:p>
-        </p:txBody>
-      </p:sp>
-      <p:sp>
-        <p:nvSpPr>
-          <p:cNvPr id="27" name="TextBox 26"/>
+          <p:cNvPr id="33" name="TextBox 32"/>
           <p:cNvSpPr txBox="1"/>
           <p:nvPr/>
         </p:nvSpPr>
         <p:spPr>
           <a:xfrm>
-            <a:off x="6492240" y="3977640"/>
-            <a:ext cx="3200400" cy="457200"/>
+            <a:off x="10241280" y="2194560"/>
+            <a:ext cx="640080" cy="548640"/>
           </a:xfrm>
           <a:prstGeom prst="rect">
             <a:avLst/>
@@ -6646,29 +6834,25 @@
           </a:bodyPr>
           <a:lstStyle/>
           <a:p>
-            <a:pPr>
-              <a:defRPr sz="2000" b="1">
-                <a:solidFill>
-                  <a:srgbClr val="CD853F"/>
-                </a:solidFill>
-              </a:defRPr>
+            <a:pPr algn="ctr">
+              <a:defRPr sz="2800"/>
             </a:pPr>
             <a:r>
-              <a:t>🧭  Navigate AI Confidently</a:t>
-            </a:r>
-          </a:p>
-        </p:txBody>
-      </p:sp>
-      <p:sp>
-        <p:nvSpPr>
-          <p:cNvPr id="28" name="TextBox 27"/>
+              <a:t>🤖</a:t>
+            </a:r>
+          </a:p>
+        </p:txBody>
+      </p:sp>
+      <p:sp>
+        <p:nvSpPr>
+          <p:cNvPr id="34" name="TextBox 33"/>
           <p:cNvSpPr txBox="1"/>
           <p:nvPr/>
         </p:nvSpPr>
         <p:spPr>
           <a:xfrm>
-            <a:off x="6492240" y="4389120"/>
-            <a:ext cx="3200400" cy="365760"/>
+            <a:off x="9281160" y="2926080"/>
+            <a:ext cx="2560320" cy="457200"/>
           </a:xfrm>
           <a:prstGeom prst="rect">
             <a:avLst/>
@@ -6681,29 +6865,64 @@
           </a:bodyPr>
           <a:lstStyle/>
           <a:p>
-            <a:pPr>
-              <a:defRPr sz="1300" i="1">
+            <a:pPr algn="ctr">
+              <a:defRPr sz="1800" b="1">
+                <a:solidFill>
+                  <a:srgbClr val="9370A5"/>
+                </a:solidFill>
+              </a:defRPr>
+            </a:pPr>
+            <a:r>
+              <a:t>Intelligent Tools</a:t>
+            </a:r>
+          </a:p>
+        </p:txBody>
+      </p:sp>
+      <p:sp>
+        <p:nvSpPr>
+          <p:cNvPr id="35" name="TextBox 34"/>
+          <p:cNvSpPr txBox="1"/>
+          <p:nvPr/>
+        </p:nvSpPr>
+        <p:spPr>
+          <a:xfrm>
+            <a:off x="9281160" y="3337560"/>
+            <a:ext cx="2560320" cy="365760"/>
+          </a:xfrm>
+          <a:prstGeom prst="rect">
+            <a:avLst/>
+          </a:prstGeom>
+          <a:noFill/>
+        </p:spPr>
+        <p:txBody>
+          <a:bodyPr wrap="none">
+            <a:spAutoFit/>
+          </a:bodyPr>
+          <a:lstStyle/>
+          <a:p>
+            <a:pPr algn="ctr">
+              <a:defRPr sz="1200" i="1">
                 <a:solidFill>
                   <a:srgbClr val="64748B"/>
                 </a:solidFill>
               </a:defRPr>
             </a:pPr>
             <a:r>
-              <a:t>Make smart choices in a fast-moving landscape</a:t>
-            </a:r>
-          </a:p>
-        </p:txBody>
-      </p:sp>
-      <p:sp>
-        <p:nvSpPr>
-          <p:cNvPr id="29" name="TextBox 28"/>
+              <a:t>AI that works for you</a:t>
+            </a:r>
+          </a:p>
+        </p:txBody>
+      </p:sp>
+      <p:sp>
+        <p:nvSpPr>
+          <p:cNvPr id="36" name="TextBox 35"/>
           <p:cNvSpPr txBox="1"/>
           <p:nvPr/>
         </p:nvSpPr>
         <p:spPr>
           <a:xfrm>
-            <a:off x="6492240" y="4800600"/>
-            <a:ext cx="3200400" cy="1371600"/>
+            <a:off x="9326880" y="3749040"/>
+            <a:ext cx="2468880" cy="1554480"/>
           </a:xfrm>
           <a:prstGeom prst="rect">
             <a:avLst/>
@@ -6718,53 +6937,88 @@
           <a:p>
             <a:pPr>
               <a:spcAft>
-                <a:spcPts val="300"/>
+                <a:spcPts val="400"/>
               </a:spcAft>
-              <a:defRPr sz="1200">
+              <a:defRPr sz="1100">
                 <a:solidFill>
                   <a:srgbClr val="475569"/>
                 </a:solidFill>
               </a:defRPr>
             </a:pPr>
             <a:r>
-              <a:t>• Guidance on using ChatGPT and similar tools safely</a:t>
+              <a:t>• Generate reports and documents automatically</a:t>
             </a:r>
           </a:p>
           <a:p>
             <a:pPr>
               <a:spcAft>
-                <a:spcPts val="300"/>
+                <a:spcPts val="400"/>
               </a:spcAft>
-              <a:defRPr sz="1200">
+              <a:defRPr sz="1100">
                 <a:solidFill>
                   <a:srgbClr val="475569"/>
                 </a:solidFill>
               </a:defRPr>
             </a:pPr>
             <a:r>
-              <a:t>• Evaluate which AI products are actually worth it</a:t>
+              <a:t>• Ask questions, get instant answers</a:t>
             </a:r>
           </a:p>
           <a:p>
             <a:pPr>
               <a:spcAft>
-                <a:spcPts val="300"/>
+                <a:spcPts val="400"/>
               </a:spcAft>
-              <a:defRPr sz="1200">
+              <a:defRPr sz="1100">
                 <a:solidFill>
                   <a:srgbClr val="475569"/>
                 </a:solidFill>
               </a:defRPr>
             </a:pPr>
             <a:r>
-              <a:t>• Stay ahead with university and industry connections</a:t>
-            </a:r>
-          </a:p>
-        </p:txBody>
-      </p:sp>
-      <p:sp>
-        <p:nvSpPr>
-          <p:cNvPr id="30" name="TextBox 29"/>
+              <a:t>• Smart alerts when you need to act</a:t>
+            </a:r>
+          </a:p>
+        </p:txBody>
+      </p:sp>
+      <p:sp>
+        <p:nvSpPr>
+          <p:cNvPr id="37" name="TextBox 36"/>
+          <p:cNvSpPr txBox="1"/>
+          <p:nvPr/>
+        </p:nvSpPr>
+        <p:spPr>
+          <a:xfrm>
+            <a:off x="457200" y="5669280"/>
+            <a:ext cx="11247120" cy="457200"/>
+          </a:xfrm>
+          <a:prstGeom prst="rect">
+            <a:avLst/>
+          </a:prstGeom>
+          <a:noFill/>
+        </p:spPr>
+        <p:txBody>
+          <a:bodyPr wrap="none">
+            <a:spAutoFit/>
+          </a:bodyPr>
+          <a:lstStyle/>
+          <a:p>
+            <a:pPr algn="ctr">
+              <a:defRPr sz="1400" i="1">
+                <a:solidFill>
+                  <a:srgbClr val="64748B"/>
+                </a:solidFill>
+              </a:defRPr>
+            </a:pPr>
+            <a:r>
+              <a:t>Each solution is tailored to your specific needs — let's look at some examples →</a:t>
+            </a:r>
+          </a:p>
+        </p:txBody>
+      </p:sp>
+      <p:sp>
+        <p:nvSpPr>
+          <p:cNvPr id="38" name="TextBox 37"/>
           <p:cNvSpPr txBox="1"/>
           <p:nvPr/>
         </p:nvSpPr>
@@ -6931,7 +7185,7 @@
               </a:defRPr>
             </a:pPr>
             <a:r>
-              <a:t>Types of Solutions We Build</a:t>
+              <a:t>Beyond Project Work</a:t>
             </a:r>
           </a:p>
         </p:txBody>
@@ -6944,7 +7198,7 @@
         </p:nvSpPr>
         <p:spPr>
           <a:xfrm>
-            <a:off x="731520" y="1371600"/>
+            <a:off x="731520" y="1325880"/>
             <a:ext cx="10515600" cy="457200"/>
           </a:xfrm>
           <a:prstGeom prst="rect">
@@ -6966,7 +7220,7 @@
               </a:defRPr>
             </a:pPr>
             <a:r>
-              <a:t>A spectrum of tools — from simple visibility to intelligent automation</a:t>
+              <a:t>How we support the broader organization</a:t>
             </a:r>
           </a:p>
         </p:txBody>
@@ -6979,8 +7233,8 @@
         </p:nvSpPr>
         <p:spPr>
           <a:xfrm>
-            <a:off x="457200" y="1920240"/>
-            <a:ext cx="2148840" cy="3840480"/>
+            <a:off x="411480" y="1828800"/>
+            <a:ext cx="3657600" cy="1737360"/>
           </a:xfrm>
           <a:prstGeom prst="roundRect">
             <a:avLst/>
@@ -6988,9 +7242,9 @@
           <a:solidFill>
             <a:srgbClr val="FFFFFF"/>
           </a:solidFill>
-          <a:ln w="25400">
+          <a:ln w="19050">
             <a:solidFill>
-              <a:srgbClr val="4682B4"/>
+              <a:srgbClr val="CD853F"/>
             </a:solidFill>
           </a:ln>
         </p:spPr>
@@ -7024,8 +7278,166 @@
         </p:nvSpPr>
         <p:spPr>
           <a:xfrm>
-            <a:off x="457200" y="1920240"/>
-            <a:ext cx="2148840" cy="137160"/>
+            <a:off x="411480" y="1828800"/>
+            <a:ext cx="109728" cy="1737360"/>
+          </a:xfrm>
+          <a:prstGeom prst="rect">
+            <a:avLst/>
+          </a:prstGeom>
+          <a:solidFill>
+            <a:srgbClr val="CD853F"/>
+          </a:solidFill>
+          <a:ln>
+            <a:noFill/>
+          </a:ln>
+        </p:spPr>
+        <p:style>
+          <a:lnRef idx="1">
+            <a:schemeClr val="accent1"/>
+          </a:lnRef>
+          <a:fillRef idx="3">
+            <a:schemeClr val="accent1"/>
+          </a:fillRef>
+          <a:effectRef idx="2">
+            <a:schemeClr val="accent1"/>
+          </a:effectRef>
+          <a:fontRef idx="minor">
+            <a:schemeClr val="lt1"/>
+          </a:fontRef>
+        </p:style>
+        <p:txBody>
+          <a:bodyPr rtlCol="0" anchor="ctr"/>
+          <a:lstStyle/>
+          <a:p>
+            <a:pPr algn="ctr"/>
+          </a:p>
+        </p:txBody>
+      </p:sp>
+      <p:sp>
+        <p:nvSpPr>
+          <p:cNvPr id="8" name="TextBox 7"/>
+          <p:cNvSpPr txBox="1"/>
+          <p:nvPr/>
+        </p:nvSpPr>
+        <p:spPr>
+          <a:xfrm>
+            <a:off x="640080" y="1965960"/>
+            <a:ext cx="3291840" cy="457200"/>
+          </a:xfrm>
+          <a:prstGeom prst="rect">
+            <a:avLst/>
+          </a:prstGeom>
+          <a:noFill/>
+        </p:spPr>
+        <p:txBody>
+          <a:bodyPr wrap="none">
+            <a:spAutoFit/>
+          </a:bodyPr>
+          <a:lstStyle/>
+          <a:p>
+            <a:pPr>
+              <a:defRPr sz="1600" b="1">
+                <a:solidFill>
+                  <a:srgbClr val="CD853F"/>
+                </a:solidFill>
+              </a:defRPr>
+            </a:pPr>
+            <a:r>
+              <a:t>🧭  AI Guidance</a:t>
+            </a:r>
+          </a:p>
+        </p:txBody>
+      </p:sp>
+      <p:sp>
+        <p:nvSpPr>
+          <p:cNvPr id="9" name="TextBox 8"/>
+          <p:cNvSpPr txBox="1"/>
+          <p:nvPr/>
+        </p:nvSpPr>
+        <p:spPr>
+          <a:xfrm>
+            <a:off x="640080" y="2377440"/>
+            <a:ext cx="3291840" cy="1097280"/>
+          </a:xfrm>
+          <a:prstGeom prst="rect">
+            <a:avLst/>
+          </a:prstGeom>
+          <a:noFill/>
+        </p:spPr>
+        <p:txBody>
+          <a:bodyPr wrap="square">
+            <a:spAutoFit/>
+          </a:bodyPr>
+          <a:lstStyle/>
+          <a:p>
+            <a:pPr>
+              <a:defRPr sz="1200">
+                <a:solidFill>
+                  <a:srgbClr val="475569"/>
+                </a:solidFill>
+              </a:defRPr>
+            </a:pPr>
+            <a:r>
+              <a:t>Navigate AI tools confidently — we help you use ChatGPT and similar tools safely, and evaluate which products are worth buying</a:t>
+            </a:r>
+          </a:p>
+        </p:txBody>
+      </p:sp>
+      <p:sp>
+        <p:nvSpPr>
+          <p:cNvPr id="10" name="Rounded Rectangle 9"/>
+          <p:cNvSpPr/>
+          <p:nvPr/>
+        </p:nvSpPr>
+        <p:spPr>
+          <a:xfrm>
+            <a:off x="4251960" y="1828800"/>
+            <a:ext cx="3657600" cy="1737360"/>
+          </a:xfrm>
+          <a:prstGeom prst="roundRect">
+            <a:avLst/>
+          </a:prstGeom>
+          <a:solidFill>
+            <a:srgbClr val="FFFFFF"/>
+          </a:solidFill>
+          <a:ln w="19050">
+            <a:solidFill>
+              <a:srgbClr val="4682B4"/>
+            </a:solidFill>
+          </a:ln>
+        </p:spPr>
+        <p:style>
+          <a:lnRef idx="1">
+            <a:schemeClr val="accent1"/>
+          </a:lnRef>
+          <a:fillRef idx="3">
+            <a:schemeClr val="accent1"/>
+          </a:fillRef>
+          <a:effectRef idx="2">
+            <a:schemeClr val="accent1"/>
+          </a:effectRef>
+          <a:fontRef idx="minor">
+            <a:schemeClr val="lt1"/>
+          </a:fontRef>
+        </p:style>
+        <p:txBody>
+          <a:bodyPr rtlCol="0" anchor="ctr"/>
+          <a:lstStyle/>
+          <a:p>
+            <a:pPr algn="ctr"/>
+          </a:p>
+        </p:txBody>
+      </p:sp>
+      <p:sp>
+        <p:nvSpPr>
+          <p:cNvPr id="11" name="Rectangle 10"/>
+          <p:cNvSpPr/>
+          <p:nvPr/>
+        </p:nvSpPr>
+        <p:spPr>
+          <a:xfrm>
+            <a:off x="4251960" y="1828800"/>
+            <a:ext cx="109728" cy="1737360"/>
           </a:xfrm>
           <a:prstGeom prst="rect">
             <a:avLst/>
@@ -7061,23 +7473,95 @@
       </p:sp>
       <p:sp>
         <p:nvSpPr>
-          <p:cNvPr id="8" name="Oval 7"/>
+          <p:cNvPr id="12" name="TextBox 11"/>
+          <p:cNvSpPr txBox="1"/>
+          <p:nvPr/>
+        </p:nvSpPr>
+        <p:spPr>
+          <a:xfrm>
+            <a:off x="4480560" y="1965960"/>
+            <a:ext cx="3291840" cy="457200"/>
+          </a:xfrm>
+          <a:prstGeom prst="rect">
+            <a:avLst/>
+          </a:prstGeom>
+          <a:noFill/>
+        </p:spPr>
+        <p:txBody>
+          <a:bodyPr wrap="none">
+            <a:spAutoFit/>
+          </a:bodyPr>
+          <a:lstStyle/>
+          <a:p>
+            <a:pPr>
+              <a:defRPr sz="1600" b="1">
+                <a:solidFill>
+                  <a:srgbClr val="4682B4"/>
+                </a:solidFill>
+              </a:defRPr>
+            </a:pPr>
+            <a:r>
+              <a:t>🎓  Training &amp; Skills</a:t>
+            </a:r>
+          </a:p>
+        </p:txBody>
+      </p:sp>
+      <p:sp>
+        <p:nvSpPr>
+          <p:cNvPr id="13" name="TextBox 12"/>
+          <p:cNvSpPr txBox="1"/>
+          <p:nvPr/>
+        </p:nvSpPr>
+        <p:spPr>
+          <a:xfrm>
+            <a:off x="4480560" y="2377440"/>
+            <a:ext cx="3291840" cy="1097280"/>
+          </a:xfrm>
+          <a:prstGeom prst="rect">
+            <a:avLst/>
+          </a:prstGeom>
+          <a:noFill/>
+        </p:spPr>
+        <p:txBody>
+          <a:bodyPr wrap="square">
+            <a:spAutoFit/>
+          </a:bodyPr>
+          <a:lstStyle/>
+          <a:p>
+            <a:pPr>
+              <a:defRPr sz="1200">
+                <a:solidFill>
+                  <a:srgbClr val="475569"/>
+                </a:solidFill>
+              </a:defRPr>
+            </a:pPr>
+            <a:r>
+              <a:t>Level up your team's data capabilities through workshops, office hours, and hands-on learning opportunities</a:t>
+            </a:r>
+          </a:p>
+        </p:txBody>
+      </p:sp>
+      <p:sp>
+        <p:nvSpPr>
+          <p:cNvPr id="14" name="Rounded Rectangle 13"/>
           <p:cNvSpPr/>
           <p:nvPr/>
         </p:nvSpPr>
         <p:spPr>
           <a:xfrm>
-            <a:off x="1165860" y="2240280"/>
-            <a:ext cx="731520" cy="731520"/>
-          </a:xfrm>
-          <a:prstGeom prst="ellipse">
+            <a:off x="8092440" y="1828800"/>
+            <a:ext cx="3657600" cy="1737360"/>
+          </a:xfrm>
+          <a:prstGeom prst="roundRect">
             <a:avLst/>
           </a:prstGeom>
           <a:solidFill>
-            <a:srgbClr val="4682B4"/>
+            <a:srgbClr val="FFFFFF"/>
           </a:solidFill>
-          <a:ln>
-            <a:noFill/>
+          <a:ln w="19050">
+            <a:solidFill>
+              <a:srgbClr val="008080"/>
+            </a:solidFill>
           </a:ln>
         </p:spPr>
         <p:style>
@@ -7104,242 +7588,14 @@
       </p:sp>
       <p:sp>
         <p:nvSpPr>
-          <p:cNvPr id="9" name="TextBox 8"/>
-          <p:cNvSpPr txBox="1"/>
-          <p:nvPr/>
-        </p:nvSpPr>
-        <p:spPr>
-          <a:xfrm>
-            <a:off x="1211580" y="2331720"/>
-            <a:ext cx="640080" cy="548640"/>
-          </a:xfrm>
-          <a:prstGeom prst="rect">
-            <a:avLst/>
-          </a:prstGeom>
-          <a:noFill/>
-        </p:spPr>
-        <p:txBody>
-          <a:bodyPr wrap="none">
-            <a:spAutoFit/>
-          </a:bodyPr>
-          <a:lstStyle/>
-          <a:p>
-            <a:pPr algn="ctr">
-              <a:defRPr sz="2800"/>
-            </a:pPr>
-            <a:r>
-              <a:t>📊</a:t>
-            </a:r>
-          </a:p>
-        </p:txBody>
-      </p:sp>
-      <p:sp>
-        <p:nvSpPr>
-          <p:cNvPr id="10" name="TextBox 9"/>
-          <p:cNvSpPr txBox="1"/>
-          <p:nvPr/>
-        </p:nvSpPr>
-        <p:spPr>
-          <a:xfrm>
-            <a:off x="548640" y="3063240"/>
-            <a:ext cx="1965960" cy="731520"/>
-          </a:xfrm>
-          <a:prstGeom prst="rect">
-            <a:avLst/>
-          </a:prstGeom>
-          <a:noFill/>
-        </p:spPr>
-        <p:txBody>
-          <a:bodyPr wrap="square">
-            <a:spAutoFit/>
-          </a:bodyPr>
-          <a:lstStyle/>
-          <a:p>
-            <a:pPr algn="ctr">
-              <a:defRPr sz="1400" b="1">
-                <a:solidFill>
-                  <a:srgbClr val="4682B4"/>
-                </a:solidFill>
-              </a:defRPr>
-            </a:pPr>
-            <a:r>
-              <a:t>Dashboards &amp;</a:t>
-            </a:r>
-            <a:br/>
-            <a:r>
-              <a:t>Visualizations</a:t>
-            </a:r>
-          </a:p>
-        </p:txBody>
-      </p:sp>
-      <p:sp>
-        <p:nvSpPr>
-          <p:cNvPr id="11" name="TextBox 10"/>
-          <p:cNvSpPr txBox="1"/>
-          <p:nvPr/>
-        </p:nvSpPr>
-        <p:spPr>
-          <a:xfrm>
-            <a:off x="548640" y="3794759"/>
-            <a:ext cx="1965960" cy="457200"/>
-          </a:xfrm>
-          <a:prstGeom prst="rect">
-            <a:avLst/>
-          </a:prstGeom>
-          <a:noFill/>
-        </p:spPr>
-        <p:txBody>
-          <a:bodyPr wrap="square">
-            <a:spAutoFit/>
-          </a:bodyPr>
-          <a:lstStyle/>
-          <a:p>
-            <a:pPr algn="ctr">
-              <a:defRPr sz="1300" b="1">
-                <a:solidFill>
-                  <a:srgbClr val="475569"/>
-                </a:solidFill>
-              </a:defRPr>
-            </a:pPr>
-            <a:r>
-              <a:t>See your data clearly</a:t>
-            </a:r>
-          </a:p>
-        </p:txBody>
-      </p:sp>
-      <p:sp>
-        <p:nvSpPr>
-          <p:cNvPr id="12" name="TextBox 11"/>
-          <p:cNvSpPr txBox="1"/>
-          <p:nvPr/>
-        </p:nvSpPr>
-        <p:spPr>
-          <a:xfrm>
-            <a:off x="548640" y="4251960"/>
-            <a:ext cx="1965960" cy="1280160"/>
-          </a:xfrm>
-          <a:prstGeom prst="rect">
-            <a:avLst/>
-          </a:prstGeom>
-          <a:noFill/>
-        </p:spPr>
-        <p:txBody>
-          <a:bodyPr wrap="square">
-            <a:spAutoFit/>
-          </a:bodyPr>
-          <a:lstStyle/>
-          <a:p>
-            <a:pPr algn="ctr">
-              <a:defRPr sz="1100">
-                <a:solidFill>
-                  <a:srgbClr val="64748B"/>
-                </a:solidFill>
-              </a:defRPr>
-            </a:pPr>
-            <a:r>
-              <a:t>Status trackers, maps, charts that update automatically</a:t>
-            </a:r>
-          </a:p>
-        </p:txBody>
-      </p:sp>
-      <p:sp>
-        <p:nvSpPr>
-          <p:cNvPr id="13" name="Right Arrow 12"/>
-          <p:cNvSpPr/>
-          <p:nvPr/>
-        </p:nvSpPr>
-        <p:spPr>
-          <a:xfrm>
-            <a:off x="2624328" y="2651760"/>
-            <a:ext cx="146304" cy="228600"/>
-          </a:xfrm>
-          <a:prstGeom prst="rightArrow">
-            <a:avLst/>
-          </a:prstGeom>
-          <a:solidFill>
-            <a:srgbClr val="C8D2DC"/>
-          </a:solidFill>
-          <a:ln>
-            <a:noFill/>
-          </a:ln>
-        </p:spPr>
-        <p:style>
-          <a:lnRef idx="1">
-            <a:schemeClr val="accent1"/>
-          </a:lnRef>
-          <a:fillRef idx="3">
-            <a:schemeClr val="accent1"/>
-          </a:fillRef>
-          <a:effectRef idx="2">
-            <a:schemeClr val="accent1"/>
-          </a:effectRef>
-          <a:fontRef idx="minor">
-            <a:schemeClr val="lt1"/>
-          </a:fontRef>
-        </p:style>
-        <p:txBody>
-          <a:bodyPr rtlCol="0" anchor="ctr"/>
-          <a:lstStyle/>
-          <a:p>
-            <a:pPr algn="ctr"/>
-          </a:p>
-        </p:txBody>
-      </p:sp>
-      <p:sp>
-        <p:nvSpPr>
-          <p:cNvPr id="14" name="Rounded Rectangle 13"/>
-          <p:cNvSpPr/>
-          <p:nvPr/>
-        </p:nvSpPr>
-        <p:spPr>
-          <a:xfrm>
-            <a:off x="2788920" y="1920240"/>
-            <a:ext cx="2148840" cy="3840480"/>
-          </a:xfrm>
-          <a:prstGeom prst="roundRect">
-            <a:avLst/>
-          </a:prstGeom>
-          <a:solidFill>
-            <a:srgbClr val="FFFFFF"/>
-          </a:solidFill>
-          <a:ln w="25400">
-            <a:solidFill>
-              <a:srgbClr val="008080"/>
-            </a:solidFill>
-          </a:ln>
-        </p:spPr>
-        <p:style>
-          <a:lnRef idx="1">
-            <a:schemeClr val="accent1"/>
-          </a:lnRef>
-          <a:fillRef idx="3">
-            <a:schemeClr val="accent1"/>
-          </a:fillRef>
-          <a:effectRef idx="2">
-            <a:schemeClr val="accent1"/>
-          </a:effectRef>
-          <a:fontRef idx="minor">
-            <a:schemeClr val="lt1"/>
-          </a:fontRef>
-        </p:style>
-        <p:txBody>
-          <a:bodyPr rtlCol="0" anchor="ctr"/>
-          <a:lstStyle/>
-          <a:p>
-            <a:pPr algn="ctr"/>
-          </a:p>
-        </p:txBody>
-      </p:sp>
-      <p:sp>
-        <p:nvSpPr>
           <p:cNvPr id="15" name="Rectangle 14"/>
           <p:cNvSpPr/>
           <p:nvPr/>
         </p:nvSpPr>
         <p:spPr>
           <a:xfrm>
-            <a:off x="2788920" y="1920240"/>
-            <a:ext cx="2148840" cy="137160"/>
+            <a:off x="8092440" y="1828800"/>
+            <a:ext cx="109728" cy="1737360"/>
           </a:xfrm>
           <a:prstGeom prst="rect">
             <a:avLst/>
@@ -7375,23 +7631,95 @@
       </p:sp>
       <p:sp>
         <p:nvSpPr>
-          <p:cNvPr id="16" name="Oval 15"/>
+          <p:cNvPr id="16" name="TextBox 15"/>
+          <p:cNvSpPr txBox="1"/>
+          <p:nvPr/>
+        </p:nvSpPr>
+        <p:spPr>
+          <a:xfrm>
+            <a:off x="8321040" y="1965960"/>
+            <a:ext cx="3291840" cy="457200"/>
+          </a:xfrm>
+          <a:prstGeom prst="rect">
+            <a:avLst/>
+          </a:prstGeom>
+          <a:noFill/>
+        </p:spPr>
+        <p:txBody>
+          <a:bodyPr wrap="none">
+            <a:spAutoFit/>
+          </a:bodyPr>
+          <a:lstStyle/>
+          <a:p>
+            <a:pPr>
+              <a:defRPr sz="1600" b="1">
+                <a:solidFill>
+                  <a:srgbClr val="008080"/>
+                </a:solidFill>
+              </a:defRPr>
+            </a:pPr>
+            <a:r>
+              <a:t>🔬  External Partnerships</a:t>
+            </a:r>
+          </a:p>
+        </p:txBody>
+      </p:sp>
+      <p:sp>
+        <p:nvSpPr>
+          <p:cNvPr id="17" name="TextBox 16"/>
+          <p:cNvSpPr txBox="1"/>
+          <p:nvPr/>
+        </p:nvSpPr>
+        <p:spPr>
+          <a:xfrm>
+            <a:off x="8321040" y="2377440"/>
+            <a:ext cx="3291840" cy="1097280"/>
+          </a:xfrm>
+          <a:prstGeom prst="rect">
+            <a:avLst/>
+          </a:prstGeom>
+          <a:noFill/>
+        </p:spPr>
+        <p:txBody>
+          <a:bodyPr wrap="square">
+            <a:spAutoFit/>
+          </a:bodyPr>
+          <a:lstStyle/>
+          <a:p>
+            <a:pPr>
+              <a:defRPr sz="1200">
+                <a:solidFill>
+                  <a:srgbClr val="475569"/>
+                </a:solidFill>
+              </a:defRPr>
+            </a:pPr>
+            <a:r>
+              <a:t>Connections to universities, national labs, and industry partners to bring cutting-edge solutions to our challenges</a:t>
+            </a:r>
+          </a:p>
+        </p:txBody>
+      </p:sp>
+      <p:sp>
+        <p:nvSpPr>
+          <p:cNvPr id="18" name="Rounded Rectangle 17"/>
           <p:cNvSpPr/>
           <p:nvPr/>
         </p:nvSpPr>
         <p:spPr>
           <a:xfrm>
-            <a:off x="3497580" y="2240280"/>
-            <a:ext cx="731520" cy="731520"/>
-          </a:xfrm>
-          <a:prstGeom prst="ellipse">
+            <a:off x="2331720" y="3749039"/>
+            <a:ext cx="3657600" cy="1737360"/>
+          </a:xfrm>
+          <a:prstGeom prst="roundRect">
             <a:avLst/>
           </a:prstGeom>
           <a:solidFill>
-            <a:srgbClr val="008080"/>
+            <a:srgbClr val="FFFFFF"/>
           </a:solidFill>
-          <a:ln>
-            <a:noFill/>
+          <a:ln w="19050">
+            <a:solidFill>
+              <a:srgbClr val="558B6E"/>
+            </a:solidFill>
           </a:ln>
         </p:spPr>
         <p:style>
@@ -7418,242 +7746,14 @@
       </p:sp>
       <p:sp>
         <p:nvSpPr>
-          <p:cNvPr id="17" name="TextBox 16"/>
-          <p:cNvSpPr txBox="1"/>
-          <p:nvPr/>
-        </p:nvSpPr>
-        <p:spPr>
-          <a:xfrm>
-            <a:off x="3543300" y="2331720"/>
-            <a:ext cx="640080" cy="548640"/>
-          </a:xfrm>
-          <a:prstGeom prst="rect">
-            <a:avLst/>
-          </a:prstGeom>
-          <a:noFill/>
-        </p:spPr>
-        <p:txBody>
-          <a:bodyPr wrap="none">
-            <a:spAutoFit/>
-          </a:bodyPr>
-          <a:lstStyle/>
-          <a:p>
-            <a:pPr algn="ctr">
-              <a:defRPr sz="2800"/>
-            </a:pPr>
-            <a:r>
-              <a:t>🔗</a:t>
-            </a:r>
-          </a:p>
-        </p:txBody>
-      </p:sp>
-      <p:sp>
-        <p:nvSpPr>
-          <p:cNvPr id="18" name="TextBox 17"/>
-          <p:cNvSpPr txBox="1"/>
-          <p:nvPr/>
-        </p:nvSpPr>
-        <p:spPr>
-          <a:xfrm>
-            <a:off x="2880360" y="3063240"/>
-            <a:ext cx="1965960" cy="731520"/>
-          </a:xfrm>
-          <a:prstGeom prst="rect">
-            <a:avLst/>
-          </a:prstGeom>
-          <a:noFill/>
-        </p:spPr>
-        <p:txBody>
-          <a:bodyPr wrap="square">
-            <a:spAutoFit/>
-          </a:bodyPr>
-          <a:lstStyle/>
-          <a:p>
-            <a:pPr algn="ctr">
-              <a:defRPr sz="1400" b="1">
-                <a:solidFill>
-                  <a:srgbClr val="008080"/>
-                </a:solidFill>
-              </a:defRPr>
-            </a:pPr>
-            <a:r>
-              <a:t>Connected</a:t>
-            </a:r>
-            <a:br/>
-            <a:r>
-              <a:t>Data Systems</a:t>
-            </a:r>
-          </a:p>
-        </p:txBody>
-      </p:sp>
-      <p:sp>
-        <p:nvSpPr>
-          <p:cNvPr id="19" name="TextBox 18"/>
-          <p:cNvSpPr txBox="1"/>
-          <p:nvPr/>
-        </p:nvSpPr>
-        <p:spPr>
-          <a:xfrm>
-            <a:off x="2880360" y="3794759"/>
-            <a:ext cx="1965960" cy="457200"/>
-          </a:xfrm>
-          <a:prstGeom prst="rect">
-            <a:avLst/>
-          </a:prstGeom>
-          <a:noFill/>
-        </p:spPr>
-        <p:txBody>
-          <a:bodyPr wrap="square">
-            <a:spAutoFit/>
-          </a:bodyPr>
-          <a:lstStyle/>
-          <a:p>
-            <a:pPr algn="ctr">
-              <a:defRPr sz="1300" b="1">
-                <a:solidFill>
-                  <a:srgbClr val="475569"/>
-                </a:solidFill>
-              </a:defRPr>
-            </a:pPr>
-            <a:r>
-              <a:t>Bring scattered info together</a:t>
-            </a:r>
-          </a:p>
-        </p:txBody>
-      </p:sp>
-      <p:sp>
-        <p:nvSpPr>
-          <p:cNvPr id="20" name="TextBox 19"/>
-          <p:cNvSpPr txBox="1"/>
-          <p:nvPr/>
-        </p:nvSpPr>
-        <p:spPr>
-          <a:xfrm>
-            <a:off x="2880360" y="4251960"/>
-            <a:ext cx="1965960" cy="1280160"/>
-          </a:xfrm>
-          <a:prstGeom prst="rect">
-            <a:avLst/>
-          </a:prstGeom>
-          <a:noFill/>
-        </p:spPr>
-        <p:txBody>
-          <a:bodyPr wrap="square">
-            <a:spAutoFit/>
-          </a:bodyPr>
-          <a:lstStyle/>
-          <a:p>
-            <a:pPr algn="ctr">
-              <a:defRPr sz="1100">
-                <a:solidFill>
-                  <a:srgbClr val="64748B"/>
-                </a:solidFill>
-              </a:defRPr>
-            </a:pPr>
-            <a:r>
-              <a:t>Link spreadsheets, databases, and documents in one place</a:t>
-            </a:r>
-          </a:p>
-        </p:txBody>
-      </p:sp>
-      <p:sp>
-        <p:nvSpPr>
-          <p:cNvPr id="21" name="Right Arrow 20"/>
+          <p:cNvPr id="19" name="Rectangle 18"/>
           <p:cNvSpPr/>
           <p:nvPr/>
         </p:nvSpPr>
         <p:spPr>
           <a:xfrm>
-            <a:off x="4956048" y="2651760"/>
-            <a:ext cx="146304" cy="228600"/>
-          </a:xfrm>
-          <a:prstGeom prst="rightArrow">
-            <a:avLst/>
-          </a:prstGeom>
-          <a:solidFill>
-            <a:srgbClr val="C8D2DC"/>
-          </a:solidFill>
-          <a:ln>
-            <a:noFill/>
-          </a:ln>
-        </p:spPr>
-        <p:style>
-          <a:lnRef idx="1">
-            <a:schemeClr val="accent1"/>
-          </a:lnRef>
-          <a:fillRef idx="3">
-            <a:schemeClr val="accent1"/>
-          </a:fillRef>
-          <a:effectRef idx="2">
-            <a:schemeClr val="accent1"/>
-          </a:effectRef>
-          <a:fontRef idx="minor">
-            <a:schemeClr val="lt1"/>
-          </a:fontRef>
-        </p:style>
-        <p:txBody>
-          <a:bodyPr rtlCol="0" anchor="ctr"/>
-          <a:lstStyle/>
-          <a:p>
-            <a:pPr algn="ctr"/>
-          </a:p>
-        </p:txBody>
-      </p:sp>
-      <p:sp>
-        <p:nvSpPr>
-          <p:cNvPr id="22" name="Rounded Rectangle 21"/>
-          <p:cNvSpPr/>
-          <p:nvPr/>
-        </p:nvSpPr>
-        <p:spPr>
-          <a:xfrm>
-            <a:off x="5120640" y="1920240"/>
-            <a:ext cx="2148840" cy="3840480"/>
-          </a:xfrm>
-          <a:prstGeom prst="roundRect">
-            <a:avLst/>
-          </a:prstGeom>
-          <a:solidFill>
-            <a:srgbClr val="FFFFFF"/>
-          </a:solidFill>
-          <a:ln w="25400">
-            <a:solidFill>
-              <a:srgbClr val="558B6E"/>
-            </a:solidFill>
-          </a:ln>
-        </p:spPr>
-        <p:style>
-          <a:lnRef idx="1">
-            <a:schemeClr val="accent1"/>
-          </a:lnRef>
-          <a:fillRef idx="3">
-            <a:schemeClr val="accent1"/>
-          </a:fillRef>
-          <a:effectRef idx="2">
-            <a:schemeClr val="accent1"/>
-          </a:effectRef>
-          <a:fontRef idx="minor">
-            <a:schemeClr val="lt1"/>
-          </a:fontRef>
-        </p:style>
-        <p:txBody>
-          <a:bodyPr rtlCol="0" anchor="ctr"/>
-          <a:lstStyle/>
-          <a:p>
-            <a:pPr algn="ctr"/>
-          </a:p>
-        </p:txBody>
-      </p:sp>
-      <p:sp>
-        <p:nvSpPr>
-          <p:cNvPr id="23" name="Rectangle 22"/>
-          <p:cNvSpPr/>
-          <p:nvPr/>
-        </p:nvSpPr>
-        <p:spPr>
-          <a:xfrm>
-            <a:off x="5120640" y="1920240"/>
-            <a:ext cx="2148840" cy="137160"/>
+            <a:off x="2331720" y="3749039"/>
+            <a:ext cx="109728" cy="1737360"/>
           </a:xfrm>
           <a:prstGeom prst="rect">
             <a:avLst/>
@@ -7689,23 +7789,95 @@
       </p:sp>
       <p:sp>
         <p:nvSpPr>
-          <p:cNvPr id="24" name="Oval 23"/>
+          <p:cNvPr id="20" name="TextBox 19"/>
+          <p:cNvSpPr txBox="1"/>
+          <p:nvPr/>
+        </p:nvSpPr>
+        <p:spPr>
+          <a:xfrm>
+            <a:off x="2560320" y="3886199"/>
+            <a:ext cx="3291840" cy="457200"/>
+          </a:xfrm>
+          <a:prstGeom prst="rect">
+            <a:avLst/>
+          </a:prstGeom>
+          <a:noFill/>
+        </p:spPr>
+        <p:txBody>
+          <a:bodyPr wrap="none">
+            <a:spAutoFit/>
+          </a:bodyPr>
+          <a:lstStyle/>
+          <a:p>
+            <a:pPr>
+              <a:defRPr sz="1600" b="1">
+                <a:solidFill>
+                  <a:srgbClr val="558B6E"/>
+                </a:solidFill>
+              </a:defRPr>
+            </a:pPr>
+            <a:r>
+              <a:t>🤝  Cross-Company Collaboration</a:t>
+            </a:r>
+          </a:p>
+        </p:txBody>
+      </p:sp>
+      <p:sp>
+        <p:nvSpPr>
+          <p:cNvPr id="21" name="TextBox 20"/>
+          <p:cNvSpPr txBox="1"/>
+          <p:nvPr/>
+        </p:nvSpPr>
+        <p:spPr>
+          <a:xfrm>
+            <a:off x="2560320" y="4297679"/>
+            <a:ext cx="3291840" cy="1097280"/>
+          </a:xfrm>
+          <a:prstGeom prst="rect">
+            <a:avLst/>
+          </a:prstGeom>
+          <a:noFill/>
+        </p:spPr>
+        <p:txBody>
+          <a:bodyPr wrap="square">
+            <a:spAutoFit/>
+          </a:bodyPr>
+          <a:lstStyle/>
+          <a:p>
+            <a:pPr>
+              <a:defRPr sz="1200">
+                <a:solidFill>
+                  <a:srgbClr val="475569"/>
+                </a:solidFill>
+              </a:defRPr>
+            </a:pPr>
+            <a:r>
+              <a:t>Working alongside data professionals in every department to share best practices and build tools everyone can use</a:t>
+            </a:r>
+          </a:p>
+        </p:txBody>
+      </p:sp>
+      <p:sp>
+        <p:nvSpPr>
+          <p:cNvPr id="22" name="Rounded Rectangle 21"/>
           <p:cNvSpPr/>
           <p:nvPr/>
         </p:nvSpPr>
         <p:spPr>
           <a:xfrm>
-            <a:off x="5829300" y="2240280"/>
-            <a:ext cx="731520" cy="731520"/>
-          </a:xfrm>
-          <a:prstGeom prst="ellipse">
+            <a:off x="6172200" y="3749039"/>
+            <a:ext cx="3657600" cy="1737360"/>
+          </a:xfrm>
+          <a:prstGeom prst="roundRect">
             <a:avLst/>
           </a:prstGeom>
           <a:solidFill>
-            <a:srgbClr val="558B6E"/>
+            <a:srgbClr val="FFFFFF"/>
           </a:solidFill>
-          <a:ln>
-            <a:noFill/>
+          <a:ln w="19050">
+            <a:solidFill>
+              <a:srgbClr val="9370A5"/>
+            </a:solidFill>
           </a:ln>
         </p:spPr>
         <p:style>
@@ -7732,242 +7904,14 @@
       </p:sp>
       <p:sp>
         <p:nvSpPr>
-          <p:cNvPr id="25" name="TextBox 24"/>
-          <p:cNvSpPr txBox="1"/>
-          <p:nvPr/>
-        </p:nvSpPr>
-        <p:spPr>
-          <a:xfrm>
-            <a:off x="5875020" y="2331720"/>
-            <a:ext cx="640080" cy="548640"/>
-          </a:xfrm>
-          <a:prstGeom prst="rect">
-            <a:avLst/>
-          </a:prstGeom>
-          <a:noFill/>
-        </p:spPr>
-        <p:txBody>
-          <a:bodyPr wrap="none">
-            <a:spAutoFit/>
-          </a:bodyPr>
-          <a:lstStyle/>
-          <a:p>
-            <a:pPr algn="ctr">
-              <a:defRPr sz="2800"/>
-            </a:pPr>
-            <a:r>
-              <a:t>📈</a:t>
-            </a:r>
-          </a:p>
-        </p:txBody>
-      </p:sp>
-      <p:sp>
-        <p:nvSpPr>
-          <p:cNvPr id="26" name="TextBox 25"/>
-          <p:cNvSpPr txBox="1"/>
-          <p:nvPr/>
-        </p:nvSpPr>
-        <p:spPr>
-          <a:xfrm>
-            <a:off x="5212080" y="3063240"/>
-            <a:ext cx="1965960" cy="731520"/>
-          </a:xfrm>
-          <a:prstGeom prst="rect">
-            <a:avLst/>
-          </a:prstGeom>
-          <a:noFill/>
-        </p:spPr>
-        <p:txBody>
-          <a:bodyPr wrap="square">
-            <a:spAutoFit/>
-          </a:bodyPr>
-          <a:lstStyle/>
-          <a:p>
-            <a:pPr algn="ctr">
-              <a:defRPr sz="1400" b="1">
-                <a:solidFill>
-                  <a:srgbClr val="558B6E"/>
-                </a:solidFill>
-              </a:defRPr>
-            </a:pPr>
-            <a:r>
-              <a:t>Analysis &amp;</a:t>
-            </a:r>
-            <a:br/>
-            <a:r>
-              <a:t>Insights</a:t>
-            </a:r>
-          </a:p>
-        </p:txBody>
-      </p:sp>
-      <p:sp>
-        <p:nvSpPr>
-          <p:cNvPr id="27" name="TextBox 26"/>
-          <p:cNvSpPr txBox="1"/>
-          <p:nvPr/>
-        </p:nvSpPr>
-        <p:spPr>
-          <a:xfrm>
-            <a:off x="5212080" y="3794759"/>
-            <a:ext cx="1965960" cy="457200"/>
-          </a:xfrm>
-          <a:prstGeom prst="rect">
-            <a:avLst/>
-          </a:prstGeom>
-          <a:noFill/>
-        </p:spPr>
-        <p:txBody>
-          <a:bodyPr wrap="square">
-            <a:spAutoFit/>
-          </a:bodyPr>
-          <a:lstStyle/>
-          <a:p>
-            <a:pPr algn="ctr">
-              <a:defRPr sz="1300" b="1">
-                <a:solidFill>
-                  <a:srgbClr val="475569"/>
-                </a:solidFill>
-              </a:defRPr>
-            </a:pPr>
-            <a:r>
-              <a:t>Find patterns and trends</a:t>
-            </a:r>
-          </a:p>
-        </p:txBody>
-      </p:sp>
-      <p:sp>
-        <p:nvSpPr>
-          <p:cNvPr id="28" name="TextBox 27"/>
-          <p:cNvSpPr txBox="1"/>
-          <p:nvPr/>
-        </p:nvSpPr>
-        <p:spPr>
-          <a:xfrm>
-            <a:off x="5212080" y="4251960"/>
-            <a:ext cx="1965960" cy="1280160"/>
-          </a:xfrm>
-          <a:prstGeom prst="rect">
-            <a:avLst/>
-          </a:prstGeom>
-          <a:noFill/>
-        </p:spPr>
-        <p:txBody>
-          <a:bodyPr wrap="square">
-            <a:spAutoFit/>
-          </a:bodyPr>
-          <a:lstStyle/>
-          <a:p>
-            <a:pPr algn="ctr">
-              <a:defRPr sz="1100">
-                <a:solidFill>
-                  <a:srgbClr val="64748B"/>
-                </a:solidFill>
-              </a:defRPr>
-            </a:pPr>
-            <a:r>
-              <a:t>What's working? What's slowing down? Where to focus?</a:t>
-            </a:r>
-          </a:p>
-        </p:txBody>
-      </p:sp>
-      <p:sp>
-        <p:nvSpPr>
-          <p:cNvPr id="29" name="Right Arrow 28"/>
+          <p:cNvPr id="23" name="Rectangle 22"/>
           <p:cNvSpPr/>
           <p:nvPr/>
         </p:nvSpPr>
         <p:spPr>
           <a:xfrm>
-            <a:off x="7287768" y="2651760"/>
-            <a:ext cx="146304" cy="228600"/>
-          </a:xfrm>
-          <a:prstGeom prst="rightArrow">
-            <a:avLst/>
-          </a:prstGeom>
-          <a:solidFill>
-            <a:srgbClr val="C8D2DC"/>
-          </a:solidFill>
-          <a:ln>
-            <a:noFill/>
-          </a:ln>
-        </p:spPr>
-        <p:style>
-          <a:lnRef idx="1">
-            <a:schemeClr val="accent1"/>
-          </a:lnRef>
-          <a:fillRef idx="3">
-            <a:schemeClr val="accent1"/>
-          </a:fillRef>
-          <a:effectRef idx="2">
-            <a:schemeClr val="accent1"/>
-          </a:effectRef>
-          <a:fontRef idx="minor">
-            <a:schemeClr val="lt1"/>
-          </a:fontRef>
-        </p:style>
-        <p:txBody>
-          <a:bodyPr rtlCol="0" anchor="ctr"/>
-          <a:lstStyle/>
-          <a:p>
-            <a:pPr algn="ctr"/>
-          </a:p>
-        </p:txBody>
-      </p:sp>
-      <p:sp>
-        <p:nvSpPr>
-          <p:cNvPr id="30" name="Rounded Rectangle 29"/>
-          <p:cNvSpPr/>
-          <p:nvPr/>
-        </p:nvSpPr>
-        <p:spPr>
-          <a:xfrm>
-            <a:off x="7452360" y="1920240"/>
-            <a:ext cx="2148840" cy="3840480"/>
-          </a:xfrm>
-          <a:prstGeom prst="roundRect">
-            <a:avLst/>
-          </a:prstGeom>
-          <a:solidFill>
-            <a:srgbClr val="FFFFFF"/>
-          </a:solidFill>
-          <a:ln w="25400">
-            <a:solidFill>
-              <a:srgbClr val="9370A5"/>
-            </a:solidFill>
-          </a:ln>
-        </p:spPr>
-        <p:style>
-          <a:lnRef idx="1">
-            <a:schemeClr val="accent1"/>
-          </a:lnRef>
-          <a:fillRef idx="3">
-            <a:schemeClr val="accent1"/>
-          </a:fillRef>
-          <a:effectRef idx="2">
-            <a:schemeClr val="accent1"/>
-          </a:effectRef>
-          <a:fontRef idx="minor">
-            <a:schemeClr val="lt1"/>
-          </a:fontRef>
-        </p:style>
-        <p:txBody>
-          <a:bodyPr rtlCol="0" anchor="ctr"/>
-          <a:lstStyle/>
-          <a:p>
-            <a:pPr algn="ctr"/>
-          </a:p>
-        </p:txBody>
-      </p:sp>
-      <p:sp>
-        <p:nvSpPr>
-          <p:cNvPr id="31" name="Rectangle 30"/>
-          <p:cNvSpPr/>
-          <p:nvPr/>
-        </p:nvSpPr>
-        <p:spPr>
-          <a:xfrm>
-            <a:off x="7452360" y="1920240"/>
-            <a:ext cx="2148840" cy="137160"/>
+            <a:off x="6172200" y="3749039"/>
+            <a:ext cx="109728" cy="1737360"/>
           </a:xfrm>
           <a:prstGeom prst="rect">
             <a:avLst/>
@@ -8003,57 +7947,14 @@
       </p:sp>
       <p:sp>
         <p:nvSpPr>
-          <p:cNvPr id="32" name="Oval 31"/>
-          <p:cNvSpPr/>
-          <p:nvPr/>
-        </p:nvSpPr>
-        <p:spPr>
-          <a:xfrm>
-            <a:off x="8161020" y="2240280"/>
-            <a:ext cx="731520" cy="731520"/>
-          </a:xfrm>
-          <a:prstGeom prst="ellipse">
-            <a:avLst/>
-          </a:prstGeom>
-          <a:solidFill>
-            <a:srgbClr val="9370A5"/>
-          </a:solidFill>
-          <a:ln>
-            <a:noFill/>
-          </a:ln>
-        </p:spPr>
-        <p:style>
-          <a:lnRef idx="1">
-            <a:schemeClr val="accent1"/>
-          </a:lnRef>
-          <a:fillRef idx="3">
-            <a:schemeClr val="accent1"/>
-          </a:fillRef>
-          <a:effectRef idx="2">
-            <a:schemeClr val="accent1"/>
-          </a:effectRef>
-          <a:fontRef idx="minor">
-            <a:schemeClr val="lt1"/>
-          </a:fontRef>
-        </p:style>
-        <p:txBody>
-          <a:bodyPr rtlCol="0" anchor="ctr"/>
-          <a:lstStyle/>
-          <a:p>
-            <a:pPr algn="ctr"/>
-          </a:p>
-        </p:txBody>
-      </p:sp>
-      <p:sp>
-        <p:nvSpPr>
-          <p:cNvPr id="33" name="TextBox 32"/>
+          <p:cNvPr id="24" name="TextBox 23"/>
           <p:cNvSpPr txBox="1"/>
           <p:nvPr/>
         </p:nvSpPr>
         <p:spPr>
           <a:xfrm>
-            <a:off x="8206740" y="2331720"/>
-            <a:ext cx="640080" cy="548640"/>
+            <a:off x="6400800" y="3886199"/>
+            <a:ext cx="3291840" cy="457200"/>
           </a:xfrm>
           <a:prstGeom prst="rect">
             <a:avLst/>
@@ -8066,25 +7967,29 @@
           </a:bodyPr>
           <a:lstStyle/>
           <a:p>
-            <a:pPr algn="ctr">
-              <a:defRPr sz="2800"/>
+            <a:pPr>
+              <a:defRPr sz="1600" b="1">
+                <a:solidFill>
+                  <a:srgbClr val="9370A5"/>
+                </a:solidFill>
+              </a:defRPr>
             </a:pPr>
             <a:r>
-              <a:t>🔮</a:t>
-            </a:r>
-          </a:p>
-        </p:txBody>
-      </p:sp>
-      <p:sp>
-        <p:nvSpPr>
-          <p:cNvPr id="34" name="TextBox 33"/>
+              <a:t>👥  Communities of Practice</a:t>
+            </a:r>
+          </a:p>
+        </p:txBody>
+      </p:sp>
+      <p:sp>
+        <p:nvSpPr>
+          <p:cNvPr id="25" name="TextBox 24"/>
           <p:cNvSpPr txBox="1"/>
           <p:nvPr/>
         </p:nvSpPr>
         <p:spPr>
           <a:xfrm>
-            <a:off x="7543800" y="3063240"/>
-            <a:ext cx="1965960" cy="731520"/>
+            <a:off x="6400800" y="4297679"/>
+            <a:ext cx="3291840" cy="1097280"/>
           </a:xfrm>
           <a:prstGeom prst="rect">
             <a:avLst/>
@@ -8097,277 +8002,29 @@
           </a:bodyPr>
           <a:lstStyle/>
           <a:p>
-            <a:pPr algn="ctr">
-              <a:defRPr sz="1400" b="1">
-                <a:solidFill>
-                  <a:srgbClr val="9370A5"/>
+            <a:pPr>
+              <a:defRPr sz="1200">
+                <a:solidFill>
+                  <a:srgbClr val="475569"/>
                 </a:solidFill>
               </a:defRPr>
             </a:pPr>
             <a:r>
-              <a:t>Predictions &amp;</a:t>
-            </a:r>
-            <a:br/>
-            <a:r>
-              <a:t>Forecasts</a:t>
-            </a:r>
-          </a:p>
-        </p:txBody>
-      </p:sp>
-      <p:sp>
-        <p:nvSpPr>
-          <p:cNvPr id="35" name="TextBox 34"/>
+              <a:t>User groups and working sessions where people across the company can learn from each other and solve common challenges</a:t>
+            </a:r>
+          </a:p>
+        </p:txBody>
+      </p:sp>
+      <p:sp>
+        <p:nvSpPr>
+          <p:cNvPr id="26" name="TextBox 25"/>
           <p:cNvSpPr txBox="1"/>
           <p:nvPr/>
         </p:nvSpPr>
         <p:spPr>
           <a:xfrm>
-            <a:off x="7543800" y="3794759"/>
-            <a:ext cx="1965960" cy="457200"/>
-          </a:xfrm>
-          <a:prstGeom prst="rect">
-            <a:avLst/>
-          </a:prstGeom>
-          <a:noFill/>
-        </p:spPr>
-        <p:txBody>
-          <a:bodyPr wrap="square">
-            <a:spAutoFit/>
-          </a:bodyPr>
-          <a:lstStyle/>
-          <a:p>
-            <a:pPr algn="ctr">
-              <a:defRPr sz="1300" b="1">
-                <a:solidFill>
-                  <a:srgbClr val="475569"/>
-                </a:solidFill>
-              </a:defRPr>
-            </a:pPr>
-            <a:r>
-              <a:t>See what's likely coming</a:t>
-            </a:r>
-          </a:p>
-        </p:txBody>
-      </p:sp>
-      <p:sp>
-        <p:nvSpPr>
-          <p:cNvPr id="36" name="TextBox 35"/>
-          <p:cNvSpPr txBox="1"/>
-          <p:nvPr/>
-        </p:nvSpPr>
-        <p:spPr>
-          <a:xfrm>
-            <a:off x="7543800" y="4251960"/>
-            <a:ext cx="1965960" cy="1280160"/>
-          </a:xfrm>
-          <a:prstGeom prst="rect">
-            <a:avLst/>
-          </a:prstGeom>
-          <a:noFill/>
-        </p:spPr>
-        <p:txBody>
-          <a:bodyPr wrap="square">
-            <a:spAutoFit/>
-          </a:bodyPr>
-          <a:lstStyle/>
-          <a:p>
-            <a:pPr algn="ctr">
-              <a:defRPr sz="1100">
-                <a:solidFill>
-                  <a:srgbClr val="64748B"/>
-                </a:solidFill>
-              </a:defRPr>
-            </a:pPr>
-            <a:r>
-              <a:t>Timeline estimates, risk flags, outcome probabilities</a:t>
-            </a:r>
-          </a:p>
-        </p:txBody>
-      </p:sp>
-      <p:sp>
-        <p:nvSpPr>
-          <p:cNvPr id="37" name="Right Arrow 36"/>
-          <p:cNvSpPr/>
-          <p:nvPr/>
-        </p:nvSpPr>
-        <p:spPr>
-          <a:xfrm>
-            <a:off x="9619488" y="2651760"/>
-            <a:ext cx="146304" cy="228600"/>
-          </a:xfrm>
-          <a:prstGeom prst="rightArrow">
-            <a:avLst/>
-          </a:prstGeom>
-          <a:solidFill>
-            <a:srgbClr val="C8D2DC"/>
-          </a:solidFill>
-          <a:ln>
-            <a:noFill/>
-          </a:ln>
-        </p:spPr>
-        <p:style>
-          <a:lnRef idx="1">
-            <a:schemeClr val="accent1"/>
-          </a:lnRef>
-          <a:fillRef idx="3">
-            <a:schemeClr val="accent1"/>
-          </a:fillRef>
-          <a:effectRef idx="2">
-            <a:schemeClr val="accent1"/>
-          </a:effectRef>
-          <a:fontRef idx="minor">
-            <a:schemeClr val="lt1"/>
-          </a:fontRef>
-        </p:style>
-        <p:txBody>
-          <a:bodyPr rtlCol="0" anchor="ctr"/>
-          <a:lstStyle/>
-          <a:p>
-            <a:pPr algn="ctr"/>
-          </a:p>
-        </p:txBody>
-      </p:sp>
-      <p:sp>
-        <p:nvSpPr>
-          <p:cNvPr id="38" name="Rounded Rectangle 37"/>
-          <p:cNvSpPr/>
-          <p:nvPr/>
-        </p:nvSpPr>
-        <p:spPr>
-          <a:xfrm>
-            <a:off x="9784080" y="1920240"/>
-            <a:ext cx="2148840" cy="3840480"/>
-          </a:xfrm>
-          <a:prstGeom prst="roundRect">
-            <a:avLst/>
-          </a:prstGeom>
-          <a:solidFill>
-            <a:srgbClr val="FFFFFF"/>
-          </a:solidFill>
-          <a:ln w="25400">
-            <a:solidFill>
-              <a:srgbClr val="CD853F"/>
-            </a:solidFill>
-          </a:ln>
-        </p:spPr>
-        <p:style>
-          <a:lnRef idx="1">
-            <a:schemeClr val="accent1"/>
-          </a:lnRef>
-          <a:fillRef idx="3">
-            <a:schemeClr val="accent1"/>
-          </a:fillRef>
-          <a:effectRef idx="2">
-            <a:schemeClr val="accent1"/>
-          </a:effectRef>
-          <a:fontRef idx="minor">
-            <a:schemeClr val="lt1"/>
-          </a:fontRef>
-        </p:style>
-        <p:txBody>
-          <a:bodyPr rtlCol="0" anchor="ctr"/>
-          <a:lstStyle/>
-          <a:p>
-            <a:pPr algn="ctr"/>
-          </a:p>
-        </p:txBody>
-      </p:sp>
-      <p:sp>
-        <p:nvSpPr>
-          <p:cNvPr id="39" name="Rectangle 38"/>
-          <p:cNvSpPr/>
-          <p:nvPr/>
-        </p:nvSpPr>
-        <p:spPr>
-          <a:xfrm>
-            <a:off x="9784080" y="1920240"/>
-            <a:ext cx="2148840" cy="137160"/>
-          </a:xfrm>
-          <a:prstGeom prst="rect">
-            <a:avLst/>
-          </a:prstGeom>
-          <a:solidFill>
-            <a:srgbClr val="CD853F"/>
-          </a:solidFill>
-          <a:ln>
-            <a:noFill/>
-          </a:ln>
-        </p:spPr>
-        <p:style>
-          <a:lnRef idx="1">
-            <a:schemeClr val="accent1"/>
-          </a:lnRef>
-          <a:fillRef idx="3">
-            <a:schemeClr val="accent1"/>
-          </a:fillRef>
-          <a:effectRef idx="2">
-            <a:schemeClr val="accent1"/>
-          </a:effectRef>
-          <a:fontRef idx="minor">
-            <a:schemeClr val="lt1"/>
-          </a:fontRef>
-        </p:style>
-        <p:txBody>
-          <a:bodyPr rtlCol="0" anchor="ctr"/>
-          <a:lstStyle/>
-          <a:p>
-            <a:pPr algn="ctr"/>
-          </a:p>
-        </p:txBody>
-      </p:sp>
-      <p:sp>
-        <p:nvSpPr>
-          <p:cNvPr id="40" name="Oval 39"/>
-          <p:cNvSpPr/>
-          <p:nvPr/>
-        </p:nvSpPr>
-        <p:spPr>
-          <a:xfrm>
-            <a:off x="10492740" y="2240280"/>
-            <a:ext cx="731520" cy="731520"/>
-          </a:xfrm>
-          <a:prstGeom prst="ellipse">
-            <a:avLst/>
-          </a:prstGeom>
-          <a:solidFill>
-            <a:srgbClr val="CD853F"/>
-          </a:solidFill>
-          <a:ln>
-            <a:noFill/>
-          </a:ln>
-        </p:spPr>
-        <p:style>
-          <a:lnRef idx="1">
-            <a:schemeClr val="accent1"/>
-          </a:lnRef>
-          <a:fillRef idx="3">
-            <a:schemeClr val="accent1"/>
-          </a:fillRef>
-          <a:effectRef idx="2">
-            <a:schemeClr val="accent1"/>
-          </a:effectRef>
-          <a:fontRef idx="minor">
-            <a:schemeClr val="lt1"/>
-          </a:fontRef>
-        </p:style>
-        <p:txBody>
-          <a:bodyPr rtlCol="0" anchor="ctr"/>
-          <a:lstStyle/>
-          <a:p>
-            <a:pPr algn="ctr"/>
-          </a:p>
-        </p:txBody>
-      </p:sp>
-      <p:sp>
-        <p:nvSpPr>
-          <p:cNvPr id="41" name="TextBox 40"/>
-          <p:cNvSpPr txBox="1"/>
-          <p:nvPr/>
-        </p:nvSpPr>
-        <p:spPr>
-          <a:xfrm>
-            <a:off x="10538460" y="2331720"/>
-            <a:ext cx="640080" cy="548640"/>
+            <a:off x="457200" y="5669280"/>
+            <a:ext cx="11247120" cy="457200"/>
           </a:xfrm>
           <a:prstGeom prst="rect">
             <a:avLst/>
@@ -8381,161 +8038,21 @@
           <a:lstStyle/>
           <a:p>
             <a:pPr algn="ctr">
-              <a:defRPr sz="2800"/>
+              <a:defRPr sz="1400" i="1">
+                <a:solidFill>
+                  <a:srgbClr val="64748B"/>
+                </a:solidFill>
+              </a:defRPr>
             </a:pPr>
             <a:r>
-              <a:t>🤖</a:t>
-            </a:r>
-          </a:p>
-        </p:txBody>
-      </p:sp>
-      <p:sp>
-        <p:nvSpPr>
-          <p:cNvPr id="42" name="TextBox 41"/>
-          <p:cNvSpPr txBox="1"/>
-          <p:nvPr/>
-        </p:nvSpPr>
-        <p:spPr>
-          <a:xfrm>
-            <a:off x="9875520" y="3063240"/>
-            <a:ext cx="1965960" cy="731520"/>
-          </a:xfrm>
-          <a:prstGeom prst="rect">
-            <a:avLst/>
-          </a:prstGeom>
-          <a:noFill/>
-        </p:spPr>
-        <p:txBody>
-          <a:bodyPr wrap="square">
-            <a:spAutoFit/>
-          </a:bodyPr>
-          <a:lstStyle/>
-          <a:p>
-            <a:pPr algn="ctr">
-              <a:defRPr sz="1400" b="1">
-                <a:solidFill>
-                  <a:srgbClr val="CD853F"/>
-                </a:solidFill>
-              </a:defRPr>
-            </a:pPr>
-            <a:r>
-              <a:t>AI-Powered</a:t>
-            </a:r>
-            <a:br/>
-            <a:r>
-              <a:t>Tools</a:t>
-            </a:r>
-          </a:p>
-        </p:txBody>
-      </p:sp>
-      <p:sp>
-        <p:nvSpPr>
-          <p:cNvPr id="43" name="TextBox 42"/>
-          <p:cNvSpPr txBox="1"/>
-          <p:nvPr/>
-        </p:nvSpPr>
-        <p:spPr>
-          <a:xfrm>
-            <a:off x="9875520" y="3794759"/>
-            <a:ext cx="1965960" cy="457200"/>
-          </a:xfrm>
-          <a:prstGeom prst="rect">
-            <a:avLst/>
-          </a:prstGeom>
-          <a:noFill/>
-        </p:spPr>
-        <p:txBody>
-          <a:bodyPr wrap="square">
-            <a:spAutoFit/>
-          </a:bodyPr>
-          <a:lstStyle/>
-          <a:p>
-            <a:pPr algn="ctr">
-              <a:defRPr sz="1300" b="1">
-                <a:solidFill>
-                  <a:srgbClr val="475569"/>
-                </a:solidFill>
-              </a:defRPr>
-            </a:pPr>
-            <a:r>
-              <a:t>Smart automation</a:t>
-            </a:r>
-          </a:p>
-        </p:txBody>
-      </p:sp>
-      <p:sp>
-        <p:nvSpPr>
-          <p:cNvPr id="44" name="TextBox 43"/>
-          <p:cNvSpPr txBox="1"/>
-          <p:nvPr/>
-        </p:nvSpPr>
-        <p:spPr>
-          <a:xfrm>
-            <a:off x="9875520" y="4251960"/>
-            <a:ext cx="1965960" cy="1280160"/>
-          </a:xfrm>
-          <a:prstGeom prst="rect">
-            <a:avLst/>
-          </a:prstGeom>
-          <a:noFill/>
-        </p:spPr>
-        <p:txBody>
-          <a:bodyPr wrap="square">
-            <a:spAutoFit/>
-          </a:bodyPr>
-          <a:lstStyle/>
-          <a:p>
-            <a:pPr algn="ctr">
-              <a:defRPr sz="1100">
-                <a:solidFill>
-                  <a:srgbClr val="64748B"/>
-                </a:solidFill>
-              </a:defRPr>
-            </a:pPr>
-            <a:r>
-              <a:t>Document generation, Q&amp;A assistants, intelligent workflows</a:t>
-            </a:r>
-          </a:p>
-        </p:txBody>
-      </p:sp>
-      <p:sp>
-        <p:nvSpPr>
-          <p:cNvPr id="45" name="TextBox 44"/>
-          <p:cNvSpPr txBox="1"/>
-          <p:nvPr/>
-        </p:nvSpPr>
-        <p:spPr>
-          <a:xfrm>
-            <a:off x="457200" y="5943600"/>
-            <a:ext cx="11247120" cy="457200"/>
-          </a:xfrm>
-          <a:prstGeom prst="rect">
-            <a:avLst/>
-          </a:prstGeom>
-          <a:noFill/>
-        </p:spPr>
-        <p:txBody>
-          <a:bodyPr wrap="none">
-            <a:spAutoFit/>
-          </a:bodyPr>
-          <a:lstStyle/>
-          <a:p>
-            <a:pPr algn="ctr">
-              <a:defRPr sz="1600" b="1">
-                <a:solidFill>
-                  <a:srgbClr val="008080"/>
-                </a:solidFill>
-              </a:defRPr>
-            </a:pPr>
-            <a:r>
-              <a:t>Let's look at some real examples →</a:t>
-            </a:r>
-          </a:p>
-        </p:txBody>
-      </p:sp>
-      <p:sp>
-        <p:nvSpPr>
-          <p:cNvPr id="46" name="TextBox 45"/>
+              <a:t>These services are available to everyone — no project required</a:t>
+            </a:r>
+          </a:p>
+        </p:txBody>
+      </p:sp>
+      <p:sp>
+        <p:nvSpPr>
+          <p:cNvPr id="27" name="TextBox 26"/>
           <p:cNvSpPr txBox="1"/>
           <p:nvPr/>
         </p:nvSpPr>

</xml_diff>